<commit_message>
Fix slide 9 chart to use the real stepped weekly data
The nurse-response trend chart on slide 9 had been built from a hand-
smoothed ramp between two observed endpoints instead of the actual
per-week values in northline/sim/out/weekly.json (which step at each
quarterly update: 18.1 -> 22.5 -> 28.3 -> 36.4h before triage deploys,
then flat at 4.0h after). Corrected the chart data to match the file.

Co-Authored-By: Claude Fable 5.1 <noreply@anthropic.com>
</commit_message>
<xml_diff>
--- a/slides/deck.pptx
+++ b/slides/deck.pptx
@@ -404,115 +404,115 @@
                   <c:v>18.1</c:v>
                 </c:pt>
                 <c:pt idx="1">
-                  <c:v>18.6</c:v>
+                  <c:v>18.1</c:v>
                 </c:pt>
                 <c:pt idx="2">
-                  <c:v>19.2</c:v>
+                  <c:v>18.1</c:v>
                 </c:pt>
                 <c:pt idx="3">
-                  <c:v>19.7</c:v>
+                  <c:v>18.1</c:v>
                 </c:pt>
                 <c:pt idx="4">
-                  <c:v>20.3</c:v>
+                  <c:v>18.1</c:v>
                 </c:pt>
                 <c:pt idx="5">
-                  <c:v>20.8</c:v>
+                  <c:v>18.1</c:v>
                 </c:pt>
                 <c:pt idx="6">
-                  <c:v>21.4</c:v>
+                  <c:v>18.1</c:v>
                 </c:pt>
                 <c:pt idx="7">
-                  <c:v>21.9</c:v>
+                  <c:v>18.1</c:v>
                 </c:pt>
                 <c:pt idx="8">
+                  <c:v>18.1</c:v>
+                </c:pt>
+                <c:pt idx="9">
+                  <c:v>18.1</c:v>
+                </c:pt>
+                <c:pt idx="10">
+                  <c:v>18.1</c:v>
+                </c:pt>
+                <c:pt idx="11">
+                  <c:v>18.1</c:v>
+                </c:pt>
+                <c:pt idx="12">
+                  <c:v>18.1</c:v>
+                </c:pt>
+                <c:pt idx="13">
+                  <c:v>18.1</c:v>
+                </c:pt>
+                <c:pt idx="14">
+                  <c:v>18.1</c:v>
+                </c:pt>
+                <c:pt idx="15">
                   <c:v>22.5</c:v>
                 </c:pt>
-                <c:pt idx="9">
-                  <c:v>23</c:v>
-                </c:pt>
-                <c:pt idx="10">
-                  <c:v>23.6</c:v>
-                </c:pt>
-                <c:pt idx="11">
-                  <c:v>24.1</c:v>
-                </c:pt>
-                <c:pt idx="12">
-                  <c:v>24.7</c:v>
-                </c:pt>
-                <c:pt idx="13">
-                  <c:v>25.2</c:v>
-                </c:pt>
-                <c:pt idx="14">
-                  <c:v>25.8</c:v>
-                </c:pt>
-                <c:pt idx="15">
-                  <c:v>26.3</c:v>
-                </c:pt>
                 <c:pt idx="16">
-                  <c:v>26.9</c:v>
+                  <c:v>22.5</c:v>
                 </c:pt>
                 <c:pt idx="17">
-                  <c:v>27.4</c:v>
+                  <c:v>22.5</c:v>
                 </c:pt>
                 <c:pt idx="18">
-                  <c:v>28</c:v>
+                  <c:v>22.5</c:v>
                 </c:pt>
                 <c:pt idx="19">
-                  <c:v>28.5</c:v>
+                  <c:v>22.5</c:v>
                 </c:pt>
                 <c:pt idx="20">
-                  <c:v>29.1</c:v>
+                  <c:v>22.5</c:v>
                 </c:pt>
                 <c:pt idx="21">
-                  <c:v>29.6</c:v>
+                  <c:v>22.5</c:v>
                 </c:pt>
                 <c:pt idx="22">
-                  <c:v>26.5</c:v>
+                  <c:v>22.5</c:v>
                 </c:pt>
                 <c:pt idx="23">
-                  <c:v>27</c:v>
+                  <c:v>22.5</c:v>
                 </c:pt>
                 <c:pt idx="24">
-                  <c:v>27.5</c:v>
+                  <c:v>22.5</c:v>
                 </c:pt>
                 <c:pt idx="25">
-                  <c:v>28</c:v>
+                  <c:v>22.5</c:v>
                 </c:pt>
                 <c:pt idx="26">
-                  <c:v>28.5</c:v>
+                  <c:v>22.5</c:v>
                 </c:pt>
                 <c:pt idx="27">
-                  <c:v>29</c:v>
+                  <c:v>28.3</c:v>
                 </c:pt>
                 <c:pt idx="28">
-                  <c:v>29.5</c:v>
+                  <c:v>28.3</c:v>
                 </c:pt>
                 <c:pt idx="29">
-                  <c:v>30</c:v>
+                  <c:v>28.3</c:v>
                 </c:pt>
                 <c:pt idx="30">
-                  <c:v>30.5</c:v>
+                  <c:v>28.3</c:v>
                 </c:pt>
                 <c:pt idx="31">
-                  <c:v>31</c:v>
+                  <c:v>28.3</c:v>
                 </c:pt>
                 <c:pt idx="32">
-                  <c:v>31.5</c:v>
+                  <c:v>28.3</c:v>
                 </c:pt>
                 <c:pt idx="33">
-                  <c:v>32</c:v>
+                  <c:v>28.3</c:v>
                 </c:pt>
                 <c:pt idx="34">
-                  <c:v>32.5</c:v>
+                  <c:v>28.3</c:v>
                 </c:pt>
                 <c:pt idx="35">
-                  <c:v>33.5</c:v>
+                  <c:v>28.3</c:v>
                 </c:pt>
                 <c:pt idx="36">
-                  <c:v>34.5</c:v>
+                  <c:v>36.4</c:v>
                 </c:pt>
                 <c:pt idx="37">
-                  <c:v>35.5</c:v>
+                  <c:v>36.4</c:v>
                 </c:pt>
                 <c:pt idx="38">
                   <c:v>36.4</c:v>

</xml_diff>

<commit_message>
Apply review fixes: laptop-numbers caveat, slide 13 to white, slide 6 note
Review findings, controller-ruled:
1. Slides 9 and 11 show company numbers from a triage deployment made
   locally with the 190/115 decisions, which is intentionally not
   committed. Added a one-line caption under each chart and the same
   sentence to the speaker notes and outline.md, telling presenters to
   show the live dashboard instead since their room's numbers will
   differ. Chart data unchanged.
2. Slide 13 was the only content slide using the dark background;
   fixed it to a white content slide (kicker + title bar, like every
   other content slide) with dark-on-white text colours, matching the
   "only slide 1 is dark" constraint.
3. Slide 6 keeps its static list; added "Read them one at a time; do
   not show all five at once." to its speaker note and outline.md.

Co-Authored-By: Claude Fable 5.1 <noreply@anthropic.com>
</commit_message>
<xml_diff>
--- a/slides/deck.pptx
+++ b/slides/deck.pptx
@@ -1872,7 +1872,7 @@
           <a:p>
             <a:r>
               <a:rPr lang="en-US" dirty="0"/>
-              <a:t>same contract, same 100,000 patients, two very different lines — and the only thing that moved between them is a prompt four people voted on this afternoon.</a:t>
+              <a:t>same contract, same 100,000 patients, two very different lines — and the only thing that moved between them is a prompt four people voted on this afternoon. Numbers from a triage deployment made with the 190/115 decisions on this laptop; your room's numbers will differ. Show the live dashboard.</a:t>
             </a:r>
             <a:endParaRPr lang="en-US" dirty="0"/>
           </a:p>
@@ -2576,7 +2576,7 @@
           <a:p>
             <a:r>
               <a:rPr lang="en-US" dirty="0"/>
-              <a:t>one per click, during the board meeting. Toggle “Sign Prairie” on the presenting team's own numbers while they answer.</a:t>
+              <a:t>one per click, during the board meeting. Toggle “Sign Prairie” on the presenting team's own numbers while they answer. Read them one at a time; do not show all five at once.</a:t>
             </a:r>
             <a:endParaRPr lang="en-US" dirty="0"/>
           </a:p>
@@ -2840,7 +2840,7 @@
           <a:p>
             <a:r>
               <a:rPr lang="en-US" dirty="0"/>
-              <a:t>every queue number gets better in a day. Read the last row before anyone celebrates the rest of the table.</a:t>
+              <a:t>every queue number gets better in a day. Read the last row before anyone celebrates the rest of the table. Numbers from a triage deployment made with the 190/115 decisions on this laptop; your room's numbers will differ. Show the live dashboard.</a:t>
             </a:r>
             <a:endParaRPr lang="en-US" dirty="0"/>
           </a:p>
@@ -4972,8 +4972,8 @@
           <p:nvPr/>
         </p:nvGraphicFramePr>
         <p:xfrm>
-          <a:off x="548640" y="1554480"/>
-          <a:ext cx="11094415" cy="4206240"/>
+          <a:off x="548640" y="1463040"/>
+          <a:ext cx="11094415" cy="3931920"/>
         </p:xfrm>
         <a:graphic xmlns:a="http://schemas.openxmlformats.org/drawingml/2006/main">
           <a:graphicData uri="http://schemas.openxmlformats.org/drawingml/2006/chart">
@@ -4989,8 +4989,8 @@
         </p:nvSpPr>
         <p:spPr>
           <a:xfrm>
-            <a:off x="548640" y="5897880"/>
-            <a:ext cx="11094415" cy="365760"/>
+            <a:off x="548640" y="5532120"/>
+            <a:ext cx="11094415" cy="292608"/>
           </a:xfrm>
           <a:prstGeom prst="rect">
             <a:avLst/>
@@ -5006,7 +5006,7 @@
               <a:buNone/>
             </a:pPr>
             <a:r>
-              <a:rPr lang="en-US" sz="1300" i="1" dirty="0">
+              <a:rPr lang="en-US" sz="1250" i="1" dirty="0">
                 <a:solidFill>
                   <a:srgbClr val="5B6472"/>
                 </a:solidFill>
@@ -5016,13 +5016,52 @@
               </a:rPr>
               <a:t>Same 100,000 patients, same contract — 336h capped without the deployment, ~24–31h with it.</a:t>
             </a:r>
-            <a:endParaRPr lang="en-US" sz="1300" dirty="0"/>
+            <a:endParaRPr lang="en-US" sz="1250" dirty="0"/>
           </a:p>
         </p:txBody>
       </p:sp>
       <p:sp>
         <p:nvSpPr>
           <p:cNvPr id="6" name="Text 3"/>
+          <p:cNvSpPr txBox="1"/>
+          <p:nvPr/>
+        </p:nvSpPr>
+        <p:spPr>
+          <a:xfrm>
+            <a:off x="548640" y="5852160"/>
+            <a:ext cx="11094415" cy="292608"/>
+          </a:xfrm>
+          <a:prstGeom prst="rect">
+            <a:avLst/>
+          </a:prstGeom>
+          <a:noFill/>
+          <a:ln/>
+        </p:spPr>
+        <p:txBody>
+          <a:bodyPr wrap="square" lIns="0" tIns="0" rIns="0" bIns="0" rtlCol="0" anchor="ctr"/>
+          <a:lstStyle/>
+          <a:p>
+            <a:pPr indent="0" marL="0">
+              <a:buNone/>
+            </a:pPr>
+            <a:r>
+              <a:rPr lang="en-US" sz="1200" i="1" dirty="0">
+                <a:solidFill>
+                  <a:srgbClr val="1C7293"/>
+                </a:solidFill>
+                <a:latin typeface="Calibri" pitchFamily="34" charset="0"/>
+                <a:ea typeface="Calibri" pitchFamily="34" charset="-122"/>
+                <a:cs typeface="Calibri" pitchFamily="34" charset="-120"/>
+              </a:rPr>
+              <a:t>Numbers from a triage deployment made with the 190/115 decisions on this laptop; your room's numbers will differ. Show the live dashboard.</a:t>
+            </a:r>
+            <a:endParaRPr lang="en-US" sz="1200" dirty="0"/>
+          </a:p>
+        </p:txBody>
+      </p:sp>
+      <p:sp>
+        <p:nvSpPr>
+          <p:cNvPr id="7" name="Text 4"/>
           <p:cNvSpPr txBox="1"/>
           <p:nvPr/>
         </p:nvSpPr>
@@ -7313,7 +7352,7 @@
     <p:bg>
       <p:bgPr>
         <a:solidFill>
-          <a:srgbClr val="21295C"/>
+          <a:srgbClr val="FFFFFF"/>
         </a:solidFill>
       </p:bgPr>
     </p:bg>
@@ -7333,19 +7372,95 @@
       </p:grpSpPr>
       <p:sp>
         <p:nvSpPr>
-          <p:cNvPr id="2" name="Shape 0"/>
+          <p:cNvPr id="2" name="Text 0"/>
+          <p:cNvSpPr txBox="1"/>
+          <p:nvPr/>
+        </p:nvSpPr>
+        <p:spPr>
+          <a:xfrm>
+            <a:off x="548640" y="164592"/>
+            <a:ext cx="11094415" cy="274320"/>
+          </a:xfrm>
+          <a:prstGeom prst="rect">
+            <a:avLst/>
+          </a:prstGeom>
+          <a:noFill/>
+          <a:ln/>
+        </p:spPr>
+        <p:txBody>
+          <a:bodyPr wrap="square" lIns="0" tIns="0" rIns="0" bIns="0" rtlCol="0" anchor="ctr"/>
+          <a:lstStyle/>
+          <a:p>
+            <a:pPr algn="l" indent="0" marL="0">
+              <a:buNone/>
+            </a:pPr>
+            <a:r>
+              <a:rPr lang="en-US" sz="1200" b="1" spc="200" kern="0" dirty="0">
+                <a:solidFill>
+                  <a:srgbClr val="1C7293"/>
+                </a:solidFill>
+                <a:latin typeface="Calibri" pitchFamily="34" charset="0"/>
+                <a:ea typeface="Calibri" pitchFamily="34" charset="-122"/>
+                <a:cs typeface="Calibri" pitchFamily="34" charset="-120"/>
+              </a:rPr>
+              <a:t>CASE ONE IN ONE SLIDE</a:t>
+            </a:r>
+            <a:endParaRPr lang="en-US" sz="1200" dirty="0"/>
+          </a:p>
+        </p:txBody>
+      </p:sp>
+      <p:sp>
+        <p:nvSpPr>
+          <p:cNvPr id="3" name="Text 1"/>
+          <p:cNvSpPr txBox="1"/>
+          <p:nvPr/>
+        </p:nvSpPr>
+        <p:spPr>
+          <a:xfrm>
+            <a:off x="548640" y="411480"/>
+            <a:ext cx="11094415" cy="822960"/>
+          </a:xfrm>
+          <a:prstGeom prst="rect">
+            <a:avLst/>
+          </a:prstGeom>
+          <a:noFill/>
+          <a:ln/>
+        </p:spPr>
+        <p:txBody>
+          <a:bodyPr wrap="square" lIns="0" tIns="0" rIns="0" bIns="0" rtlCol="0" anchor="ctr"/>
+          <a:lstStyle/>
+          <a:p>
+            <a:pPr algn="l" indent="0" marL="0">
+              <a:buNone/>
+            </a:pPr>
+            <a:r>
+              <a:rPr lang="en-US" sz="3200" b="1" dirty="0">
+                <a:solidFill>
+                  <a:srgbClr val="1B1F27"/>
+                </a:solidFill>
+                <a:latin typeface="Cambria" pitchFamily="34" charset="0"/>
+                <a:ea typeface="Cambria" pitchFamily="34" charset="-122"/>
+                <a:cs typeface="Cambria" pitchFamily="34" charset="-120"/>
+              </a:rPr>
+              <a:t>Build-versus-buy is a go-to-market question.</a:t>
+            </a:r>
+            <a:endParaRPr lang="en-US" sz="3200" dirty="0"/>
+          </a:p>
+        </p:txBody>
+      </p:sp>
+      <p:sp>
+        <p:nvSpPr>
+          <p:cNvPr id="4" name="Shape 2"/>
           <p:cNvSpPr/>
           <p:nvPr/>
         </p:nvSpPr>
         <p:spPr>
           <a:xfrm>
-            <a:off x="822960" y="822960"/>
-            <a:ext cx="822960" cy="822960"/>
+            <a:off x="548640" y="1874520"/>
+            <a:ext cx="640080" cy="640080"/>
           </a:xfrm>
-          <a:prstGeom prst="roundRect">
-            <a:avLst>
-              <a:gd name="adj" fmla="val 50000"/>
-            </a:avLst>
+          <a:prstGeom prst="ellipse">
+            <a:avLst/>
           </a:prstGeom>
           <a:solidFill>
             <a:srgbClr val="1C7293"/>
@@ -7355,14 +7470,14 @@
       </p:sp>
       <p:sp>
         <p:nvSpPr>
-          <p:cNvPr id="3" name="Text 1"/>
+          <p:cNvPr id="5" name="Text 3"/>
           <p:cNvSpPr txBox="1"/>
           <p:nvPr/>
         </p:nvSpPr>
         <p:spPr>
           <a:xfrm>
-            <a:off x="822960" y="658368"/>
-            <a:ext cx="822960" cy="822960"/>
+            <a:off x="548640" y="1737360"/>
+            <a:ext cx="640080" cy="640080"/>
           </a:xfrm>
           <a:prstGeom prst="rect">
             <a:avLst/>
@@ -7378,7 +7493,7 @@
               <a:buNone/>
             </a:pPr>
             <a:r>
-              <a:rPr lang="en-US" sz="4600" b="1" dirty="0">
+              <a:rPr lang="en-US" sz="3400" b="1" dirty="0">
                 <a:solidFill>
                   <a:srgbClr val="FFFFFF"/>
                 </a:solidFill>
@@ -7388,84 +7503,6 @@
               </a:rPr>
               <a:t>“</a:t>
             </a:r>
-            <a:endParaRPr lang="en-US" sz="4600" dirty="0"/>
-          </a:p>
-        </p:txBody>
-      </p:sp>
-      <p:sp>
-        <p:nvSpPr>
-          <p:cNvPr id="4" name="Text 2"/>
-          <p:cNvSpPr txBox="1"/>
-          <p:nvPr/>
-        </p:nvSpPr>
-        <p:spPr>
-          <a:xfrm>
-            <a:off x="548640" y="1828800"/>
-            <a:ext cx="11094415" cy="457200"/>
-          </a:xfrm>
-          <a:prstGeom prst="rect">
-            <a:avLst/>
-          </a:prstGeom>
-          <a:noFill/>
-          <a:ln/>
-        </p:spPr>
-        <p:txBody>
-          <a:bodyPr wrap="square" lIns="0" tIns="0" rIns="0" bIns="0" rtlCol="0" anchor="ctr"/>
-          <a:lstStyle/>
-          <a:p>
-            <a:pPr indent="0" marL="0">
-              <a:buNone/>
-            </a:pPr>
-            <a:r>
-              <a:rPr lang="en-US" sz="1400" b="1" spc="200" kern="0" dirty="0">
-                <a:solidFill>
-                  <a:srgbClr val="CADCFC"/>
-                </a:solidFill>
-                <a:latin typeface="Calibri" pitchFamily="34" charset="0"/>
-                <a:ea typeface="Calibri" pitchFamily="34" charset="-122"/>
-                <a:cs typeface="Calibri" pitchFamily="34" charset="-120"/>
-              </a:rPr>
-              <a:t>Case one in one slide</a:t>
-            </a:r>
-            <a:endParaRPr lang="en-US" sz="1400" dirty="0"/>
-          </a:p>
-        </p:txBody>
-      </p:sp>
-      <p:sp>
-        <p:nvSpPr>
-          <p:cNvPr id="5" name="Text 3"/>
-          <p:cNvSpPr txBox="1"/>
-          <p:nvPr/>
-        </p:nvSpPr>
-        <p:spPr>
-          <a:xfrm>
-            <a:off x="548640" y="2331720"/>
-            <a:ext cx="11094415" cy="914400"/>
-          </a:xfrm>
-          <a:prstGeom prst="rect">
-            <a:avLst/>
-          </a:prstGeom>
-          <a:noFill/>
-          <a:ln/>
-        </p:spPr>
-        <p:txBody>
-          <a:bodyPr wrap="square" lIns="0" tIns="0" rIns="0" bIns="0" rtlCol="0" anchor="ctr"/>
-          <a:lstStyle/>
-          <a:p>
-            <a:pPr indent="0" marL="0">
-              <a:buNone/>
-            </a:pPr>
-            <a:r>
-              <a:rPr lang="en-US" sz="3400" b="1" dirty="0">
-                <a:solidFill>
-                  <a:srgbClr val="FFFFFF"/>
-                </a:solidFill>
-                <a:latin typeface="Cambria" pitchFamily="34" charset="0"/>
-                <a:ea typeface="Cambria" pitchFamily="34" charset="-122"/>
-                <a:cs typeface="Cambria" pitchFamily="34" charset="-120"/>
-              </a:rPr>
-              <a:t>Build-versus-buy is a go-to-market question.</a:t>
-            </a:r>
             <a:endParaRPr lang="en-US" sz="3400" dirty="0"/>
           </a:p>
         </p:txBody>
@@ -7478,8 +7515,8 @@
         </p:nvSpPr>
         <p:spPr>
           <a:xfrm>
-            <a:off x="548640" y="3337560"/>
-            <a:ext cx="10180015" cy="1463040"/>
+            <a:off x="1463040" y="1783080"/>
+            <a:ext cx="10180015" cy="1828800"/>
           </a:xfrm>
           <a:prstGeom prst="rect">
             <a:avLst/>
@@ -7500,7 +7537,7 @@
             <a:r>
               <a:rPr lang="en-US" sz="2200" i="1" dirty="0">
                 <a:solidFill>
-                  <a:srgbClr val="CADCFC"/>
+                  <a:srgbClr val="1B1F27"/>
                 </a:solidFill>
                 <a:latin typeface="Times New Roman" pitchFamily="34" charset="0"/>
                 <a:ea typeface="Times New Roman" pitchFamily="34" charset="-122"/>
@@ -7539,7 +7576,7 @@
             <a:r>
               <a:rPr lang="en-US" sz="1000" dirty="0">
                 <a:solidFill>
-                  <a:srgbClr val="CADCFC"/>
+                  <a:srgbClr val="5B6472"/>
                 </a:solidFill>
                 <a:latin typeface="Calibri" pitchFamily="34" charset="0"/>
                 <a:ea typeface="Calibri" pitchFamily="34" charset="-122"/>
@@ -20442,8 +20479,8 @@
           <p:nvPr/>
         </p:nvGraphicFramePr>
         <p:xfrm>
-          <a:off x="548640" y="1554480"/>
-          <a:ext cx="11094415" cy="4114800"/>
+          <a:off x="548640" y="1508760"/>
+          <a:ext cx="11094415" cy="3840480"/>
         </p:xfrm>
         <a:graphic xmlns:a="http://schemas.openxmlformats.org/drawingml/2006/main">
           <a:graphicData uri="http://schemas.openxmlformats.org/drawingml/2006/chart">
@@ -20459,8 +20496,8 @@
         </p:nvSpPr>
         <p:spPr>
           <a:xfrm>
-            <a:off x="548640" y="5806440"/>
-            <a:ext cx="11094415" cy="365760"/>
+            <a:off x="548640" y="5486400"/>
+            <a:ext cx="11094415" cy="292608"/>
           </a:xfrm>
           <a:prstGeom prst="rect">
             <a:avLst/>
@@ -20476,7 +20513,7 @@
               <a:buNone/>
             </a:pPr>
             <a:r>
-              <a:rPr lang="en-US" sz="1300" i="1" dirty="0">
+              <a:rPr lang="en-US" sz="1250" i="1" dirty="0">
                 <a:solidFill>
                   <a:srgbClr val="5B6472"/>
                 </a:solidFill>
@@ -20486,13 +20523,52 @@
               </a:rPr>
               <a:t>Median nurse response: 29.7h → 4.0h — but 90.0 urgent cases a week are now missed.</a:t>
             </a:r>
-            <a:endParaRPr lang="en-US" sz="1300" dirty="0"/>
+            <a:endParaRPr lang="en-US" sz="1250" dirty="0"/>
           </a:p>
         </p:txBody>
       </p:sp>
       <p:sp>
         <p:nvSpPr>
           <p:cNvPr id="6" name="Text 3"/>
+          <p:cNvSpPr txBox="1"/>
+          <p:nvPr/>
+        </p:nvSpPr>
+        <p:spPr>
+          <a:xfrm>
+            <a:off x="548640" y="5806440"/>
+            <a:ext cx="11094415" cy="292608"/>
+          </a:xfrm>
+          <a:prstGeom prst="rect">
+            <a:avLst/>
+          </a:prstGeom>
+          <a:noFill/>
+          <a:ln/>
+        </p:spPr>
+        <p:txBody>
+          <a:bodyPr wrap="square" lIns="0" tIns="0" rIns="0" bIns="0" rtlCol="0" anchor="ctr"/>
+          <a:lstStyle/>
+          <a:p>
+            <a:pPr indent="0" marL="0">
+              <a:buNone/>
+            </a:pPr>
+            <a:r>
+              <a:rPr lang="en-US" sz="1200" i="1" dirty="0">
+                <a:solidFill>
+                  <a:srgbClr val="1C7293"/>
+                </a:solidFill>
+                <a:latin typeface="Calibri" pitchFamily="34" charset="0"/>
+                <a:ea typeface="Calibri" pitchFamily="34" charset="-122"/>
+                <a:cs typeface="Calibri" pitchFamily="34" charset="-120"/>
+              </a:rPr>
+              <a:t>Numbers from a triage deployment made with the 190/115 decisions on this laptop; your room's numbers will differ. Show the live dashboard.</a:t>
+            </a:r>
+            <a:endParaRPr lang="en-US" sz="1200" dirty="0"/>
+          </a:p>
+        </p:txBody>
+      </p:sp>
+      <p:sp>
+        <p:nvSpPr>
+          <p:cNvPr id="7" name="Text 4"/>
           <p:cNvSpPr txBox="1"/>
           <p:nvPr/>
         </p:nvSpPr>

</xml_diff>

<commit_message>
Calibrate the simulation so Exhibit B lands on the paper case
The dashboard, slide 7 and the docs showed 334 patients inactive and 2
resignations against the case's 340 and 3. The model now has a resignation
hazard that ramps in from week 19 (nurses do not quit in the first month of
overload) and caps at 30% overload, and a slightly steeper response curve.
Last quarter now reads 22 nurses, 31.1 h median, 1,151 overtime hours,
3 resignations (weeks 29, 34, 38), 340 inactive. Headcount is reported as
the end-of-quarter number rather than a quarterly average.

Regenerated sim/out, slide 7's table, the slide 9 and 11 charts and
captions, and the figures quoted in docs/03, docs/04 and slides/outline.md.
test_sim now pins the Exhibit B numbers.

Co-Authored-By: Claude Fable 5.1 <noreply@anthropic.com>
Claude-Session: https://claude.ai/code/session_01Jo9JuGz9sGjCWMSFMqHMPx
</commit_message>
<xml_diff>
--- a/slides/deck.pptx
+++ b/slides/deck.pptx
@@ -229,170 +229,168 @@
             </c:spPr>
           </c:marker>
           <c:cat>
-            <c:multiLvlStrRef>
+            <c:strRef>
               <c:f>Sheet1!$A$2:$A$53</c:f>
-              <c:multiLvlStrCache>
+              <c:strCache>
                 <c:ptCount val="52"/>
-                <c:lvl>
-                  <c:pt idx="0">
-                    <c:v>1</c:v>
-                  </c:pt>
-                  <c:pt idx="1">
-                    <c:v>2</c:v>
-                  </c:pt>
-                  <c:pt idx="2">
-                    <c:v>3</c:v>
-                  </c:pt>
-                  <c:pt idx="3">
-                    <c:v>4</c:v>
-                  </c:pt>
-                  <c:pt idx="4">
-                    <c:v>5</c:v>
-                  </c:pt>
-                  <c:pt idx="5">
-                    <c:v>6</c:v>
-                  </c:pt>
-                  <c:pt idx="6">
-                    <c:v>7</c:v>
-                  </c:pt>
-                  <c:pt idx="7">
-                    <c:v>8</c:v>
-                  </c:pt>
-                  <c:pt idx="8">
-                    <c:v>9</c:v>
-                  </c:pt>
-                  <c:pt idx="9">
-                    <c:v>10</c:v>
-                  </c:pt>
-                  <c:pt idx="10">
-                    <c:v>11</c:v>
-                  </c:pt>
-                  <c:pt idx="11">
-                    <c:v>12</c:v>
-                  </c:pt>
-                  <c:pt idx="12">
-                    <c:v>13</c:v>
-                  </c:pt>
-                  <c:pt idx="13">
-                    <c:v>14</c:v>
-                  </c:pt>
-                  <c:pt idx="14">
-                    <c:v>15</c:v>
-                  </c:pt>
-                  <c:pt idx="15">
-                    <c:v>16</c:v>
-                  </c:pt>
-                  <c:pt idx="16">
-                    <c:v>17</c:v>
-                  </c:pt>
-                  <c:pt idx="17">
-                    <c:v>18</c:v>
-                  </c:pt>
-                  <c:pt idx="18">
-                    <c:v>19</c:v>
-                  </c:pt>
-                  <c:pt idx="19">
-                    <c:v>20</c:v>
-                  </c:pt>
-                  <c:pt idx="20">
-                    <c:v>21</c:v>
-                  </c:pt>
-                  <c:pt idx="21">
-                    <c:v>22</c:v>
-                  </c:pt>
-                  <c:pt idx="22">
-                    <c:v>23</c:v>
-                  </c:pt>
-                  <c:pt idx="23">
-                    <c:v>24</c:v>
-                  </c:pt>
-                  <c:pt idx="24">
-                    <c:v>25</c:v>
-                  </c:pt>
-                  <c:pt idx="25">
-                    <c:v>26</c:v>
-                  </c:pt>
-                  <c:pt idx="26">
-                    <c:v>27</c:v>
-                  </c:pt>
-                  <c:pt idx="27">
-                    <c:v>28</c:v>
-                  </c:pt>
-                  <c:pt idx="28">
-                    <c:v>29</c:v>
-                  </c:pt>
-                  <c:pt idx="29">
-                    <c:v>30</c:v>
-                  </c:pt>
-                  <c:pt idx="30">
-                    <c:v>31</c:v>
-                  </c:pt>
-                  <c:pt idx="31">
-                    <c:v>32</c:v>
-                  </c:pt>
-                  <c:pt idx="32">
-                    <c:v>33</c:v>
-                  </c:pt>
-                  <c:pt idx="33">
-                    <c:v>34</c:v>
-                  </c:pt>
-                  <c:pt idx="34">
-                    <c:v>35</c:v>
-                  </c:pt>
-                  <c:pt idx="35">
-                    <c:v>36</c:v>
-                  </c:pt>
-                  <c:pt idx="36">
-                    <c:v>37</c:v>
-                  </c:pt>
-                  <c:pt idx="37">
-                    <c:v>38</c:v>
-                  </c:pt>
-                  <c:pt idx="38">
-                    <c:v>39</c:v>
-                  </c:pt>
-                  <c:pt idx="39">
-                    <c:v>40</c:v>
-                  </c:pt>
-                  <c:pt idx="40">
-                    <c:v>41</c:v>
-                  </c:pt>
-                  <c:pt idx="41">
-                    <c:v>42</c:v>
-                  </c:pt>
-                  <c:pt idx="42">
-                    <c:v>43</c:v>
-                  </c:pt>
-                  <c:pt idx="43">
-                    <c:v>44</c:v>
-                  </c:pt>
-                  <c:pt idx="44">
-                    <c:v>45</c:v>
-                  </c:pt>
-                  <c:pt idx="45">
-                    <c:v>46</c:v>
-                  </c:pt>
-                  <c:pt idx="46">
-                    <c:v>47</c:v>
-                  </c:pt>
-                  <c:pt idx="47">
-                    <c:v>48</c:v>
-                  </c:pt>
-                  <c:pt idx="48">
-                    <c:v>49</c:v>
-                  </c:pt>
-                  <c:pt idx="49">
-                    <c:v>50</c:v>
-                  </c:pt>
-                  <c:pt idx="50">
-                    <c:v>51</c:v>
-                  </c:pt>
-                  <c:pt idx="51">
-                    <c:v>52</c:v>
-                  </c:pt>
-                </c:lvl>
-              </c:multiLvlStrCache>
-            </c:multiLvlStrRef>
+                <c:pt idx="0">
+                  <c:v>1</c:v>
+                </c:pt>
+                <c:pt idx="1">
+                  <c:v>2</c:v>
+                </c:pt>
+                <c:pt idx="2">
+                  <c:v>3</c:v>
+                </c:pt>
+                <c:pt idx="3">
+                  <c:v>4</c:v>
+                </c:pt>
+                <c:pt idx="4">
+                  <c:v>5</c:v>
+                </c:pt>
+                <c:pt idx="5">
+                  <c:v>6</c:v>
+                </c:pt>
+                <c:pt idx="6">
+                  <c:v>7</c:v>
+                </c:pt>
+                <c:pt idx="7">
+                  <c:v>8</c:v>
+                </c:pt>
+                <c:pt idx="8">
+                  <c:v>9</c:v>
+                </c:pt>
+                <c:pt idx="9">
+                  <c:v>10</c:v>
+                </c:pt>
+                <c:pt idx="10">
+                  <c:v>11</c:v>
+                </c:pt>
+                <c:pt idx="11">
+                  <c:v>12</c:v>
+                </c:pt>
+                <c:pt idx="12">
+                  <c:v>13</c:v>
+                </c:pt>
+                <c:pt idx="13">
+                  <c:v>14</c:v>
+                </c:pt>
+                <c:pt idx="14">
+                  <c:v>15</c:v>
+                </c:pt>
+                <c:pt idx="15">
+                  <c:v>16</c:v>
+                </c:pt>
+                <c:pt idx="16">
+                  <c:v>17</c:v>
+                </c:pt>
+                <c:pt idx="17">
+                  <c:v>18</c:v>
+                </c:pt>
+                <c:pt idx="18">
+                  <c:v>19</c:v>
+                </c:pt>
+                <c:pt idx="19">
+                  <c:v>20</c:v>
+                </c:pt>
+                <c:pt idx="20">
+                  <c:v>21</c:v>
+                </c:pt>
+                <c:pt idx="21">
+                  <c:v>22</c:v>
+                </c:pt>
+                <c:pt idx="22">
+                  <c:v>23</c:v>
+                </c:pt>
+                <c:pt idx="23">
+                  <c:v>24</c:v>
+                </c:pt>
+                <c:pt idx="24">
+                  <c:v>25</c:v>
+                </c:pt>
+                <c:pt idx="25">
+                  <c:v>26</c:v>
+                </c:pt>
+                <c:pt idx="26">
+                  <c:v>27</c:v>
+                </c:pt>
+                <c:pt idx="27">
+                  <c:v>28</c:v>
+                </c:pt>
+                <c:pt idx="28">
+                  <c:v>29</c:v>
+                </c:pt>
+                <c:pt idx="29">
+                  <c:v>30</c:v>
+                </c:pt>
+                <c:pt idx="30">
+                  <c:v>31</c:v>
+                </c:pt>
+                <c:pt idx="31">
+                  <c:v>32</c:v>
+                </c:pt>
+                <c:pt idx="32">
+                  <c:v>33</c:v>
+                </c:pt>
+                <c:pt idx="33">
+                  <c:v>34</c:v>
+                </c:pt>
+                <c:pt idx="34">
+                  <c:v>35</c:v>
+                </c:pt>
+                <c:pt idx="35">
+                  <c:v>36</c:v>
+                </c:pt>
+                <c:pt idx="36">
+                  <c:v>37</c:v>
+                </c:pt>
+                <c:pt idx="37">
+                  <c:v>38</c:v>
+                </c:pt>
+                <c:pt idx="38">
+                  <c:v>39</c:v>
+                </c:pt>
+                <c:pt idx="39">
+                  <c:v>40</c:v>
+                </c:pt>
+                <c:pt idx="40">
+                  <c:v>41</c:v>
+                </c:pt>
+                <c:pt idx="41">
+                  <c:v>42</c:v>
+                </c:pt>
+                <c:pt idx="42">
+                  <c:v>43</c:v>
+                </c:pt>
+                <c:pt idx="43">
+                  <c:v>44</c:v>
+                </c:pt>
+                <c:pt idx="44">
+                  <c:v>45</c:v>
+                </c:pt>
+                <c:pt idx="45">
+                  <c:v>46</c:v>
+                </c:pt>
+                <c:pt idx="46">
+                  <c:v>47</c:v>
+                </c:pt>
+                <c:pt idx="47">
+                  <c:v>48</c:v>
+                </c:pt>
+                <c:pt idx="48">
+                  <c:v>49</c:v>
+                </c:pt>
+                <c:pt idx="49">
+                  <c:v>50</c:v>
+                </c:pt>
+                <c:pt idx="50">
+                  <c:v>51</c:v>
+                </c:pt>
+                <c:pt idx="51">
+                  <c:v>52</c:v>
+                </c:pt>
+              </c:strCache>
+            </c:strRef>
           </c:cat>
           <c:val>
             <c:numRef>
@@ -401,91 +399,91 @@
                 <c:formatCode>General</c:formatCode>
                 <c:ptCount val="52"/>
                 <c:pt idx="0">
-                  <c:v>18.1</c:v>
+                  <c:v>22.2</c:v>
                 </c:pt>
                 <c:pt idx="1">
-                  <c:v>18.1</c:v>
+                  <c:v>22.2</c:v>
                 </c:pt>
                 <c:pt idx="2">
-                  <c:v>18.1</c:v>
+                  <c:v>22.2</c:v>
                 </c:pt>
                 <c:pt idx="3">
-                  <c:v>18.1</c:v>
+                  <c:v>22.2</c:v>
                 </c:pt>
                 <c:pt idx="4">
-                  <c:v>18.1</c:v>
+                  <c:v>22.2</c:v>
                 </c:pt>
                 <c:pt idx="5">
-                  <c:v>18.1</c:v>
+                  <c:v>22.2</c:v>
                 </c:pt>
                 <c:pt idx="6">
-                  <c:v>18.1</c:v>
+                  <c:v>22.2</c:v>
                 </c:pt>
                 <c:pt idx="7">
-                  <c:v>18.1</c:v>
+                  <c:v>22.2</c:v>
                 </c:pt>
                 <c:pt idx="8">
-                  <c:v>18.1</c:v>
+                  <c:v>22.2</c:v>
                 </c:pt>
                 <c:pt idx="9">
-                  <c:v>18.1</c:v>
+                  <c:v>22.2</c:v>
                 </c:pt>
                 <c:pt idx="10">
-                  <c:v>18.1</c:v>
+                  <c:v>22.2</c:v>
                 </c:pt>
                 <c:pt idx="11">
-                  <c:v>18.1</c:v>
+                  <c:v>22.2</c:v>
                 </c:pt>
                 <c:pt idx="12">
-                  <c:v>18.1</c:v>
+                  <c:v>22.2</c:v>
                 </c:pt>
                 <c:pt idx="13">
-                  <c:v>18.1</c:v>
+                  <c:v>22.2</c:v>
                 </c:pt>
                 <c:pt idx="14">
-                  <c:v>18.1</c:v>
+                  <c:v>22.2</c:v>
                 </c:pt>
                 <c:pt idx="15">
-                  <c:v>22.5</c:v>
+                  <c:v>22.2</c:v>
                 </c:pt>
                 <c:pt idx="16">
-                  <c:v>22.5</c:v>
+                  <c:v>22.2</c:v>
                 </c:pt>
                 <c:pt idx="17">
-                  <c:v>22.5</c:v>
+                  <c:v>22.2</c:v>
                 </c:pt>
                 <c:pt idx="18">
-                  <c:v>22.5</c:v>
+                  <c:v>22.2</c:v>
                 </c:pt>
                 <c:pt idx="19">
-                  <c:v>22.5</c:v>
+                  <c:v>22.2</c:v>
                 </c:pt>
                 <c:pt idx="20">
-                  <c:v>22.5</c:v>
+                  <c:v>22.2</c:v>
                 </c:pt>
                 <c:pt idx="21">
-                  <c:v>22.5</c:v>
+                  <c:v>22.2</c:v>
                 </c:pt>
                 <c:pt idx="22">
-                  <c:v>22.5</c:v>
+                  <c:v>22.2</c:v>
                 </c:pt>
                 <c:pt idx="23">
-                  <c:v>22.5</c:v>
+                  <c:v>22.2</c:v>
                 </c:pt>
                 <c:pt idx="24">
-                  <c:v>22.5</c:v>
+                  <c:v>22.2</c:v>
                 </c:pt>
                 <c:pt idx="25">
-                  <c:v>22.5</c:v>
+                  <c:v>22.2</c:v>
                 </c:pt>
                 <c:pt idx="26">
-                  <c:v>22.5</c:v>
+                  <c:v>22.2</c:v>
                 </c:pt>
                 <c:pt idx="27">
-                  <c:v>28.3</c:v>
+                  <c:v>22.2</c:v>
                 </c:pt>
                 <c:pt idx="28">
-                  <c:v>28.3</c:v>
+                  <c:v>22.2</c:v>
                 </c:pt>
                 <c:pt idx="29">
                   <c:v>28.3</c:v>
@@ -503,58 +501,58 @@
                   <c:v>28.3</c:v>
                 </c:pt>
                 <c:pt idx="34">
-                  <c:v>28.3</c:v>
+                  <c:v>36.7</c:v>
                 </c:pt>
                 <c:pt idx="35">
-                  <c:v>28.3</c:v>
+                  <c:v>36.7</c:v>
                 </c:pt>
                 <c:pt idx="36">
-                  <c:v>36.4</c:v>
+                  <c:v>36.7</c:v>
                 </c:pt>
                 <c:pt idx="37">
-                  <c:v>36.4</c:v>
+                  <c:v>36.7</c:v>
                 </c:pt>
                 <c:pt idx="38">
-                  <c:v>36.4</c:v>
+                  <c:v>48.9</c:v>
                 </c:pt>
                 <c:pt idx="39">
-                  <c:v>4</c:v>
+                  <c:v>4.0</c:v>
                 </c:pt>
                 <c:pt idx="40">
-                  <c:v>4</c:v>
+                  <c:v>4.0</c:v>
                 </c:pt>
                 <c:pt idx="41">
-                  <c:v>4</c:v>
+                  <c:v>4.0</c:v>
                 </c:pt>
                 <c:pt idx="42">
-                  <c:v>4</c:v>
+                  <c:v>4.0</c:v>
                 </c:pt>
                 <c:pt idx="43">
-                  <c:v>4</c:v>
+                  <c:v>4.0</c:v>
                 </c:pt>
                 <c:pt idx="44">
-                  <c:v>4</c:v>
+                  <c:v>4.0</c:v>
                 </c:pt>
                 <c:pt idx="45">
-                  <c:v>4</c:v>
+                  <c:v>4.0</c:v>
                 </c:pt>
                 <c:pt idx="46">
-                  <c:v>4</c:v>
+                  <c:v>4.0</c:v>
                 </c:pt>
                 <c:pt idx="47">
-                  <c:v>4</c:v>
+                  <c:v>4.0</c:v>
                 </c:pt>
                 <c:pt idx="48">
-                  <c:v>4</c:v>
+                  <c:v>4.0</c:v>
                 </c:pt>
                 <c:pt idx="49">
-                  <c:v>4</c:v>
+                  <c:v>4.0</c:v>
                 </c:pt>
                 <c:pt idx="50">
-                  <c:v>4</c:v>
+                  <c:v>4.0</c:v>
                 </c:pt>
                 <c:pt idx="51">
-                  <c:v>4</c:v>
+                  <c:v>4.0</c:v>
                 </c:pt>
               </c:numCache>
             </c:numRef>
@@ -844,53 +842,51 @@
             </c:spPr>
           </c:marker>
           <c:cat>
-            <c:multiLvlStrRef>
+            <c:strRef>
               <c:f>Sheet1!$A$2:$A$14</c:f>
-              <c:multiLvlStrCache>
+              <c:strCache>
                 <c:ptCount val="13"/>
-                <c:lvl>
-                  <c:pt idx="0">
-                    <c:v>40</c:v>
-                  </c:pt>
-                  <c:pt idx="1">
-                    <c:v>41</c:v>
-                  </c:pt>
-                  <c:pt idx="2">
-                    <c:v>42</c:v>
-                  </c:pt>
-                  <c:pt idx="3">
-                    <c:v>43</c:v>
-                  </c:pt>
-                  <c:pt idx="4">
-                    <c:v>44</c:v>
-                  </c:pt>
-                  <c:pt idx="5">
-                    <c:v>45</c:v>
-                  </c:pt>
-                  <c:pt idx="6">
-                    <c:v>46</c:v>
-                  </c:pt>
-                  <c:pt idx="7">
-                    <c:v>47</c:v>
-                  </c:pt>
-                  <c:pt idx="8">
-                    <c:v>48</c:v>
-                  </c:pt>
-                  <c:pt idx="9">
-                    <c:v>49</c:v>
-                  </c:pt>
-                  <c:pt idx="10">
-                    <c:v>50</c:v>
-                  </c:pt>
-                  <c:pt idx="11">
-                    <c:v>51</c:v>
-                  </c:pt>
-                  <c:pt idx="12">
-                    <c:v>52</c:v>
-                  </c:pt>
-                </c:lvl>
-              </c:multiLvlStrCache>
-            </c:multiLvlStrRef>
+                <c:pt idx="0">
+                  <c:v>40</c:v>
+                </c:pt>
+                <c:pt idx="1">
+                  <c:v>41</c:v>
+                </c:pt>
+                <c:pt idx="2">
+                  <c:v>42</c:v>
+                </c:pt>
+                <c:pt idx="3">
+                  <c:v>43</c:v>
+                </c:pt>
+                <c:pt idx="4">
+                  <c:v>44</c:v>
+                </c:pt>
+                <c:pt idx="5">
+                  <c:v>45</c:v>
+                </c:pt>
+                <c:pt idx="6">
+                  <c:v>46</c:v>
+                </c:pt>
+                <c:pt idx="7">
+                  <c:v>47</c:v>
+                </c:pt>
+                <c:pt idx="8">
+                  <c:v>48</c:v>
+                </c:pt>
+                <c:pt idx="9">
+                  <c:v>49</c:v>
+                </c:pt>
+                <c:pt idx="10">
+                  <c:v>50</c:v>
+                </c:pt>
+                <c:pt idx="11">
+                  <c:v>51</c:v>
+                </c:pt>
+                <c:pt idx="12">
+                  <c:v>52</c:v>
+                </c:pt>
+              </c:strCache>
+            </c:strRef>
           </c:cat>
           <c:val>
             <c:numRef>
@@ -899,43 +895,43 @@
                 <c:formatCode>General</c:formatCode>
                 <c:ptCount val="13"/>
                 <c:pt idx="0">
-                  <c:v>24.2</c:v>
+                  <c:v>30.8</c:v>
                 </c:pt>
                 <c:pt idx="1">
-                  <c:v>24.2</c:v>
+                  <c:v>30.8</c:v>
                 </c:pt>
                 <c:pt idx="2">
-                  <c:v>24.2</c:v>
+                  <c:v>30.8</c:v>
                 </c:pt>
                 <c:pt idx="3">
-                  <c:v>24.2</c:v>
+                  <c:v>30.8</c:v>
                 </c:pt>
                 <c:pt idx="4">
-                  <c:v>24.2</c:v>
+                  <c:v>30.8</c:v>
                 </c:pt>
                 <c:pt idx="5">
-                  <c:v>24.2</c:v>
+                  <c:v>41.2</c:v>
                 </c:pt>
                 <c:pt idx="6">
-                  <c:v>24.2</c:v>
+                  <c:v>41.2</c:v>
                 </c:pt>
                 <c:pt idx="7">
-                  <c:v>24.2</c:v>
+                  <c:v>41.2</c:v>
                 </c:pt>
                 <c:pt idx="8">
-                  <c:v>24.2</c:v>
+                  <c:v>41.2</c:v>
                 </c:pt>
                 <c:pt idx="9">
-                  <c:v>24.2</c:v>
+                  <c:v>56.7</c:v>
                 </c:pt>
                 <c:pt idx="10">
-                  <c:v>24.2</c:v>
+                  <c:v>56.7</c:v>
                 </c:pt>
                 <c:pt idx="11">
-                  <c:v>24.2</c:v>
+                  <c:v>56.7</c:v>
                 </c:pt>
                 <c:pt idx="12">
-                  <c:v>31.3</c:v>
+                  <c:v>56.7</c:v>
                 </c:pt>
               </c:numCache>
             </c:numRef>
@@ -1012,53 +1008,51 @@
             </c:spPr>
           </c:marker>
           <c:cat>
-            <c:multiLvlStrRef>
+            <c:strRef>
               <c:f>Sheet1!$A$2:$A$14</c:f>
-              <c:multiLvlStrCache>
+              <c:strCache>
                 <c:ptCount val="13"/>
-                <c:lvl>
-                  <c:pt idx="0">
-                    <c:v>40</c:v>
-                  </c:pt>
-                  <c:pt idx="1">
-                    <c:v>41</c:v>
-                  </c:pt>
-                  <c:pt idx="2">
-                    <c:v>42</c:v>
-                  </c:pt>
-                  <c:pt idx="3">
-                    <c:v>43</c:v>
-                  </c:pt>
-                  <c:pt idx="4">
-                    <c:v>44</c:v>
-                  </c:pt>
-                  <c:pt idx="5">
-                    <c:v>45</c:v>
-                  </c:pt>
-                  <c:pt idx="6">
-                    <c:v>46</c:v>
-                  </c:pt>
-                  <c:pt idx="7">
-                    <c:v>47</c:v>
-                  </c:pt>
-                  <c:pt idx="8">
-                    <c:v>48</c:v>
-                  </c:pt>
-                  <c:pt idx="9">
-                    <c:v>49</c:v>
-                  </c:pt>
-                  <c:pt idx="10">
-                    <c:v>50</c:v>
-                  </c:pt>
-                  <c:pt idx="11">
-                    <c:v>51</c:v>
-                  </c:pt>
-                  <c:pt idx="12">
-                    <c:v>52</c:v>
-                  </c:pt>
-                </c:lvl>
-              </c:multiLvlStrCache>
-            </c:multiLvlStrRef>
+                <c:pt idx="0">
+                  <c:v>40</c:v>
+                </c:pt>
+                <c:pt idx="1">
+                  <c:v>41</c:v>
+                </c:pt>
+                <c:pt idx="2">
+                  <c:v>42</c:v>
+                </c:pt>
+                <c:pt idx="3">
+                  <c:v>43</c:v>
+                </c:pt>
+                <c:pt idx="4">
+                  <c:v>44</c:v>
+                </c:pt>
+                <c:pt idx="5">
+                  <c:v>45</c:v>
+                </c:pt>
+                <c:pt idx="6">
+                  <c:v>46</c:v>
+                </c:pt>
+                <c:pt idx="7">
+                  <c:v>47</c:v>
+                </c:pt>
+                <c:pt idx="8">
+                  <c:v>48</c:v>
+                </c:pt>
+                <c:pt idx="9">
+                  <c:v>49</c:v>
+                </c:pt>
+                <c:pt idx="10">
+                  <c:v>50</c:v>
+                </c:pt>
+                <c:pt idx="11">
+                  <c:v>51</c:v>
+                </c:pt>
+                <c:pt idx="12">
+                  <c:v>52</c:v>
+                </c:pt>
+              </c:strCache>
+            </c:strRef>
           </c:cat>
           <c:val>
             <c:numRef>
@@ -1067,43 +1061,43 @@
                 <c:formatCode>General</c:formatCode>
                 <c:ptCount val="13"/>
                 <c:pt idx="0">
-                  <c:v>336</c:v>
+                  <c:v>336.0</c:v>
                 </c:pt>
                 <c:pt idx="1">
-                  <c:v>336</c:v>
+                  <c:v>336.0</c:v>
                 </c:pt>
                 <c:pt idx="2">
-                  <c:v>336</c:v>
+                  <c:v>336.0</c:v>
                 </c:pt>
                 <c:pt idx="3">
-                  <c:v>336</c:v>
+                  <c:v>336.0</c:v>
                 </c:pt>
                 <c:pt idx="4">
-                  <c:v>336</c:v>
+                  <c:v>336.0</c:v>
                 </c:pt>
                 <c:pt idx="5">
-                  <c:v>336</c:v>
+                  <c:v>336.0</c:v>
                 </c:pt>
                 <c:pt idx="6">
-                  <c:v>336</c:v>
+                  <c:v>336.0</c:v>
                 </c:pt>
                 <c:pt idx="7">
-                  <c:v>336</c:v>
+                  <c:v>336.0</c:v>
                 </c:pt>
                 <c:pt idx="8">
-                  <c:v>336</c:v>
+                  <c:v>336.0</c:v>
                 </c:pt>
                 <c:pt idx="9">
-                  <c:v>336</c:v>
+                  <c:v>336.0</c:v>
                 </c:pt>
                 <c:pt idx="10">
-                  <c:v>336</c:v>
+                  <c:v>336.0</c:v>
                 </c:pt>
                 <c:pt idx="11">
-                  <c:v>336</c:v>
+                  <c:v>336.0</c:v>
                 </c:pt>
                 <c:pt idx="12">
-                  <c:v>336</c:v>
+                  <c:v>336.0</c:v>
                 </c:pt>
               </c:numCache>
             </c:numRef>
@@ -5014,7 +5008,7 @@
                 <a:ea typeface="Calibri" pitchFamily="34" charset="-122"/>
                 <a:cs typeface="Calibri" pitchFamily="34" charset="-120"/>
               </a:rPr>
-              <a:t>Same 100,000 patients, same contract — 336h capped without the deployment, ~24–31h with it.</a:t>
+              <a:t>Same 100,000 patients, same contract — 336h capped without the deployment, 31h climbing to 57h with it. Triage buys a quarter, not headcount.</a:t>
             </a:r>
             <a:endParaRPr lang="en-US" sz="1250" dirty="0"/>
           </a:p>
@@ -12901,7 +12895,7 @@
                           <a:ea typeface="Calibri" pitchFamily="34" charset="-122"/>
                           <a:cs typeface="Calibri" pitchFamily="34" charset="-120"/>
                         </a:rPr>
-                        <a:t>25.0</a:t>
+                        <a:t>25</a:t>
                       </a:r>
                       <a:endParaRPr lang="en-US" sz="1300" dirty="0">
                         <a:latin typeface="Calibri" charset="0"/>
@@ -12969,7 +12963,7 @@
                           <a:ea typeface="Calibri" pitchFamily="34" charset="-122"/>
                           <a:cs typeface="Calibri" pitchFamily="34" charset="-120"/>
                         </a:rPr>
-                        <a:t>22.9</a:t>
+                        <a:t>22</a:t>
                       </a:r>
                       <a:endParaRPr lang="en-US" sz="1300" dirty="0">
                         <a:latin typeface="Calibri" charset="0"/>
@@ -13793,7 +13787,7 @@
                           <a:ea typeface="Calibri" pitchFamily="34" charset="-122"/>
                           <a:cs typeface="Calibri" pitchFamily="34" charset="-120"/>
                         </a:rPr>
-                        <a:t>29.7h</a:t>
+                        <a:t>31.1h</a:t>
                       </a:r>
                       <a:endParaRPr lang="en-US" sz="1300" dirty="0">
                         <a:latin typeface="Calibri" charset="0"/>
@@ -13999,7 +13993,7 @@
                           <a:ea typeface="Calibri" pitchFamily="34" charset="-122"/>
                           <a:cs typeface="Calibri" pitchFamily="34" charset="-120"/>
                         </a:rPr>
-                        <a:t>1,154</a:t>
+                        <a:t>1,151</a:t>
                       </a:r>
                       <a:endParaRPr lang="en-US" sz="1300" dirty="0">
                         <a:latin typeface="Calibri" charset="0"/>
@@ -14205,7 +14199,7 @@
                           <a:ea typeface="Calibri" pitchFamily="34" charset="-122"/>
                           <a:cs typeface="Calibri" pitchFamily="34" charset="-120"/>
                         </a:rPr>
-                        <a:t>2</a:t>
+                        <a:t>3</a:t>
                       </a:r>
                       <a:endParaRPr lang="en-US" sz="1300" dirty="0">
                         <a:latin typeface="Calibri" charset="0"/>
@@ -14411,7 +14405,7 @@
                           <a:ea typeface="Calibri" pitchFamily="34" charset="-122"/>
                           <a:cs typeface="Calibri" pitchFamily="34" charset="-120"/>
                         </a:rPr>
-                        <a:t>334</a:t>
+                        <a:t>340</a:t>
                       </a:r>
                       <a:endParaRPr lang="en-US" sz="1300" dirty="0">
                         <a:latin typeface="Calibri" charset="0"/>
@@ -20521,7 +20515,7 @@
                 <a:ea typeface="Calibri" pitchFamily="34" charset="-122"/>
                 <a:cs typeface="Calibri" pitchFamily="34" charset="-120"/>
               </a:rPr>
-              <a:t>Median nurse response: 29.7h → 4.0h — but 90.0 urgent cases a week are now missed.</a:t>
+              <a:t>Median nurse response: 31.1h → 4.0h — but 90.0 urgent cases a week are now missed.</a:t>
             </a:r>
             <a:endParaRPr lang="en-US" sz="1250" dirty="0"/>
           </a:p>

</xml_diff>

<commit_message>
Add a setup slide at the front of the deck for a conference room
New slide 1, "Get set up": Claude Code signed in, download the folder from
GitHub, /setup, the server in a second window, with the Windows notes and
the GitHub link in a band at the bottom. Footers, the outline, and the
slide numbers in the session plan and crosswalk shift by one.

Co-Authored-By: Claude Fable 5.1 <noreply@anthropic.com>
Claude-Session: https://claude.ai/code/session_01Jo9JuGz9sGjCWMSFMqHMPx
</commit_message>
<xml_diff>
--- a/slides/deck.pptx
+++ b/slides/deck.pptx
@@ -5,6 +5,7 @@
     <p:sldMasterId id="2147483648" r:id="rId1"/>
   </p:sldMasterIdLst>
   <p:sldIdLst>
+    <p:sldId id="270" r:id="rId21"/>
     <p:sldId id="256" r:id="rId2"/>
     <p:sldId id="257" r:id="rId3"/>
     <p:sldId id="258" r:id="rId4"/>
@@ -3311,6 +3312,10 @@
             <a:prstDash val="solid"/>
           </a:ln>
         </p:spPr>
+        <p:txBody>
+          <a:bodyPr/>
+          <a:p/>
+        </p:txBody>
       </p:sp>
       <p:sp>
         <p:nvSpPr>
@@ -3416,6 +3421,10 @@
             <a:prstDash val="solid"/>
           </a:ln>
         </p:spPr>
+        <p:txBody>
+          <a:bodyPr/>
+          <a:p/>
+        </p:txBody>
       </p:sp>
       <p:sp>
         <p:nvSpPr>
@@ -3521,6 +3530,10 @@
             <a:prstDash val="solid"/>
           </a:ln>
         </p:spPr>
+        <p:txBody>
+          <a:bodyPr/>
+          <a:p/>
+        </p:txBody>
       </p:sp>
       <p:sp>
         <p:nvSpPr>
@@ -4843,7 +4856,7 @@
                 <a:ea typeface="Calibri" pitchFamily="34" charset="-122"/>
                 <a:cs typeface="Calibri" pitchFamily="34" charset="-120"/>
               </a:rPr>
-              <a:t>Northline Care  ·  10</a:t>
+              <a:t>Northline Care  ·  11</a:t>
             </a:r>
             <a:endParaRPr lang="en-US" sz="1000" dirty="0"/>
           </a:p>
@@ -5086,7 +5099,7 @@
                 <a:ea typeface="Calibri" pitchFamily="34" charset="-122"/>
                 <a:cs typeface="Calibri" pitchFamily="34" charset="-120"/>
               </a:rPr>
-              <a:t>Northline Care  ·  11</a:t>
+              <a:t>Northline Care  ·  12</a:t>
             </a:r>
             <a:endParaRPr lang="en-US" sz="1000" dirty="0"/>
           </a:p>
@@ -7326,7 +7339,7 @@
                 <a:ea typeface="Calibri" pitchFamily="34" charset="-122"/>
                 <a:cs typeface="Calibri" pitchFamily="34" charset="-120"/>
               </a:rPr>
-              <a:t>Northline Care  ·  12</a:t>
+              <a:t>Northline Care  ·  13</a:t>
             </a:r>
             <a:endParaRPr lang="en-US" sz="1000" dirty="0"/>
           </a:p>
@@ -7461,6 +7474,10 @@
           </a:solidFill>
           <a:ln/>
         </p:spPr>
+        <p:txBody>
+          <a:bodyPr/>
+          <a:p/>
+        </p:txBody>
       </p:sp>
       <p:sp>
         <p:nvSpPr>
@@ -7576,7 +7593,7 @@
                 <a:ea typeface="Calibri" pitchFamily="34" charset="-122"/>
                 <a:cs typeface="Calibri" pitchFamily="34" charset="-120"/>
               </a:rPr>
-              <a:t>Northline Care  ·  13</a:t>
+              <a:t>Northline Care  ·  14</a:t>
             </a:r>
             <a:endParaRPr lang="en-US" sz="1000" dirty="0"/>
           </a:p>
@@ -7713,6 +7730,10 @@
           </a:solidFill>
           <a:ln/>
         </p:spPr>
+        <p:txBody>
+          <a:bodyPr/>
+          <a:p/>
+        </p:txBody>
       </p:sp>
       <p:sp>
         <p:nvSpPr>
@@ -7854,6 +7875,10 @@
             <a:tailEnd type="triangle"/>
           </a:ln>
         </p:spPr>
+        <p:txBody>
+          <a:bodyPr/>
+          <a:p/>
+        </p:txBody>
       </p:sp>
       <p:sp>
         <p:nvSpPr>
@@ -7876,6 +7901,10 @@
           </a:solidFill>
           <a:ln/>
         </p:spPr>
+        <p:txBody>
+          <a:bodyPr/>
+          <a:p/>
+        </p:txBody>
       </p:sp>
       <p:sp>
         <p:nvSpPr>
@@ -8017,6 +8046,10 @@
             <a:tailEnd type="triangle"/>
           </a:ln>
         </p:spPr>
+        <p:txBody>
+          <a:bodyPr/>
+          <a:p/>
+        </p:txBody>
       </p:sp>
       <p:sp>
         <p:nvSpPr>
@@ -8039,6 +8072,10 @@
           </a:solidFill>
           <a:ln/>
         </p:spPr>
+        <p:txBody>
+          <a:bodyPr/>
+          <a:p/>
+        </p:txBody>
       </p:sp>
       <p:sp>
         <p:nvSpPr>
@@ -8180,6 +8217,10 @@
             <a:tailEnd type="triangle"/>
           </a:ln>
         </p:spPr>
+        <p:txBody>
+          <a:bodyPr/>
+          <a:p/>
+        </p:txBody>
       </p:sp>
       <p:sp>
         <p:nvSpPr>
@@ -8202,6 +8243,10 @@
           </a:solidFill>
           <a:ln/>
         </p:spPr>
+        <p:txBody>
+          <a:bodyPr/>
+          <a:p/>
+        </p:txBody>
       </p:sp>
       <p:sp>
         <p:nvSpPr>
@@ -8346,6 +8391,10 @@
             <a:prstDash val="solid"/>
           </a:ln>
         </p:spPr>
+        <p:txBody>
+          <a:bodyPr/>
+          <a:p/>
+        </p:txBody>
       </p:sp>
       <p:sp>
         <p:nvSpPr>
@@ -8419,9 +8468,1138 @@
                 <a:ea typeface="Calibri" pitchFamily="34" charset="-122"/>
                 <a:cs typeface="Calibri" pitchFamily="34" charset="-120"/>
               </a:rPr>
-              <a:t>Northline Care  ·  14</a:t>
+              <a:t>Northline Care  ·  15</a:t>
             </a:r>
             <a:endParaRPr lang="en-US" sz="1000" dirty="0"/>
+          </a:p>
+        </p:txBody>
+      </p:sp>
+    </p:spTree>
+  </p:cSld>
+  <p:clrMapOvr>
+    <a:masterClrMapping/>
+  </p:clrMapOvr>
+</p:sld>
+</file>
+
+<file path=ppt/slides/slide15.xml><?xml version="1.0" encoding="utf-8"?>
+<p:sld xmlns:a="http://schemas.openxmlformats.org/drawingml/2006/main" xmlns:p="http://schemas.openxmlformats.org/presentationml/2006/main" xmlns:r="http://schemas.openxmlformats.org/officeDocument/2006/relationships">
+  <p:cSld>
+    <p:bg>
+      <p:bgPr>
+        <a:solidFill>
+          <a:srgbClr val="FFFFFF"/>
+        </a:solidFill>
+        <a:effectLst/>
+      </p:bgPr>
+    </p:bg>
+    <p:spTree>
+      <p:nvGrpSpPr>
+        <p:cNvPr id="1" name=""/>
+        <p:cNvGrpSpPr/>
+        <p:nvPr/>
+      </p:nvGrpSpPr>
+      <p:grpSpPr/>
+      <p:sp>
+        <p:nvSpPr>
+          <p:cNvPr id="2" name="TextBox 1"/>
+          <p:cNvSpPr txBox="1"/>
+          <p:nvPr/>
+        </p:nvSpPr>
+        <p:spPr>
+          <a:xfrm>
+            <a:off x="548640" y="164592"/>
+            <a:ext cx="11094415" cy="274320"/>
+          </a:xfrm>
+          <a:prstGeom prst="rect">
+            <a:avLst/>
+          </a:prstGeom>
+          <a:noFill/>
+        </p:spPr>
+        <p:txBody>
+          <a:bodyPr wrap="square" lIns="0" rIns="0" tIns="0" bIns="0">
+            <a:spAutoFit/>
+          </a:bodyPr>
+          <a:lstStyle/>
+          <a:p>
+            <a:r>
+              <a:rPr sz="1200" b="1">
+                <a:solidFill>
+                  <a:srgbClr val="1C7293"/>
+                </a:solidFill>
+                <a:latin typeface="Calibri"/>
+              </a:rPr>
+              <a:t>BEFORE WE START  ·  ABOUT 10 MINUTES</a:t>
+            </a:r>
+          </a:p>
+        </p:txBody>
+      </p:sp>
+      <p:sp>
+        <p:nvSpPr>
+          <p:cNvPr id="3" name="TextBox 2"/>
+          <p:cNvSpPr txBox="1"/>
+          <p:nvPr/>
+        </p:nvSpPr>
+        <p:spPr>
+          <a:xfrm>
+            <a:off x="548640" y="411480"/>
+            <a:ext cx="11094415" cy="822960"/>
+          </a:xfrm>
+          <a:prstGeom prst="rect">
+            <a:avLst/>
+          </a:prstGeom>
+          <a:noFill/>
+        </p:spPr>
+        <p:txBody>
+          <a:bodyPr wrap="square" lIns="0" rIns="0" tIns="0" bIns="0">
+            <a:spAutoFit/>
+          </a:bodyPr>
+          <a:lstStyle/>
+          <a:p>
+            <a:r>
+              <a:rPr sz="3200" b="1">
+                <a:solidFill>
+                  <a:srgbClr val="1B1F27"/>
+                </a:solidFill>
+                <a:latin typeface="Cambria"/>
+              </a:rPr>
+              <a:t>Get set up</a:t>
+            </a:r>
+          </a:p>
+        </p:txBody>
+      </p:sp>
+      <p:sp>
+        <p:nvSpPr>
+          <p:cNvPr id="4" name="Rounded Rectangle 3"/>
+          <p:cNvSpPr/>
+          <p:nvPr/>
+        </p:nvSpPr>
+        <p:spPr>
+          <a:xfrm>
+            <a:off x="548640" y="1417320"/>
+            <a:ext cx="5318608" cy="1783080"/>
+          </a:xfrm>
+          <a:prstGeom prst="roundRect">
+            <a:avLst>
+              <a:gd name="adj" fmla="val 3400"/>
+            </a:avLst>
+          </a:prstGeom>
+          <a:solidFill>
+            <a:srgbClr val="F4F7FA"/>
+          </a:solidFill>
+          <a:ln w="9525">
+            <a:solidFill>
+              <a:srgbClr val="D8E1EA"/>
+            </a:solidFill>
+          </a:ln>
+          <a:effectLst/>
+        </p:spPr>
+        <p:style>
+          <a:lnRef idx="1">
+            <a:schemeClr val="accent1"/>
+          </a:lnRef>
+          <a:fillRef idx="3">
+            <a:schemeClr val="accent1"/>
+          </a:fillRef>
+          <a:effectRef idx="2">
+            <a:schemeClr val="accent1"/>
+          </a:effectRef>
+          <a:fontRef idx="minor">
+            <a:schemeClr val="lt1"/>
+          </a:fontRef>
+        </p:style>
+        <p:txBody>
+          <a:bodyPr rtlCol="0" anchor="ctr"/>
+          <a:lstStyle/>
+          <a:p>
+            <a:pPr algn="ctr"/>
+          </a:p>
+        </p:txBody>
+      </p:sp>
+      <p:sp>
+        <p:nvSpPr>
+          <p:cNvPr id="5" name="TextBox 4"/>
+          <p:cNvSpPr txBox="1"/>
+          <p:nvPr/>
+        </p:nvSpPr>
+        <p:spPr>
+          <a:xfrm>
+            <a:off x="822960" y="1618488"/>
+            <a:ext cx="4769968" cy="365760"/>
+          </a:xfrm>
+          <a:prstGeom prst="rect">
+            <a:avLst/>
+          </a:prstGeom>
+          <a:noFill/>
+        </p:spPr>
+        <p:txBody>
+          <a:bodyPr wrap="square" lIns="0" rIns="0" tIns="0" bIns="0">
+            <a:spAutoFit/>
+          </a:bodyPr>
+          <a:lstStyle/>
+          <a:p>
+            <a:r>
+              <a:rPr sz="1700" b="1">
+                <a:solidFill>
+                  <a:srgbClr val="21295C"/>
+                </a:solidFill>
+                <a:latin typeface="Cambria"/>
+              </a:rPr>
+              <a:t>1. Claude Code, signed in</a:t>
+            </a:r>
+          </a:p>
+        </p:txBody>
+      </p:sp>
+      <p:sp>
+        <p:nvSpPr>
+          <p:cNvPr id="6" name="TextBox 5"/>
+          <p:cNvSpPr txBox="1"/>
+          <p:nvPr/>
+        </p:nvSpPr>
+        <p:spPr>
+          <a:xfrm>
+            <a:off x="822960" y="2029968"/>
+            <a:ext cx="4769968" cy="1078992"/>
+          </a:xfrm>
+          <a:prstGeom prst="rect">
+            <a:avLst/>
+          </a:prstGeom>
+          <a:noFill/>
+        </p:spPr>
+        <p:txBody>
+          <a:bodyPr wrap="square" lIns="0" rIns="0" tIns="0" bIns="0">
+            <a:spAutoFit/>
+          </a:bodyPr>
+          <a:lstStyle/>
+          <a:p>
+            <a:pPr>
+              <a:spcAft>
+                <a:spcPts val="600"/>
+              </a:spcAft>
+            </a:pPr>
+            <a:r>
+              <a:rPr sz="1200">
+                <a:solidFill>
+                  <a:srgbClr val="5B6472"/>
+                </a:solidFill>
+                <a:latin typeface="Calibri"/>
+              </a:rPr>
+              <a:t>Install the command-line tool and sign in with your Claude account. In a terminal, </a:t>
+            </a:r>
+            <a:r>
+              <a:rPr sz="1200" b="1">
+                <a:solidFill>
+                  <a:srgbClr val="1C7293"/>
+                </a:solidFill>
+                <a:latin typeface="Consolas"/>
+              </a:rPr>
+              <a:t>claude --version</a:t>
+            </a:r>
+            <a:r>
+              <a:rPr sz="1200">
+                <a:solidFill>
+                  <a:srgbClr val="5B6472"/>
+                </a:solidFill>
+                <a:latin typeface="Calibri"/>
+              </a:rPr>
+              <a:t> should print a version.</a:t>
+            </a:r>
+          </a:p>
+          <a:p>
+            <a:pPr>
+              <a:spcAft>
+                <a:spcPts val="600"/>
+              </a:spcAft>
+            </a:pPr>
+            <a:r>
+              <a:rPr sz="1200">
+                <a:solidFill>
+                  <a:srgbClr val="5B6472"/>
+                </a:solidFill>
+                <a:latin typeface="Calibri"/>
+              </a:rPr>
+              <a:t>Windows: use the native installer, not npm. Use PowerShell for the commands below.</a:t>
+            </a:r>
+          </a:p>
+        </p:txBody>
+      </p:sp>
+      <p:sp>
+        <p:nvSpPr>
+          <p:cNvPr id="7" name="Rounded Rectangle 6"/>
+          <p:cNvSpPr/>
+          <p:nvPr/>
+        </p:nvSpPr>
+        <p:spPr>
+          <a:xfrm>
+            <a:off x="6324448" y="1417320"/>
+            <a:ext cx="5318608" cy="1783080"/>
+          </a:xfrm>
+          <a:prstGeom prst="roundRect">
+            <a:avLst>
+              <a:gd name="adj" fmla="val 3400"/>
+            </a:avLst>
+          </a:prstGeom>
+          <a:solidFill>
+            <a:srgbClr val="F4F7FA"/>
+          </a:solidFill>
+          <a:ln w="9525">
+            <a:solidFill>
+              <a:srgbClr val="D8E1EA"/>
+            </a:solidFill>
+          </a:ln>
+          <a:effectLst/>
+        </p:spPr>
+        <p:style>
+          <a:lnRef idx="1">
+            <a:schemeClr val="accent1"/>
+          </a:lnRef>
+          <a:fillRef idx="3">
+            <a:schemeClr val="accent1"/>
+          </a:fillRef>
+          <a:effectRef idx="2">
+            <a:schemeClr val="accent1"/>
+          </a:effectRef>
+          <a:fontRef idx="minor">
+            <a:schemeClr val="lt1"/>
+          </a:fontRef>
+        </p:style>
+        <p:txBody>
+          <a:bodyPr rtlCol="0" anchor="ctr"/>
+          <a:lstStyle/>
+          <a:p>
+            <a:pPr algn="ctr"/>
+          </a:p>
+        </p:txBody>
+      </p:sp>
+      <p:sp>
+        <p:nvSpPr>
+          <p:cNvPr id="8" name="TextBox 7"/>
+          <p:cNvSpPr txBox="1"/>
+          <p:nvPr/>
+        </p:nvSpPr>
+        <p:spPr>
+          <a:xfrm>
+            <a:off x="6598768" y="1618488"/>
+            <a:ext cx="4769968" cy="365760"/>
+          </a:xfrm>
+          <a:prstGeom prst="rect">
+            <a:avLst/>
+          </a:prstGeom>
+          <a:noFill/>
+        </p:spPr>
+        <p:txBody>
+          <a:bodyPr wrap="square" lIns="0" rIns="0" tIns="0" bIns="0">
+            <a:spAutoFit/>
+          </a:bodyPr>
+          <a:lstStyle/>
+          <a:p>
+            <a:r>
+              <a:rPr sz="1700" b="1">
+                <a:solidFill>
+                  <a:srgbClr val="21295C"/>
+                </a:solidFill>
+                <a:latin typeface="Cambria"/>
+              </a:rPr>
+              <a:t>2. The course folder</a:t>
+            </a:r>
+          </a:p>
+        </p:txBody>
+      </p:sp>
+      <p:sp>
+        <p:nvSpPr>
+          <p:cNvPr id="9" name="TextBox 8"/>
+          <p:cNvSpPr txBox="1"/>
+          <p:nvPr/>
+        </p:nvSpPr>
+        <p:spPr>
+          <a:xfrm>
+            <a:off x="6598768" y="2029968"/>
+            <a:ext cx="4769968" cy="1078992"/>
+          </a:xfrm>
+          <a:prstGeom prst="rect">
+            <a:avLst/>
+          </a:prstGeom>
+          <a:noFill/>
+        </p:spPr>
+        <p:txBody>
+          <a:bodyPr wrap="square" lIns="0" rIns="0" tIns="0" bIns="0">
+            <a:spAutoFit/>
+          </a:bodyPr>
+          <a:lstStyle/>
+          <a:p>
+            <a:pPr>
+              <a:spcAft>
+                <a:spcPts val="600"/>
+              </a:spcAft>
+            </a:pPr>
+            <a:r>
+              <a:rPr sz="1200">
+                <a:solidFill>
+                  <a:srgbClr val="5B6472"/>
+                </a:solidFill>
+                <a:latin typeface="Calibri"/>
+              </a:rPr>
+              <a:t>Open the link at the bottom, click </a:t>
+            </a:r>
+            <a:r>
+              <a:rPr sz="1200" b="1">
+                <a:solidFill>
+                  <a:srgbClr val="5B6472"/>
+                </a:solidFill>
+                <a:latin typeface="Calibri"/>
+              </a:rPr>
+              <a:t>Code → Download ZIP</a:t>
+            </a:r>
+            <a:r>
+              <a:rPr sz="1200">
+                <a:solidFill>
+                  <a:srgbClr val="5B6472"/>
+                </a:solidFill>
+                <a:latin typeface="Calibri"/>
+              </a:rPr>
+              <a:t>, and unzip it into your home folder. It should be called </a:t>
+            </a:r>
+            <a:r>
+              <a:rPr sz="1200" b="1">
+                <a:solidFill>
+                  <a:srgbClr val="1C7293"/>
+                </a:solidFill>
+                <a:latin typeface="Consolas"/>
+              </a:rPr>
+              <a:t>northline-course</a:t>
+            </a:r>
+            <a:r>
+              <a:rPr sz="1200">
+                <a:solidFill>
+                  <a:srgbClr val="5B6472"/>
+                </a:solidFill>
+                <a:latin typeface="Calibri"/>
+              </a:rPr>
+              <a:t>.</a:t>
+            </a:r>
+          </a:p>
+          <a:p>
+            <a:pPr>
+              <a:spcAft>
+                <a:spcPts val="600"/>
+              </a:spcAft>
+            </a:pPr>
+            <a:r>
+              <a:rPr sz="1200">
+                <a:solidFill>
+                  <a:srgbClr val="5B6472"/>
+                </a:solidFill>
+                <a:latin typeface="Calibri"/>
+              </a:rPr>
+              <a:t>Or, if you have git: </a:t>
+            </a:r>
+            <a:r>
+              <a:rPr sz="1200" b="1">
+                <a:solidFill>
+                  <a:srgbClr val="1C7293"/>
+                </a:solidFill>
+                <a:latin typeface="Consolas"/>
+              </a:rPr>
+              <a:t>git clone &lt;the link&gt;</a:t>
+            </a:r>
+          </a:p>
+        </p:txBody>
+      </p:sp>
+      <p:sp>
+        <p:nvSpPr>
+          <p:cNvPr id="10" name="Rounded Rectangle 9"/>
+          <p:cNvSpPr/>
+          <p:nvPr/>
+        </p:nvSpPr>
+        <p:spPr>
+          <a:xfrm>
+            <a:off x="548640" y="3429000"/>
+            <a:ext cx="5318608" cy="1783080"/>
+          </a:xfrm>
+          <a:prstGeom prst="roundRect">
+            <a:avLst>
+              <a:gd name="adj" fmla="val 3400"/>
+            </a:avLst>
+          </a:prstGeom>
+          <a:solidFill>
+            <a:srgbClr val="F4F7FA"/>
+          </a:solidFill>
+          <a:ln w="9525">
+            <a:solidFill>
+              <a:srgbClr val="D8E1EA"/>
+            </a:solidFill>
+          </a:ln>
+          <a:effectLst/>
+        </p:spPr>
+        <p:style>
+          <a:lnRef idx="1">
+            <a:schemeClr val="accent1"/>
+          </a:lnRef>
+          <a:fillRef idx="3">
+            <a:schemeClr val="accent1"/>
+          </a:fillRef>
+          <a:effectRef idx="2">
+            <a:schemeClr val="accent1"/>
+          </a:effectRef>
+          <a:fontRef idx="minor">
+            <a:schemeClr val="lt1"/>
+          </a:fontRef>
+        </p:style>
+        <p:txBody>
+          <a:bodyPr rtlCol="0" anchor="ctr"/>
+          <a:lstStyle/>
+          <a:p>
+            <a:pPr algn="ctr"/>
+          </a:p>
+        </p:txBody>
+      </p:sp>
+      <p:sp>
+        <p:nvSpPr>
+          <p:cNvPr id="11" name="TextBox 10"/>
+          <p:cNvSpPr txBox="1"/>
+          <p:nvPr/>
+        </p:nvSpPr>
+        <p:spPr>
+          <a:xfrm>
+            <a:off x="822960" y="3630168"/>
+            <a:ext cx="4769968" cy="365760"/>
+          </a:xfrm>
+          <a:prstGeom prst="rect">
+            <a:avLst/>
+          </a:prstGeom>
+          <a:noFill/>
+        </p:spPr>
+        <p:txBody>
+          <a:bodyPr wrap="square" lIns="0" rIns="0" tIns="0" bIns="0">
+            <a:spAutoFit/>
+          </a:bodyPr>
+          <a:lstStyle/>
+          <a:p>
+            <a:r>
+              <a:rPr sz="1700" b="1">
+                <a:solidFill>
+                  <a:srgbClr val="21295C"/>
+                </a:solidFill>
+                <a:latin typeface="Cambria"/>
+              </a:rPr>
+              <a:t>3. /setup</a:t>
+            </a:r>
+          </a:p>
+        </p:txBody>
+      </p:sp>
+      <p:sp>
+        <p:nvSpPr>
+          <p:cNvPr id="12" name="TextBox 11"/>
+          <p:cNvSpPr txBox="1"/>
+          <p:nvPr/>
+        </p:nvSpPr>
+        <p:spPr>
+          <a:xfrm>
+            <a:off x="822960" y="4041648"/>
+            <a:ext cx="4769968" cy="1078992"/>
+          </a:xfrm>
+          <a:prstGeom prst="rect">
+            <a:avLst/>
+          </a:prstGeom>
+          <a:noFill/>
+        </p:spPr>
+        <p:txBody>
+          <a:bodyPr wrap="square" lIns="0" rIns="0" tIns="0" bIns="0">
+            <a:spAutoFit/>
+          </a:bodyPr>
+          <a:lstStyle/>
+          <a:p>
+            <a:pPr>
+              <a:spcAft>
+                <a:spcPts val="600"/>
+              </a:spcAft>
+            </a:pPr>
+            <a:r>
+              <a:rPr sz="1200">
+                <a:solidFill>
+                  <a:srgbClr val="5B6472"/>
+                </a:solidFill>
+                <a:latin typeface="Calibri"/>
+              </a:rPr>
+              <a:t>Terminal: </a:t>
+            </a:r>
+            <a:r>
+              <a:rPr sz="1200" b="1">
+                <a:solidFill>
+                  <a:srgbClr val="1C7293"/>
+                </a:solidFill>
+                <a:latin typeface="Consolas"/>
+              </a:rPr>
+              <a:t>cd ~/northline-course</a:t>
+            </a:r>
+            <a:r>
+              <a:rPr sz="1200">
+                <a:solidFill>
+                  <a:srgbClr val="5B6472"/>
+                </a:solidFill>
+                <a:latin typeface="Calibri"/>
+              </a:rPr>
+              <a:t> then </a:t>
+            </a:r>
+            <a:r>
+              <a:rPr sz="1200" b="1">
+                <a:solidFill>
+                  <a:srgbClr val="1C7293"/>
+                </a:solidFill>
+                <a:latin typeface="Consolas"/>
+              </a:rPr>
+              <a:t>claude</a:t>
+            </a:r>
+            <a:r>
+              <a:rPr sz="1200">
+                <a:solidFill>
+                  <a:srgbClr val="5B6472"/>
+                </a:solidFill>
+                <a:latin typeface="Calibri"/>
+              </a:rPr>
+              <a:t>. Type </a:t>
+            </a:r>
+            <a:r>
+              <a:rPr sz="1200" b="1">
+                <a:solidFill>
+                  <a:srgbClr val="1C7293"/>
+                </a:solidFill>
+                <a:latin typeface="Consolas"/>
+              </a:rPr>
+              <a:t>/setup</a:t>
+            </a:r>
+            <a:r>
+              <a:rPr sz="1200">
+                <a:solidFill>
+                  <a:srgbClr val="5B6472"/>
+                </a:solidFill>
+                <a:latin typeface="Calibri"/>
+              </a:rPr>
+              <a:t>. It installs uv, runs the checks, and prints a </a:t>
+            </a:r>
+            <a:r>
+              <a:rPr sz="1200" b="1">
+                <a:solidFill>
+                  <a:srgbClr val="1C7293"/>
+                </a:solidFill>
+                <a:latin typeface="Consolas"/>
+              </a:rPr>
+              <a:t>READY:</a:t>
+            </a:r>
+            <a:r>
+              <a:rPr sz="1200">
+                <a:solidFill>
+                  <a:srgbClr val="5B6472"/>
+                </a:solidFill>
+                <a:latin typeface="Calibri"/>
+              </a:rPr>
+              <a:t> line.</a:t>
+            </a:r>
+          </a:p>
+          <a:p>
+            <a:pPr>
+              <a:spcAft>
+                <a:spcPts val="600"/>
+              </a:spcAft>
+            </a:pPr>
+            <a:r>
+              <a:rPr sz="1200">
+                <a:solidFill>
+                  <a:srgbClr val="5B6472"/>
+                </a:solidFill>
+                <a:latin typeface="Calibri"/>
+              </a:rPr>
+              <a:t>Then quit, run </a:t>
+            </a:r>
+            <a:r>
+              <a:rPr sz="1200" b="1">
+                <a:solidFill>
+                  <a:srgbClr val="1C7293"/>
+                </a:solidFill>
+                <a:latin typeface="Consolas"/>
+              </a:rPr>
+              <a:t>claude</a:t>
+            </a:r>
+            <a:r>
+              <a:rPr sz="1200">
+                <a:solidFill>
+                  <a:srgbClr val="5B6472"/>
+                </a:solidFill>
+                <a:latin typeface="Calibri"/>
+              </a:rPr>
+              <a:t> again in the same folder, and approve the </a:t>
+            </a:r>
+            <a:r>
+              <a:rPr sz="1200" b="1">
+                <a:solidFill>
+                  <a:srgbClr val="1C7293"/>
+                </a:solidFill>
+                <a:latin typeface="Consolas"/>
+              </a:rPr>
+              <a:t>northline</a:t>
+            </a:r>
+            <a:r>
+              <a:rPr sz="1200">
+                <a:solidFill>
+                  <a:srgbClr val="5B6472"/>
+                </a:solidFill>
+                <a:latin typeface="Calibri"/>
+              </a:rPr>
+              <a:t> server when asked.</a:t>
+            </a:r>
+          </a:p>
+        </p:txBody>
+      </p:sp>
+      <p:sp>
+        <p:nvSpPr>
+          <p:cNvPr id="13" name="Rounded Rectangle 12"/>
+          <p:cNvSpPr/>
+          <p:nvPr/>
+        </p:nvSpPr>
+        <p:spPr>
+          <a:xfrm>
+            <a:off x="6324448" y="3429000"/>
+            <a:ext cx="5318608" cy="1783080"/>
+          </a:xfrm>
+          <a:prstGeom prst="roundRect">
+            <a:avLst>
+              <a:gd name="adj" fmla="val 3400"/>
+            </a:avLst>
+          </a:prstGeom>
+          <a:solidFill>
+            <a:srgbClr val="F4F7FA"/>
+          </a:solidFill>
+          <a:ln w="9525">
+            <a:solidFill>
+              <a:srgbClr val="D8E1EA"/>
+            </a:solidFill>
+          </a:ln>
+          <a:effectLst/>
+        </p:spPr>
+        <p:style>
+          <a:lnRef idx="1">
+            <a:schemeClr val="accent1"/>
+          </a:lnRef>
+          <a:fillRef idx="3">
+            <a:schemeClr val="accent1"/>
+          </a:fillRef>
+          <a:effectRef idx="2">
+            <a:schemeClr val="accent1"/>
+          </a:effectRef>
+          <a:fontRef idx="minor">
+            <a:schemeClr val="lt1"/>
+          </a:fontRef>
+        </p:style>
+        <p:txBody>
+          <a:bodyPr rtlCol="0" anchor="ctr"/>
+          <a:lstStyle/>
+          <a:p>
+            <a:pPr algn="ctr"/>
+          </a:p>
+        </p:txBody>
+      </p:sp>
+      <p:sp>
+        <p:nvSpPr>
+          <p:cNvPr id="14" name="TextBox 13"/>
+          <p:cNvSpPr txBox="1"/>
+          <p:nvPr/>
+        </p:nvSpPr>
+        <p:spPr>
+          <a:xfrm>
+            <a:off x="6598768" y="3630168"/>
+            <a:ext cx="4769968" cy="365760"/>
+          </a:xfrm>
+          <a:prstGeom prst="rect">
+            <a:avLst/>
+          </a:prstGeom>
+          <a:noFill/>
+        </p:spPr>
+        <p:txBody>
+          <a:bodyPr wrap="square" lIns="0" rIns="0" tIns="0" bIns="0">
+            <a:spAutoFit/>
+          </a:bodyPr>
+          <a:lstStyle/>
+          <a:p>
+            <a:r>
+              <a:rPr sz="1700" b="1">
+                <a:solidFill>
+                  <a:srgbClr val="21295C"/>
+                </a:solidFill>
+                <a:latin typeface="Cambria"/>
+              </a:rPr>
+              <a:t>4. The server, in a second window</a:t>
+            </a:r>
+          </a:p>
+        </p:txBody>
+      </p:sp>
+      <p:sp>
+        <p:nvSpPr>
+          <p:cNvPr id="15" name="TextBox 14"/>
+          <p:cNvSpPr txBox="1"/>
+          <p:nvPr/>
+        </p:nvSpPr>
+        <p:spPr>
+          <a:xfrm>
+            <a:off x="6598768" y="4041648"/>
+            <a:ext cx="4769968" cy="1078992"/>
+          </a:xfrm>
+          <a:prstGeom prst="rect">
+            <a:avLst/>
+          </a:prstGeom>
+          <a:noFill/>
+        </p:spPr>
+        <p:txBody>
+          <a:bodyPr wrap="square" lIns="0" rIns="0" tIns="0" bIns="0">
+            <a:spAutoFit/>
+          </a:bodyPr>
+          <a:lstStyle/>
+          <a:p>
+            <a:pPr>
+              <a:spcAft>
+                <a:spcPts val="600"/>
+              </a:spcAft>
+            </a:pPr>
+            <a:r>
+              <a:rPr sz="1200">
+                <a:solidFill>
+                  <a:srgbClr val="5B6472"/>
+                </a:solidFill>
+                <a:latin typeface="Calibri"/>
+              </a:rPr>
+              <a:t>New terminal window: </a:t>
+            </a:r>
+            <a:r>
+              <a:rPr sz="1200" b="1">
+                <a:solidFill>
+                  <a:srgbClr val="1C7293"/>
+                </a:solidFill>
+                <a:latin typeface="Consolas"/>
+              </a:rPr>
+              <a:t>cd ~/northline-course</a:t>
+            </a:r>
+            <a:r>
+              <a:rPr sz="1200">
+                <a:solidFill>
+                  <a:srgbClr val="5B6472"/>
+                </a:solidFill>
+                <a:latin typeface="Calibri"/>
+              </a:rPr>
+              <a:t> then </a:t>
+            </a:r>
+            <a:r>
+              <a:rPr sz="1200" b="1">
+                <a:solidFill>
+                  <a:srgbClr val="1C7293"/>
+                </a:solidFill>
+                <a:latin typeface="Consolas"/>
+              </a:rPr>
+              <a:t>uv run python -m northline.agent.server</a:t>
+            </a:r>
+            <a:r>
+              <a:rPr sz="1200">
+                <a:solidFill>
+                  <a:srgbClr val="5B6472"/>
+                </a:solidFill>
+                <a:latin typeface="Calibri"/>
+              </a:rPr>
+              <a:t>. Leave it open.</a:t>
+            </a:r>
+          </a:p>
+          <a:p>
+            <a:pPr>
+              <a:spcAft>
+                <a:spcPts val="600"/>
+              </a:spcAft>
+            </a:pPr>
+            <a:r>
+              <a:rPr sz="1200">
+                <a:solidFill>
+                  <a:srgbClr val="5B6472"/>
+                </a:solidFill>
+                <a:latin typeface="Calibri"/>
+              </a:rPr>
+              <a:t>Open </a:t>
+            </a:r>
+            <a:r>
+              <a:rPr sz="1200" b="1">
+                <a:solidFill>
+                  <a:srgbClr val="1C7293"/>
+                </a:solidFill>
+                <a:latin typeface="Consolas"/>
+              </a:rPr>
+              <a:t>127.0.0.1:8765</a:t>
+            </a:r>
+            <a:r>
+              <a:rPr sz="1200">
+                <a:solidFill>
+                  <a:srgbClr val="5B6472"/>
+                </a:solidFill>
+                <a:latin typeface="Calibri"/>
+              </a:rPr>
+              <a:t> and text the agent </a:t>
+            </a:r>
+            <a:r>
+              <a:rPr sz="1200" b="1">
+                <a:solidFill>
+                  <a:srgbClr val="5B6472"/>
+                </a:solidFill>
+                <a:latin typeface="Calibri"/>
+              </a:rPr>
+              <a:t>“my BP was 184/112”</a:t>
+            </a:r>
+            <a:r>
+              <a:rPr sz="1200">
+                <a:solidFill>
+                  <a:srgbClr val="5B6472"/>
+                </a:solidFill>
+                <a:latin typeface="Calibri"/>
+              </a:rPr>
+              <a:t>. Dashboard: </a:t>
+            </a:r>
+            <a:r>
+              <a:rPr sz="1200" b="1">
+                <a:solidFill>
+                  <a:srgbClr val="1C7293"/>
+                </a:solidFill>
+                <a:latin typeface="Consolas"/>
+              </a:rPr>
+              <a:t>127.0.0.1:8765/dashboard</a:t>
+            </a:r>
+          </a:p>
+        </p:txBody>
+      </p:sp>
+      <p:sp>
+        <p:nvSpPr>
+          <p:cNvPr id="16" name="Rounded Rectangle 15"/>
+          <p:cNvSpPr/>
+          <p:nvPr/>
+        </p:nvSpPr>
+        <p:spPr>
+          <a:xfrm>
+            <a:off x="548640" y="5440680"/>
+            <a:ext cx="11094415" cy="822960"/>
+          </a:xfrm>
+          <a:prstGeom prst="roundRect">
+            <a:avLst>
+              <a:gd name="adj" fmla="val 3400"/>
+            </a:avLst>
+          </a:prstGeom>
+          <a:solidFill>
+            <a:srgbClr val="065A82"/>
+          </a:solidFill>
+          <a:ln>
+            <a:noFill/>
+          </a:ln>
+          <a:effectLst/>
+        </p:spPr>
+        <p:style>
+          <a:lnRef idx="1">
+            <a:schemeClr val="accent1"/>
+          </a:lnRef>
+          <a:fillRef idx="3">
+            <a:schemeClr val="accent1"/>
+          </a:fillRef>
+          <a:effectRef idx="2">
+            <a:schemeClr val="accent1"/>
+          </a:effectRef>
+          <a:fontRef idx="minor">
+            <a:schemeClr val="lt1"/>
+          </a:fontRef>
+        </p:style>
+        <p:txBody>
+          <a:bodyPr rtlCol="0" anchor="ctr"/>
+          <a:lstStyle/>
+          <a:p>
+            <a:pPr algn="ctr"/>
+          </a:p>
+        </p:txBody>
+      </p:sp>
+      <p:sp>
+        <p:nvSpPr>
+          <p:cNvPr id="17" name="TextBox 16"/>
+          <p:cNvSpPr txBox="1"/>
+          <p:nvPr/>
+        </p:nvSpPr>
+        <p:spPr>
+          <a:xfrm>
+            <a:off x="868680" y="5568696"/>
+            <a:ext cx="7040880" cy="320040"/>
+          </a:xfrm>
+          <a:prstGeom prst="rect">
+            <a:avLst/>
+          </a:prstGeom>
+          <a:noFill/>
+        </p:spPr>
+        <p:txBody>
+          <a:bodyPr wrap="square" lIns="0" rIns="0" tIns="0" bIns="0">
+            <a:spAutoFit/>
+          </a:bodyPr>
+          <a:lstStyle/>
+          <a:p>
+            <a:r>
+              <a:rPr sz="1100" b="1">
+                <a:solidFill>
+                  <a:srgbClr val="CADCFC"/>
+                </a:solidFill>
+                <a:latin typeface="Calibri"/>
+              </a:rPr>
+              <a:t>The folder</a:t>
+            </a:r>
+          </a:p>
+        </p:txBody>
+      </p:sp>
+      <p:sp>
+        <p:nvSpPr>
+          <p:cNvPr id="18" name="TextBox 17"/>
+          <p:cNvSpPr txBox="1"/>
+          <p:nvPr/>
+        </p:nvSpPr>
+        <p:spPr>
+          <a:xfrm>
+            <a:off x="868680" y="5843016"/>
+            <a:ext cx="7040880" cy="411480"/>
+          </a:xfrm>
+          <a:prstGeom prst="rect">
+            <a:avLst/>
+          </a:prstGeom>
+          <a:noFill/>
+        </p:spPr>
+        <p:txBody>
+          <a:bodyPr wrap="square" lIns="0" rIns="0" tIns="0" bIns="0">
+            <a:spAutoFit/>
+          </a:bodyPr>
+          <a:lstStyle/>
+          <a:p>
+            <a:r>
+              <a:rPr sz="1800" b="1">
+                <a:solidFill>
+                  <a:srgbClr val="FFFFFF"/>
+                </a:solidFill>
+                <a:latin typeface="Consolas"/>
+              </a:rPr>
+              <a:t>github.com/anthonymorrisjohnson/northline-course</a:t>
+            </a:r>
+          </a:p>
+        </p:txBody>
+      </p:sp>
+      <p:sp>
+        <p:nvSpPr>
+          <p:cNvPr id="19" name="TextBox 18"/>
+          <p:cNvSpPr txBox="1"/>
+          <p:nvPr/>
+        </p:nvSpPr>
+        <p:spPr>
+          <a:xfrm>
+            <a:off x="8138160" y="5568696"/>
+            <a:ext cx="3200400" cy="320040"/>
+          </a:xfrm>
+          <a:prstGeom prst="rect">
+            <a:avLst/>
+          </a:prstGeom>
+          <a:noFill/>
+        </p:spPr>
+        <p:txBody>
+          <a:bodyPr wrap="square" lIns="0" rIns="0" tIns="0" bIns="0">
+            <a:spAutoFit/>
+          </a:bodyPr>
+          <a:lstStyle/>
+          <a:p>
+            <a:r>
+              <a:rPr sz="1100" b="1">
+                <a:solidFill>
+                  <a:srgbClr val="CADCFC"/>
+                </a:solidFill>
+                <a:latin typeface="Calibri"/>
+              </a:rPr>
+              <a:t>In the room</a:t>
+            </a:r>
+          </a:p>
+        </p:txBody>
+      </p:sp>
+      <p:sp>
+        <p:nvSpPr>
+          <p:cNvPr id="20" name="TextBox 19"/>
+          <p:cNvSpPr txBox="1"/>
+          <p:nvPr/>
+        </p:nvSpPr>
+        <p:spPr>
+          <a:xfrm>
+            <a:off x="8138160" y="5843016"/>
+            <a:ext cx="3200400" cy="411480"/>
+          </a:xfrm>
+          <a:prstGeom prst="rect">
+            <a:avLst/>
+          </a:prstGeom>
+          <a:noFill/>
+        </p:spPr>
+        <p:txBody>
+          <a:bodyPr wrap="square" lIns="0" rIns="0" tIns="0" bIns="0">
+            <a:spAutoFit/>
+          </a:bodyPr>
+          <a:lstStyle/>
+          <a:p>
+            <a:r>
+              <a:rPr sz="1500" b="1">
+                <a:solidFill>
+                  <a:srgbClr val="FFFFFF"/>
+                </a:solidFill>
+                <a:latin typeface="Consolas"/>
+              </a:rPr>
+              <a:t>/pm-run</a:t>
+            </a:r>
+            <a:r>
+              <a:rPr sz="1200">
+                <a:solidFill>
+                  <a:srgbClr val="CADCFC"/>
+                </a:solidFill>
+                <a:latin typeface="Calibri"/>
+              </a:rPr>
+              <a:t>   then   </a:t>
+            </a:r>
+            <a:r>
+              <a:rPr sz="1500" b="1">
+                <a:solidFill>
+                  <a:srgbClr val="FFFFFF"/>
+                </a:solidFill>
+                <a:latin typeface="Consolas"/>
+              </a:rPr>
+              <a:t>/deploy triage</a:t>
+            </a:r>
+          </a:p>
+        </p:txBody>
+      </p:sp>
+      <p:sp>
+        <p:nvSpPr>
+          <p:cNvPr id="21" name="TextBox 20"/>
+          <p:cNvSpPr txBox="1"/>
+          <p:nvPr/>
+        </p:nvSpPr>
+        <p:spPr>
+          <a:xfrm>
+            <a:off x="9265615" y="6400800"/>
+            <a:ext cx="2377440" cy="274320"/>
+          </a:xfrm>
+          <a:prstGeom prst="rect">
+            <a:avLst/>
+          </a:prstGeom>
+          <a:noFill/>
+        </p:spPr>
+        <p:txBody>
+          <a:bodyPr wrap="square" lIns="0" rIns="0" tIns="0" bIns="0">
+            <a:spAutoFit/>
+          </a:bodyPr>
+          <a:lstStyle/>
+          <a:p>
+            <a:pPr algn="r"/>
+            <a:r>
+              <a:rPr sz="1000">
+                <a:solidFill>
+                  <a:srgbClr val="5B6472"/>
+                </a:solidFill>
+                <a:latin typeface="Calibri"/>
+              </a:rPr>
+              <a:t>Northline Care  ·  1</a:t>
+            </a:r>
           </a:p>
         </p:txBody>
       </p:sp>
@@ -8568,6 +9746,10 @@
             </a:outerShdw>
           </a:effectLst>
         </p:spPr>
+        <p:txBody>
+          <a:bodyPr/>
+          <a:p/>
+        </p:txBody>
       </p:sp>
       <p:sp>
         <p:nvSpPr>
@@ -8750,6 +9932,10 @@
             <a:prstDash val="solid"/>
           </a:ln>
         </p:spPr>
+        <p:txBody>
+          <a:bodyPr/>
+          <a:p/>
+        </p:txBody>
       </p:sp>
       <p:sp>
         <p:nvSpPr>
@@ -8826,7 +10012,7 @@
                 <a:ea typeface="Calibri" pitchFamily="34" charset="-122"/>
                 <a:cs typeface="Calibri" pitchFamily="34" charset="-120"/>
               </a:rPr>
-              <a:t>Northline Care  ·  2</a:t>
+              <a:t>Northline Care  ·  3</a:t>
             </a:r>
             <a:endParaRPr lang="en-US" sz="1000" dirty="0"/>
           </a:p>
@@ -8968,6 +10154,10 @@
             <a:prstDash val="solid"/>
           </a:ln>
         </p:spPr>
+        <p:txBody>
+          <a:bodyPr/>
+          <a:p/>
+        </p:txBody>
       </p:sp>
       <p:sp>
         <p:nvSpPr>
@@ -9073,6 +10263,10 @@
             <a:prstDash val="solid"/>
           </a:ln>
         </p:spPr>
+        <p:txBody>
+          <a:bodyPr/>
+          <a:p/>
+        </p:txBody>
       </p:sp>
       <p:sp>
         <p:nvSpPr>
@@ -9175,6 +10369,10 @@
             <a:tailEnd type="triangle"/>
           </a:ln>
         </p:spPr>
+        <p:txBody>
+          <a:bodyPr/>
+          <a:p/>
+        </p:txBody>
       </p:sp>
       <p:sp>
         <p:nvSpPr>
@@ -9199,6 +10397,10 @@
             <a:tailEnd type="triangle"/>
           </a:ln>
         </p:spPr>
+        <p:txBody>
+          <a:bodyPr/>
+          <a:p/>
+        </p:txBody>
       </p:sp>
       <p:sp>
         <p:nvSpPr>
@@ -9226,6 +10428,10 @@
             <a:prstDash val="solid"/>
           </a:ln>
         </p:spPr>
+        <p:txBody>
+          <a:bodyPr/>
+          <a:p/>
+        </p:txBody>
       </p:sp>
       <p:sp>
         <p:nvSpPr>
@@ -9331,6 +10537,10 @@
             <a:prstDash val="solid"/>
           </a:ln>
         </p:spPr>
+        <p:txBody>
+          <a:bodyPr/>
+          <a:p/>
+        </p:txBody>
       </p:sp>
       <p:sp>
         <p:nvSpPr>
@@ -9433,6 +10643,10 @@
             <a:tailEnd type="triangle"/>
           </a:ln>
         </p:spPr>
+        <p:txBody>
+          <a:bodyPr/>
+          <a:p/>
+        </p:txBody>
       </p:sp>
       <p:sp>
         <p:nvSpPr>
@@ -9457,6 +10671,10 @@
             <a:tailEnd type="triangle"/>
           </a:ln>
         </p:spPr>
+        <p:txBody>
+          <a:bodyPr/>
+          <a:p/>
+        </p:txBody>
       </p:sp>
       <p:sp>
         <p:nvSpPr>
@@ -9480,6 +10698,10 @@
             <a:prstDash val="solid"/>
           </a:ln>
         </p:spPr>
+        <p:txBody>
+          <a:bodyPr/>
+          <a:p/>
+        </p:txBody>
       </p:sp>
       <p:sp>
         <p:nvSpPr>
@@ -9503,6 +10725,10 @@
             <a:prstDash val="solid"/>
           </a:ln>
         </p:spPr>
+        <p:txBody>
+          <a:bodyPr/>
+          <a:p/>
+        </p:txBody>
       </p:sp>
       <p:sp>
         <p:nvSpPr>
@@ -9530,6 +10756,10 @@
             <a:prstDash val="solid"/>
           </a:ln>
         </p:spPr>
+        <p:txBody>
+          <a:bodyPr/>
+          <a:p/>
+        </p:txBody>
       </p:sp>
       <p:sp>
         <p:nvSpPr>
@@ -9642,7 +10872,7 @@
                 <a:ea typeface="Calibri" pitchFamily="34" charset="-122"/>
                 <a:cs typeface="Calibri" pitchFamily="34" charset="-120"/>
               </a:rPr>
-              <a:t>Northline Care  ·  3</a:t>
+              <a:t>Northline Care  ·  4</a:t>
             </a:r>
             <a:endParaRPr lang="en-US" sz="1000" dirty="0"/>
           </a:p>
@@ -9784,6 +11014,10 @@
             <a:prstDash val="solid"/>
           </a:ln>
         </p:spPr>
+        <p:txBody>
+          <a:bodyPr/>
+          <a:p/>
+        </p:txBody>
       </p:sp>
       <p:sp>
         <p:nvSpPr>
@@ -9886,6 +11120,10 @@
             <a:tailEnd type="triangle"/>
           </a:ln>
         </p:spPr>
+        <p:txBody>
+          <a:bodyPr/>
+          <a:p/>
+        </p:txBody>
       </p:sp>
       <p:sp>
         <p:nvSpPr>
@@ -9913,6 +11151,10 @@
             <a:prstDash val="solid"/>
           </a:ln>
         </p:spPr>
+        <p:txBody>
+          <a:bodyPr/>
+          <a:p/>
+        </p:txBody>
       </p:sp>
       <p:sp>
         <p:nvSpPr>
@@ -10015,6 +11257,10 @@
             <a:tailEnd type="triangle"/>
           </a:ln>
         </p:spPr>
+        <p:txBody>
+          <a:bodyPr/>
+          <a:p/>
+        </p:txBody>
       </p:sp>
       <p:sp>
         <p:nvSpPr>
@@ -10042,6 +11288,10 @@
             <a:prstDash val="solid"/>
           </a:ln>
         </p:spPr>
+        <p:txBody>
+          <a:bodyPr/>
+          <a:p/>
+        </p:txBody>
       </p:sp>
       <p:sp>
         <p:nvSpPr>
@@ -10144,6 +11394,10 @@
             <a:tailEnd type="triangle"/>
           </a:ln>
         </p:spPr>
+        <p:txBody>
+          <a:bodyPr/>
+          <a:p/>
+        </p:txBody>
       </p:sp>
       <p:sp>
         <p:nvSpPr>
@@ -10171,6 +11425,10 @@
             <a:prstDash val="solid"/>
           </a:ln>
         </p:spPr>
+        <p:txBody>
+          <a:bodyPr/>
+          <a:p/>
+        </p:txBody>
       </p:sp>
       <p:sp>
         <p:nvSpPr>
@@ -10273,6 +11531,10 @@
             <a:tailEnd type="triangle"/>
           </a:ln>
         </p:spPr>
+        <p:txBody>
+          <a:bodyPr/>
+          <a:p/>
+        </p:txBody>
       </p:sp>
       <p:sp>
         <p:nvSpPr>
@@ -10300,6 +11562,10 @@
             <a:prstDash val="solid"/>
           </a:ln>
         </p:spPr>
+        <p:txBody>
+          <a:bodyPr/>
+          <a:p/>
+        </p:txBody>
       </p:sp>
       <p:sp>
         <p:nvSpPr>
@@ -10402,6 +11668,10 @@
             <a:tailEnd type="triangle"/>
           </a:ln>
         </p:spPr>
+        <p:txBody>
+          <a:bodyPr/>
+          <a:p/>
+        </p:txBody>
       </p:sp>
       <p:sp>
         <p:nvSpPr>
@@ -10429,6 +11699,10 @@
             <a:prstDash val="solid"/>
           </a:ln>
         </p:spPr>
+        <p:txBody>
+          <a:bodyPr/>
+          <a:p/>
+        </p:txBody>
       </p:sp>
       <p:sp>
         <p:nvSpPr>
@@ -10531,6 +11805,10 @@
             <a:tailEnd type="triangle"/>
           </a:ln>
         </p:spPr>
+        <p:txBody>
+          <a:bodyPr/>
+          <a:p/>
+        </p:txBody>
       </p:sp>
       <p:sp>
         <p:nvSpPr>
@@ -10558,6 +11836,10 @@
             <a:prstDash val="solid"/>
           </a:ln>
         </p:spPr>
+        <p:txBody>
+          <a:bodyPr/>
+          <a:p/>
+        </p:txBody>
       </p:sp>
       <p:sp>
         <p:nvSpPr>
@@ -10660,6 +11942,10 @@
             <a:tailEnd type="triangle"/>
           </a:ln>
         </p:spPr>
+        <p:txBody>
+          <a:bodyPr/>
+          <a:p/>
+        </p:txBody>
       </p:sp>
       <p:sp>
         <p:nvSpPr>
@@ -10687,6 +11973,10 @@
             <a:prstDash val="solid"/>
           </a:ln>
         </p:spPr>
+        <p:txBody>
+          <a:bodyPr/>
+          <a:p/>
+        </p:txBody>
       </p:sp>
       <p:sp>
         <p:nvSpPr>
@@ -10789,6 +12079,10 @@
             <a:tailEnd type="triangle"/>
           </a:ln>
         </p:spPr>
+        <p:txBody>
+          <a:bodyPr/>
+          <a:p/>
+        </p:txBody>
       </p:sp>
       <p:sp>
         <p:nvSpPr>
@@ -10816,6 +12110,10 @@
             <a:prstDash val="solid"/>
           </a:ln>
         </p:spPr>
+        <p:txBody>
+          <a:bodyPr/>
+          <a:p/>
+        </p:txBody>
       </p:sp>
       <p:sp>
         <p:nvSpPr>
@@ -10918,6 +12216,10 @@
             <a:tailEnd type="triangle"/>
           </a:ln>
         </p:spPr>
+        <p:txBody>
+          <a:bodyPr/>
+          <a:p/>
+        </p:txBody>
       </p:sp>
       <p:sp>
         <p:nvSpPr>
@@ -10945,6 +12247,10 @@
             <a:prstDash val="solid"/>
           </a:ln>
         </p:spPr>
+        <p:txBody>
+          <a:bodyPr/>
+          <a:p/>
+        </p:txBody>
       </p:sp>
       <p:sp>
         <p:nvSpPr>
@@ -11096,7 +12402,7 @@
                 <a:ea typeface="Calibri" pitchFamily="34" charset="-122"/>
                 <a:cs typeface="Calibri" pitchFamily="34" charset="-120"/>
               </a:rPr>
-              <a:t>Northline Care  ·  4</a:t>
+              <a:t>Northline Care  ·  5</a:t>
             </a:r>
             <a:endParaRPr lang="en-US" sz="1000" dirty="0"/>
           </a:p>
@@ -11238,6 +12544,10 @@
             <a:prstDash val="dash"/>
           </a:ln>
         </p:spPr>
+        <p:txBody>
+          <a:bodyPr/>
+          <a:p/>
+        </p:txBody>
       </p:sp>
       <p:sp>
         <p:nvSpPr>
@@ -11382,6 +12692,10 @@
             <a:prstDash val="dash"/>
           </a:ln>
         </p:spPr>
+        <p:txBody>
+          <a:bodyPr/>
+          <a:p/>
+        </p:txBody>
       </p:sp>
       <p:sp>
         <p:nvSpPr>
@@ -11526,6 +12840,10 @@
             <a:prstDash val="dash"/>
           </a:ln>
         </p:spPr>
+        <p:txBody>
+          <a:bodyPr/>
+          <a:p/>
+        </p:txBody>
       </p:sp>
       <p:sp>
         <p:nvSpPr>
@@ -11670,6 +12988,10 @@
             <a:prstDash val="dash"/>
           </a:ln>
         </p:spPr>
+        <p:txBody>
+          <a:bodyPr/>
+          <a:p/>
+        </p:txBody>
       </p:sp>
       <p:sp>
         <p:nvSpPr>
@@ -11821,7 +13143,7 @@
                 <a:ea typeface="Calibri" pitchFamily="34" charset="-122"/>
                 <a:cs typeface="Calibri" pitchFamily="34" charset="-120"/>
               </a:rPr>
-              <a:t>Northline Care  ·  5</a:t>
+              <a:t>Northline Care  ·  6</a:t>
             </a:r>
             <a:endParaRPr lang="en-US" sz="1000" dirty="0"/>
           </a:p>
@@ -11956,6 +13278,10 @@
           </a:solidFill>
           <a:ln/>
         </p:spPr>
+        <p:txBody>
+          <a:bodyPr/>
+          <a:p/>
+        </p:txBody>
       </p:sp>
       <p:sp>
         <p:nvSpPr>
@@ -12054,6 +13380,10 @@
           </a:solidFill>
           <a:ln/>
         </p:spPr>
+        <p:txBody>
+          <a:bodyPr/>
+          <a:p/>
+        </p:txBody>
       </p:sp>
       <p:sp>
         <p:nvSpPr>
@@ -12152,6 +13482,10 @@
           </a:solidFill>
           <a:ln/>
         </p:spPr>
+        <p:txBody>
+          <a:bodyPr/>
+          <a:p/>
+        </p:txBody>
       </p:sp>
       <p:sp>
         <p:nvSpPr>
@@ -12250,6 +13584,10 @@
           </a:solidFill>
           <a:ln/>
         </p:spPr>
+        <p:txBody>
+          <a:bodyPr/>
+          <a:p/>
+        </p:txBody>
       </p:sp>
       <p:sp>
         <p:nvSpPr>
@@ -12348,6 +13686,10 @@
           </a:solidFill>
           <a:ln/>
         </p:spPr>
+        <p:txBody>
+          <a:bodyPr/>
+          <a:p/>
+        </p:txBody>
       </p:sp>
       <p:sp>
         <p:nvSpPr>
@@ -12460,7 +13802,7 @@
                 <a:ea typeface="Calibri" pitchFamily="34" charset="-122"/>
                 <a:cs typeface="Calibri" pitchFamily="34" charset="-120"/>
               </a:rPr>
-              <a:t>Northline Care  ·  6</a:t>
+              <a:t>Northline Care  ·  7</a:t>
             </a:r>
             <a:endParaRPr lang="en-US" sz="1000" dirty="0"/>
           </a:p>
@@ -14739,7 +16081,7 @@
                 <a:ea typeface="Calibri" pitchFamily="34" charset="-122"/>
                 <a:cs typeface="Calibri" pitchFamily="34" charset="-120"/>
               </a:rPr>
-              <a:t>Northline Care  ·  7</a:t>
+              <a:t>Northline Care  ·  8</a:t>
             </a:r>
             <a:endParaRPr lang="en-US" sz="1000" dirty="0"/>
           </a:p>
@@ -20350,7 +21692,7 @@
                 <a:ea typeface="Calibri" pitchFamily="34" charset="-122"/>
                 <a:cs typeface="Calibri" pitchFamily="34" charset="-120"/>
               </a:rPr>
-              <a:t>Northline Care  ·  8</a:t>
+              <a:t>Northline Care  ·  9</a:t>
             </a:r>
             <a:endParaRPr lang="en-US" sz="1000" dirty="0"/>
           </a:p>
@@ -20593,7 +21935,7 @@
                 <a:ea typeface="Calibri" pitchFamily="34" charset="-122"/>
                 <a:cs typeface="Calibri" pitchFamily="34" charset="-120"/>
               </a:rPr>
-              <a:t>Northline Care  ·  9</a:t>
+              <a:t>Northline Care  ·  10</a:t>
             </a:r>
             <a:endParaRPr lang="en-US" sz="1000" dirty="0"/>
           </a:p>

</xml_diff>

<commit_message>
Simplify the setup slide to three steps; cue the rest from the front
Slide 1 now asks arrivals for three things only: Claude Code signed in,
the folder downloaded, /setup run to READY. The server window, the test
text, and the two commands move into the session plan's do-along, where
the presenter cues them at minute 25.

Co-Authored-By: Claude Fable 5.1 <noreply@anthropic.com>
Claude-Session: https://claude.ai/code/session_01Jo9JuGz9sGjCWMSFMqHMPx
</commit_message>
<xml_diff>
--- a/slides/deck.pptx
+++ b/slides/deck.pptx
@@ -3185,12 +3185,890 @@
 </file>
 
 <file path=ppt/slides/slide1.xml><?xml version="1.0" encoding="utf-8"?>
-<p:sld xmlns:a="http://schemas.openxmlformats.org/drawingml/2006/main" xmlns:r="http://schemas.openxmlformats.org/officeDocument/2006/relationships" xmlns:p="http://schemas.openxmlformats.org/presentationml/2006/main">
-  <p:cSld name="Slide 1">
+<p:sld xmlns:a="http://schemas.openxmlformats.org/drawingml/2006/main" xmlns:p="http://schemas.openxmlformats.org/presentationml/2006/main" xmlns:r="http://schemas.openxmlformats.org/officeDocument/2006/relationships">
+  <p:cSld>
     <p:bg>
       <p:bgPr>
         <a:solidFill>
-          <a:srgbClr val="21295C"/>
+          <a:srgbClr val="FFFFFF"/>
+        </a:solidFill>
+        <a:effectLst/>
+      </p:bgPr>
+    </p:bg>
+    <p:spTree>
+      <p:nvGrpSpPr>
+        <p:cNvPr id="1" name=""/>
+        <p:cNvGrpSpPr/>
+        <p:nvPr/>
+      </p:nvGrpSpPr>
+      <p:grpSpPr/>
+      <p:sp>
+        <p:nvSpPr>
+          <p:cNvPr id="2" name="TextBox 1"/>
+          <p:cNvSpPr txBox="1"/>
+          <p:nvPr/>
+        </p:nvSpPr>
+        <p:spPr>
+          <a:xfrm>
+            <a:off x="548640" y="164592"/>
+            <a:ext cx="11094415" cy="274320"/>
+          </a:xfrm>
+          <a:prstGeom prst="rect">
+            <a:avLst/>
+          </a:prstGeom>
+          <a:noFill/>
+        </p:spPr>
+        <p:txBody>
+          <a:bodyPr wrap="square" lIns="0" rIns="0" tIns="0" bIns="0">
+            <a:spAutoFit/>
+          </a:bodyPr>
+          <a:lstStyle/>
+          <a:p>
+            <a:r>
+              <a:rPr sz="1200" b="1">
+                <a:solidFill>
+                  <a:srgbClr val="1C7293"/>
+                </a:solidFill>
+                <a:latin typeface="Calibri"/>
+              </a:rPr>
+              <a:t>BEFORE WE START</a:t>
+            </a:r>
+          </a:p>
+        </p:txBody>
+      </p:sp>
+      <p:sp>
+        <p:nvSpPr>
+          <p:cNvPr id="3" name="TextBox 2"/>
+          <p:cNvSpPr txBox="1"/>
+          <p:nvPr/>
+        </p:nvSpPr>
+        <p:spPr>
+          <a:xfrm>
+            <a:off x="548640" y="411480"/>
+            <a:ext cx="11094415" cy="822960"/>
+          </a:xfrm>
+          <a:prstGeom prst="rect">
+            <a:avLst/>
+          </a:prstGeom>
+          <a:noFill/>
+        </p:spPr>
+        <p:txBody>
+          <a:bodyPr wrap="square" lIns="0" rIns="0" tIns="0" bIns="0">
+            <a:spAutoFit/>
+          </a:bodyPr>
+          <a:lstStyle/>
+          <a:p>
+            <a:r>
+              <a:rPr sz="3200" b="1">
+                <a:solidFill>
+                  <a:srgbClr val="1B1F27"/>
+                </a:solidFill>
+                <a:latin typeface="Cambria"/>
+              </a:rPr>
+              <a:t>Three things, then wait for us</a:t>
+            </a:r>
+          </a:p>
+        </p:txBody>
+      </p:sp>
+      <p:sp>
+        <p:nvSpPr>
+          <p:cNvPr id="4" name="Rounded Rectangle 3"/>
+          <p:cNvSpPr/>
+          <p:nvPr/>
+        </p:nvSpPr>
+        <p:spPr>
+          <a:xfrm>
+            <a:off x="548640" y="1554480"/>
+            <a:ext cx="3535680" cy="2743200"/>
+          </a:xfrm>
+          <a:prstGeom prst="roundRect">
+            <a:avLst>
+              <a:gd name="adj" fmla="val 3400"/>
+            </a:avLst>
+          </a:prstGeom>
+          <a:solidFill>
+            <a:srgbClr val="F4F7FA"/>
+          </a:solidFill>
+          <a:ln w="9525">
+            <a:solidFill>
+              <a:srgbClr val="D8E1EA"/>
+            </a:solidFill>
+          </a:ln>
+          <a:effectLst/>
+        </p:spPr>
+        <p:style>
+          <a:lnRef idx="1">
+            <a:schemeClr val="accent1"/>
+          </a:lnRef>
+          <a:fillRef idx="3">
+            <a:schemeClr val="accent1"/>
+          </a:fillRef>
+          <a:effectRef idx="2">
+            <a:schemeClr val="accent1"/>
+          </a:effectRef>
+          <a:fontRef idx="minor">
+            <a:schemeClr val="lt1"/>
+          </a:fontRef>
+        </p:style>
+        <p:txBody>
+          <a:bodyPr rtlCol="0" anchor="ctr"/>
+          <a:lstStyle/>
+          <a:p>
+            <a:pPr algn="ctr"/>
+          </a:p>
+        </p:txBody>
+      </p:sp>
+      <p:sp>
+        <p:nvSpPr>
+          <p:cNvPr id="5" name="TextBox 4"/>
+          <p:cNvSpPr txBox="1"/>
+          <p:nvPr/>
+        </p:nvSpPr>
+        <p:spPr>
+          <a:xfrm>
+            <a:off x="822960" y="1783080"/>
+            <a:ext cx="2987040" cy="457200"/>
+          </a:xfrm>
+          <a:prstGeom prst="rect">
+            <a:avLst/>
+          </a:prstGeom>
+          <a:noFill/>
+        </p:spPr>
+        <p:txBody>
+          <a:bodyPr wrap="square" lIns="0" rIns="0" tIns="0" bIns="0">
+            <a:spAutoFit/>
+          </a:bodyPr>
+          <a:lstStyle/>
+          <a:p>
+            <a:r>
+              <a:rPr sz="3000" b="1">
+                <a:solidFill>
+                  <a:srgbClr val="1C7293"/>
+                </a:solidFill>
+                <a:latin typeface="Cambria"/>
+              </a:rPr>
+              <a:t>1</a:t>
+            </a:r>
+          </a:p>
+        </p:txBody>
+      </p:sp>
+      <p:sp>
+        <p:nvSpPr>
+          <p:cNvPr id="6" name="TextBox 5"/>
+          <p:cNvSpPr txBox="1"/>
+          <p:nvPr/>
+        </p:nvSpPr>
+        <p:spPr>
+          <a:xfrm>
+            <a:off x="822960" y="2331720"/>
+            <a:ext cx="2987040" cy="411480"/>
+          </a:xfrm>
+          <a:prstGeom prst="rect">
+            <a:avLst/>
+          </a:prstGeom>
+          <a:noFill/>
+        </p:spPr>
+        <p:txBody>
+          <a:bodyPr wrap="square" lIns="0" rIns="0" tIns="0" bIns="0">
+            <a:spAutoFit/>
+          </a:bodyPr>
+          <a:lstStyle/>
+          <a:p>
+            <a:r>
+              <a:rPr sz="2000" b="1">
+                <a:solidFill>
+                  <a:srgbClr val="21295C"/>
+                </a:solidFill>
+                <a:latin typeface="Cambria"/>
+              </a:rPr>
+              <a:t>Claude Code</a:t>
+            </a:r>
+          </a:p>
+        </p:txBody>
+      </p:sp>
+      <p:sp>
+        <p:nvSpPr>
+          <p:cNvPr id="7" name="TextBox 6"/>
+          <p:cNvSpPr txBox="1"/>
+          <p:nvPr/>
+        </p:nvSpPr>
+        <p:spPr>
+          <a:xfrm>
+            <a:off x="822960" y="2834640"/>
+            <a:ext cx="2987040" cy="1371600"/>
+          </a:xfrm>
+          <a:prstGeom prst="rect">
+            <a:avLst/>
+          </a:prstGeom>
+          <a:noFill/>
+        </p:spPr>
+        <p:txBody>
+          <a:bodyPr wrap="square" lIns="0" rIns="0" tIns="0" bIns="0">
+            <a:spAutoFit/>
+          </a:bodyPr>
+          <a:lstStyle/>
+          <a:p>
+            <a:pPr>
+              <a:spcAft>
+                <a:spcPts val="800"/>
+              </a:spcAft>
+            </a:pPr>
+            <a:r>
+              <a:rPr sz="1400">
+                <a:solidFill>
+                  <a:srgbClr val="5B6472"/>
+                </a:solidFill>
+                <a:latin typeface="Calibri"/>
+              </a:rPr>
+              <a:t>Install it and sign in.</a:t>
+            </a:r>
+          </a:p>
+          <a:p>
+            <a:pPr>
+              <a:spcAft>
+                <a:spcPts val="800"/>
+              </a:spcAft>
+            </a:pPr>
+            <a:r>
+              <a:rPr sz="1400">
+                <a:solidFill>
+                  <a:srgbClr val="5B6472"/>
+                </a:solidFill>
+                <a:latin typeface="Calibri"/>
+              </a:rPr>
+              <a:t>Check: type </a:t>
+            </a:r>
+            <a:r>
+              <a:rPr sz="1300" b="1">
+                <a:solidFill>
+                  <a:srgbClr val="1C7293"/>
+                </a:solidFill>
+                <a:latin typeface="Consolas"/>
+              </a:rPr>
+              <a:t>claude --version</a:t>
+            </a:r>
+            <a:r>
+              <a:rPr sz="1400">
+                <a:solidFill>
+                  <a:srgbClr val="5B6472"/>
+                </a:solidFill>
+                <a:latin typeface="Calibri"/>
+              </a:rPr>
+              <a:t> in a terminal.</a:t>
+            </a:r>
+          </a:p>
+          <a:p>
+            <a:pPr>
+              <a:spcAft>
+                <a:spcPts val="800"/>
+              </a:spcAft>
+            </a:pPr>
+            <a:r>
+              <a:rPr sz="1100">
+                <a:solidFill>
+                  <a:srgbClr val="5B6472"/>
+                </a:solidFill>
+                <a:latin typeface="Calibri"/>
+              </a:rPr>
+              <a:t>Windows: use the native installer, not npm.</a:t>
+            </a:r>
+          </a:p>
+        </p:txBody>
+      </p:sp>
+      <p:sp>
+        <p:nvSpPr>
+          <p:cNvPr id="8" name="Rounded Rectangle 7"/>
+          <p:cNvSpPr/>
+          <p:nvPr/>
+        </p:nvSpPr>
+        <p:spPr>
+          <a:xfrm>
+            <a:off x="4328160" y="1554480"/>
+            <a:ext cx="3535680" cy="2743200"/>
+          </a:xfrm>
+          <a:prstGeom prst="roundRect">
+            <a:avLst>
+              <a:gd name="adj" fmla="val 3400"/>
+            </a:avLst>
+          </a:prstGeom>
+          <a:solidFill>
+            <a:srgbClr val="F4F7FA"/>
+          </a:solidFill>
+          <a:ln w="9525">
+            <a:solidFill>
+              <a:srgbClr val="D8E1EA"/>
+            </a:solidFill>
+          </a:ln>
+          <a:effectLst/>
+        </p:spPr>
+        <p:style>
+          <a:lnRef idx="1">
+            <a:schemeClr val="accent1"/>
+          </a:lnRef>
+          <a:fillRef idx="3">
+            <a:schemeClr val="accent1"/>
+          </a:fillRef>
+          <a:effectRef idx="2">
+            <a:schemeClr val="accent1"/>
+          </a:effectRef>
+          <a:fontRef idx="minor">
+            <a:schemeClr val="lt1"/>
+          </a:fontRef>
+        </p:style>
+        <p:txBody>
+          <a:bodyPr rtlCol="0" anchor="ctr"/>
+          <a:lstStyle/>
+          <a:p>
+            <a:pPr algn="ctr"/>
+          </a:p>
+        </p:txBody>
+      </p:sp>
+      <p:sp>
+        <p:nvSpPr>
+          <p:cNvPr id="9" name="TextBox 8"/>
+          <p:cNvSpPr txBox="1"/>
+          <p:nvPr/>
+        </p:nvSpPr>
+        <p:spPr>
+          <a:xfrm>
+            <a:off x="4602480" y="1783080"/>
+            <a:ext cx="2987040" cy="457200"/>
+          </a:xfrm>
+          <a:prstGeom prst="rect">
+            <a:avLst/>
+          </a:prstGeom>
+          <a:noFill/>
+        </p:spPr>
+        <p:txBody>
+          <a:bodyPr wrap="square" lIns="0" rIns="0" tIns="0" bIns="0">
+            <a:spAutoFit/>
+          </a:bodyPr>
+          <a:lstStyle/>
+          <a:p>
+            <a:r>
+              <a:rPr sz="3000" b="1">
+                <a:solidFill>
+                  <a:srgbClr val="1C7293"/>
+                </a:solidFill>
+                <a:latin typeface="Cambria"/>
+              </a:rPr>
+              <a:t>2</a:t>
+            </a:r>
+          </a:p>
+        </p:txBody>
+      </p:sp>
+      <p:sp>
+        <p:nvSpPr>
+          <p:cNvPr id="10" name="TextBox 9"/>
+          <p:cNvSpPr txBox="1"/>
+          <p:nvPr/>
+        </p:nvSpPr>
+        <p:spPr>
+          <a:xfrm>
+            <a:off x="4602480" y="2331720"/>
+            <a:ext cx="2987040" cy="411480"/>
+          </a:xfrm>
+          <a:prstGeom prst="rect">
+            <a:avLst/>
+          </a:prstGeom>
+          <a:noFill/>
+        </p:spPr>
+        <p:txBody>
+          <a:bodyPr wrap="square" lIns="0" rIns="0" tIns="0" bIns="0">
+            <a:spAutoFit/>
+          </a:bodyPr>
+          <a:lstStyle/>
+          <a:p>
+            <a:r>
+              <a:rPr sz="2000" b="1">
+                <a:solidFill>
+                  <a:srgbClr val="21295C"/>
+                </a:solidFill>
+                <a:latin typeface="Cambria"/>
+              </a:rPr>
+              <a:t>The folder</a:t>
+            </a:r>
+          </a:p>
+        </p:txBody>
+      </p:sp>
+      <p:sp>
+        <p:nvSpPr>
+          <p:cNvPr id="11" name="TextBox 10"/>
+          <p:cNvSpPr txBox="1"/>
+          <p:nvPr/>
+        </p:nvSpPr>
+        <p:spPr>
+          <a:xfrm>
+            <a:off x="4602480" y="2834640"/>
+            <a:ext cx="2987040" cy="1371600"/>
+          </a:xfrm>
+          <a:prstGeom prst="rect">
+            <a:avLst/>
+          </a:prstGeom>
+          <a:noFill/>
+        </p:spPr>
+        <p:txBody>
+          <a:bodyPr wrap="square" lIns="0" rIns="0" tIns="0" bIns="0">
+            <a:spAutoFit/>
+          </a:bodyPr>
+          <a:lstStyle/>
+          <a:p>
+            <a:pPr>
+              <a:spcAft>
+                <a:spcPts val="800"/>
+              </a:spcAft>
+            </a:pPr>
+            <a:r>
+              <a:rPr sz="1400">
+                <a:solidFill>
+                  <a:srgbClr val="5B6472"/>
+                </a:solidFill>
+                <a:latin typeface="Calibri"/>
+              </a:rPr>
+              <a:t>Open the link below, click </a:t>
+            </a:r>
+            <a:r>
+              <a:rPr sz="1400" b="1">
+                <a:solidFill>
+                  <a:srgbClr val="5B6472"/>
+                </a:solidFill>
+                <a:latin typeface="Calibri"/>
+              </a:rPr>
+              <a:t>Code → Download ZIP</a:t>
+            </a:r>
+            <a:r>
+              <a:rPr sz="1400">
+                <a:solidFill>
+                  <a:srgbClr val="5B6472"/>
+                </a:solidFill>
+                <a:latin typeface="Calibri"/>
+              </a:rPr>
+              <a:t>.</a:t>
+            </a:r>
+          </a:p>
+          <a:p>
+            <a:pPr>
+              <a:spcAft>
+                <a:spcPts val="800"/>
+              </a:spcAft>
+            </a:pPr>
+            <a:r>
+              <a:rPr sz="1400">
+                <a:solidFill>
+                  <a:srgbClr val="5B6472"/>
+                </a:solidFill>
+                <a:latin typeface="Calibri"/>
+              </a:rPr>
+              <a:t>Unzip it into your home folder.</a:t>
+            </a:r>
+          </a:p>
+        </p:txBody>
+      </p:sp>
+      <p:sp>
+        <p:nvSpPr>
+          <p:cNvPr id="12" name="Rounded Rectangle 11"/>
+          <p:cNvSpPr/>
+          <p:nvPr/>
+        </p:nvSpPr>
+        <p:spPr>
+          <a:xfrm>
+            <a:off x="8107680" y="1554480"/>
+            <a:ext cx="3535680" cy="2743200"/>
+          </a:xfrm>
+          <a:prstGeom prst="roundRect">
+            <a:avLst>
+              <a:gd name="adj" fmla="val 3400"/>
+            </a:avLst>
+          </a:prstGeom>
+          <a:solidFill>
+            <a:srgbClr val="F4F7FA"/>
+          </a:solidFill>
+          <a:ln w="9525">
+            <a:solidFill>
+              <a:srgbClr val="D8E1EA"/>
+            </a:solidFill>
+          </a:ln>
+          <a:effectLst/>
+        </p:spPr>
+        <p:style>
+          <a:lnRef idx="1">
+            <a:schemeClr val="accent1"/>
+          </a:lnRef>
+          <a:fillRef idx="3">
+            <a:schemeClr val="accent1"/>
+          </a:fillRef>
+          <a:effectRef idx="2">
+            <a:schemeClr val="accent1"/>
+          </a:effectRef>
+          <a:fontRef idx="minor">
+            <a:schemeClr val="lt1"/>
+          </a:fontRef>
+        </p:style>
+        <p:txBody>
+          <a:bodyPr rtlCol="0" anchor="ctr"/>
+          <a:lstStyle/>
+          <a:p>
+            <a:pPr algn="ctr"/>
+          </a:p>
+        </p:txBody>
+      </p:sp>
+      <p:sp>
+        <p:nvSpPr>
+          <p:cNvPr id="13" name="TextBox 12"/>
+          <p:cNvSpPr txBox="1"/>
+          <p:nvPr/>
+        </p:nvSpPr>
+        <p:spPr>
+          <a:xfrm>
+            <a:off x="8382000" y="1783080"/>
+            <a:ext cx="2987040" cy="457200"/>
+          </a:xfrm>
+          <a:prstGeom prst="rect">
+            <a:avLst/>
+          </a:prstGeom>
+          <a:noFill/>
+        </p:spPr>
+        <p:txBody>
+          <a:bodyPr wrap="square" lIns="0" rIns="0" tIns="0" bIns="0">
+            <a:spAutoFit/>
+          </a:bodyPr>
+          <a:lstStyle/>
+          <a:p>
+            <a:r>
+              <a:rPr sz="3000" b="1">
+                <a:solidFill>
+                  <a:srgbClr val="1C7293"/>
+                </a:solidFill>
+                <a:latin typeface="Cambria"/>
+              </a:rPr>
+              <a:t>3</a:t>
+            </a:r>
+          </a:p>
+        </p:txBody>
+      </p:sp>
+      <p:sp>
+        <p:nvSpPr>
+          <p:cNvPr id="14" name="TextBox 13"/>
+          <p:cNvSpPr txBox="1"/>
+          <p:nvPr/>
+        </p:nvSpPr>
+        <p:spPr>
+          <a:xfrm>
+            <a:off x="8382000" y="2331720"/>
+            <a:ext cx="2987040" cy="411480"/>
+          </a:xfrm>
+          <a:prstGeom prst="rect">
+            <a:avLst/>
+          </a:prstGeom>
+          <a:noFill/>
+        </p:spPr>
+        <p:txBody>
+          <a:bodyPr wrap="square" lIns="0" rIns="0" tIns="0" bIns="0">
+            <a:spAutoFit/>
+          </a:bodyPr>
+          <a:lstStyle/>
+          <a:p>
+            <a:r>
+              <a:rPr sz="2000" b="1">
+                <a:solidFill>
+                  <a:srgbClr val="21295C"/>
+                </a:solidFill>
+                <a:latin typeface="Cambria"/>
+              </a:rPr>
+              <a:t>/setup</a:t>
+            </a:r>
+          </a:p>
+        </p:txBody>
+      </p:sp>
+      <p:sp>
+        <p:nvSpPr>
+          <p:cNvPr id="15" name="TextBox 14"/>
+          <p:cNvSpPr txBox="1"/>
+          <p:nvPr/>
+        </p:nvSpPr>
+        <p:spPr>
+          <a:xfrm>
+            <a:off x="8382000" y="2834640"/>
+            <a:ext cx="2987040" cy="1371600"/>
+          </a:xfrm>
+          <a:prstGeom prst="rect">
+            <a:avLst/>
+          </a:prstGeom>
+          <a:noFill/>
+        </p:spPr>
+        <p:txBody>
+          <a:bodyPr wrap="square" lIns="0" rIns="0" tIns="0" bIns="0">
+            <a:spAutoFit/>
+          </a:bodyPr>
+          <a:lstStyle/>
+          <a:p>
+            <a:pPr>
+              <a:spcAft>
+                <a:spcPts val="800"/>
+              </a:spcAft>
+            </a:pPr>
+            <a:r>
+              <a:rPr sz="1400">
+                <a:solidFill>
+                  <a:srgbClr val="5B6472"/>
+                </a:solidFill>
+                <a:latin typeface="Calibri"/>
+              </a:rPr>
+              <a:t>In a terminal: </a:t>
+            </a:r>
+            <a:r>
+              <a:rPr sz="1300" b="1">
+                <a:solidFill>
+                  <a:srgbClr val="1C7293"/>
+                </a:solidFill>
+                <a:latin typeface="Consolas"/>
+              </a:rPr>
+              <a:t>cd ~/northline-course</a:t>
+            </a:r>
+          </a:p>
+          <a:p>
+            <a:pPr>
+              <a:spcAft>
+                <a:spcPts val="800"/>
+              </a:spcAft>
+            </a:pPr>
+            <a:r>
+              <a:rPr sz="1400">
+                <a:solidFill>
+                  <a:srgbClr val="5B6472"/>
+                </a:solidFill>
+                <a:latin typeface="Calibri"/>
+              </a:rPr>
+              <a:t>then </a:t>
+            </a:r>
+            <a:r>
+              <a:rPr sz="1300" b="1">
+                <a:solidFill>
+                  <a:srgbClr val="1C7293"/>
+                </a:solidFill>
+                <a:latin typeface="Consolas"/>
+              </a:rPr>
+              <a:t>claude</a:t>
+            </a:r>
+            <a:r>
+              <a:rPr sz="1400">
+                <a:solidFill>
+                  <a:srgbClr val="5B6472"/>
+                </a:solidFill>
+                <a:latin typeface="Calibri"/>
+              </a:rPr>
+              <a:t>, then type </a:t>
+            </a:r>
+            <a:r>
+              <a:rPr sz="1300" b="1">
+                <a:solidFill>
+                  <a:srgbClr val="1C7293"/>
+                </a:solidFill>
+                <a:latin typeface="Consolas"/>
+              </a:rPr>
+              <a:t>/setup</a:t>
+            </a:r>
+          </a:p>
+          <a:p>
+            <a:pPr>
+              <a:spcAft>
+                <a:spcPts val="800"/>
+              </a:spcAft>
+            </a:pPr>
+            <a:r>
+              <a:rPr sz="1400">
+                <a:solidFill>
+                  <a:srgbClr val="5B6472"/>
+                </a:solidFill>
+                <a:latin typeface="Calibri"/>
+              </a:rPr>
+              <a:t>Do what it says. Stop at </a:t>
+            </a:r>
+            <a:r>
+              <a:rPr sz="1300" b="1">
+                <a:solidFill>
+                  <a:srgbClr val="1C7293"/>
+                </a:solidFill>
+                <a:latin typeface="Consolas"/>
+              </a:rPr>
+              <a:t>READY</a:t>
+            </a:r>
+            <a:r>
+              <a:rPr sz="1400">
+                <a:solidFill>
+                  <a:srgbClr val="5B6472"/>
+                </a:solidFill>
+                <a:latin typeface="Calibri"/>
+              </a:rPr>
+              <a:t>.</a:t>
+            </a:r>
+          </a:p>
+        </p:txBody>
+      </p:sp>
+      <p:sp>
+        <p:nvSpPr>
+          <p:cNvPr id="16" name="Rounded Rectangle 15"/>
+          <p:cNvSpPr/>
+          <p:nvPr/>
+        </p:nvSpPr>
+        <p:spPr>
+          <a:xfrm>
+            <a:off x="548640" y="4754880"/>
+            <a:ext cx="11094415" cy="1005840"/>
+          </a:xfrm>
+          <a:prstGeom prst="roundRect">
+            <a:avLst>
+              <a:gd name="adj" fmla="val 3400"/>
+            </a:avLst>
+          </a:prstGeom>
+          <a:solidFill>
+            <a:srgbClr val="065A82"/>
+          </a:solidFill>
+          <a:ln>
+            <a:noFill/>
+          </a:ln>
+          <a:effectLst/>
+        </p:spPr>
+        <p:style>
+          <a:lnRef idx="1">
+            <a:schemeClr val="accent1"/>
+          </a:lnRef>
+          <a:fillRef idx="3">
+            <a:schemeClr val="accent1"/>
+          </a:fillRef>
+          <a:effectRef idx="2">
+            <a:schemeClr val="accent1"/>
+          </a:effectRef>
+          <a:fontRef idx="minor">
+            <a:schemeClr val="lt1"/>
+          </a:fontRef>
+        </p:style>
+        <p:txBody>
+          <a:bodyPr rtlCol="0" anchor="ctr"/>
+          <a:lstStyle/>
+          <a:p>
+            <a:pPr algn="ctr"/>
+          </a:p>
+        </p:txBody>
+      </p:sp>
+      <p:sp>
+        <p:nvSpPr>
+          <p:cNvPr id="17" name="TextBox 16"/>
+          <p:cNvSpPr txBox="1"/>
+          <p:nvPr/>
+        </p:nvSpPr>
+        <p:spPr>
+          <a:xfrm>
+            <a:off x="868680" y="4882896"/>
+            <a:ext cx="10454320" cy="320040"/>
+          </a:xfrm>
+          <a:prstGeom prst="rect">
+            <a:avLst/>
+          </a:prstGeom>
+          <a:noFill/>
+        </p:spPr>
+        <p:txBody>
+          <a:bodyPr wrap="square" lIns="0" rIns="0" tIns="0" bIns="0">
+            <a:spAutoFit/>
+          </a:bodyPr>
+          <a:lstStyle/>
+          <a:p>
+            <a:r>
+              <a:rPr sz="1100" b="1">
+                <a:solidFill>
+                  <a:srgbClr val="CADCFC"/>
+                </a:solidFill>
+                <a:latin typeface="Calibri"/>
+              </a:rPr>
+              <a:t>The folder</a:t>
+            </a:r>
+          </a:p>
+        </p:txBody>
+      </p:sp>
+      <p:sp>
+        <p:nvSpPr>
+          <p:cNvPr id="18" name="TextBox 17"/>
+          <p:cNvSpPr txBox="1"/>
+          <p:nvPr/>
+        </p:nvSpPr>
+        <p:spPr>
+          <a:xfrm>
+            <a:off x="868680" y="5157216"/>
+            <a:ext cx="10454320" cy="457200"/>
+          </a:xfrm>
+          <a:prstGeom prst="rect">
+            <a:avLst/>
+          </a:prstGeom>
+          <a:noFill/>
+        </p:spPr>
+        <p:txBody>
+          <a:bodyPr wrap="square" lIns="0" rIns="0" tIns="0" bIns="0">
+            <a:spAutoFit/>
+          </a:bodyPr>
+          <a:lstStyle/>
+          <a:p>
+            <a:r>
+              <a:rPr sz="2200" b="1">
+                <a:solidFill>
+                  <a:srgbClr val="FFFFFF"/>
+                </a:solidFill>
+                <a:latin typeface="Consolas"/>
+              </a:rPr>
+              <a:t>github.com/anthonymorrisjohnson/northline-course</a:t>
+            </a:r>
+          </a:p>
+        </p:txBody>
+      </p:sp>
+      <p:sp>
+        <p:nvSpPr>
+          <p:cNvPr id="19" name="TextBox 18"/>
+          <p:cNvSpPr txBox="1"/>
+          <p:nvPr/>
+        </p:nvSpPr>
+        <p:spPr>
+          <a:xfrm>
+            <a:off x="9265615" y="6400800"/>
+            <a:ext cx="2377440" cy="274320"/>
+          </a:xfrm>
+          <a:prstGeom prst="rect">
+            <a:avLst/>
+          </a:prstGeom>
+          <a:noFill/>
+        </p:spPr>
+        <p:txBody>
+          <a:bodyPr wrap="square" lIns="0" rIns="0" tIns="0" bIns="0">
+            <a:spAutoFit/>
+          </a:bodyPr>
+          <a:lstStyle/>
+          <a:p>
+            <a:pPr algn="r"/>
+            <a:r>
+              <a:rPr sz="1000">
+                <a:solidFill>
+                  <a:srgbClr val="5B6472"/>
+                </a:solidFill>
+                <a:latin typeface="Calibri"/>
+              </a:rPr>
+              <a:t>Northline Care  ·  1</a:t>
+            </a:r>
+          </a:p>
+        </p:txBody>
+      </p:sp>
+    </p:spTree>
+  </p:cSld>
+  <p:clrMapOvr>
+    <a:masterClrMapping/>
+  </p:clrMapOvr>
+</p:sld>
+</file>
+
+<file path=ppt/slides/slide10.xml><?xml version="1.0" encoding="utf-8"?>
+<p:sld xmlns:a="http://schemas.openxmlformats.org/drawingml/2006/main" xmlns:r="http://schemas.openxmlformats.org/officeDocument/2006/relationships" xmlns:p="http://schemas.openxmlformats.org/presentationml/2006/main">
+  <p:cSld name="Slide 9">
+    <p:bg>
+      <p:bgPr>
+        <a:solidFill>
+          <a:srgbClr val="FFFFFF"/>
         </a:solidFill>
       </p:bgPr>
     </p:bg>
@@ -3216,8 +4094,8 @@
         </p:nvSpPr>
         <p:spPr>
           <a:xfrm>
-            <a:off x="548640" y="2148840"/>
-            <a:ext cx="11094415" cy="1371600"/>
+            <a:off x="548640" y="164592"/>
+            <a:ext cx="11094415" cy="274320"/>
           </a:xfrm>
           <a:prstGeom prst="rect">
             <a:avLst/>
@@ -3233,17 +4111,17 @@
               <a:buNone/>
             </a:pPr>
             <a:r>
-              <a:rPr lang="en-US" sz="4400" b="1" dirty="0">
+              <a:rPr lang="en-US" sz="1200" b="1" spc="200" kern="0" dirty="0">
                 <a:solidFill>
-                  <a:srgbClr val="FFFFFF"/>
+                  <a:srgbClr val="1C7293"/>
                 </a:solidFill>
-                <a:latin typeface="Cambria" pitchFamily="34" charset="0"/>
-                <a:ea typeface="Cambria" pitchFamily="34" charset="-122"/>
-                <a:cs typeface="Cambria" pitchFamily="34" charset="-120"/>
+                <a:latin typeface="Calibri" pitchFamily="34" charset="0"/>
+                <a:ea typeface="Calibri" pitchFamily="34" charset="-122"/>
+                <a:cs typeface="Calibri" pitchFamily="34" charset="-120"/>
               </a:rPr>
-              <a:t>MOVING THE BOTTLENECK, LIVE</a:t>
+              <a:t>TREND, WEEKS 1-52</a:t>
             </a:r>
-            <a:endParaRPr lang="en-US" sz="4400" dirty="0"/>
+            <a:endParaRPr lang="en-US" sz="1200" dirty="0"/>
           </a:p>
         </p:txBody>
       </p:sp>
@@ -3255,8 +4133,8 @@
         </p:nvSpPr>
         <p:spPr>
           <a:xfrm>
-            <a:off x="548640" y="3246120"/>
-            <a:ext cx="11094415" cy="548640"/>
+            <a:off x="548640" y="411480"/>
+            <a:ext cx="11094415" cy="822960"/>
           </a:xfrm>
           <a:prstGeom prst="rect">
             <a:avLst/>
@@ -3272,61 +4150,46 @@
               <a:buNone/>
             </a:pPr>
             <a:r>
-              <a:rPr lang="en-US" sz="1800" i="1" dirty="0">
+              <a:rPr lang="en-US" sz="3200" b="1" dirty="0">
                 <a:solidFill>
-                  <a:srgbClr val="CADCFC"/>
+                  <a:srgbClr val="1B1F27"/>
                 </a:solidFill>
-                <a:latin typeface="Calibri" pitchFamily="34" charset="0"/>
-                <a:ea typeface="Calibri" pitchFamily="34" charset="-122"/>
-                <a:cs typeface="Calibri" pitchFamily="34" charset="-120"/>
+                <a:latin typeface="Cambria" pitchFamily="34" charset="0"/>
+                <a:ea typeface="Cambria" pitchFamily="34" charset="-122"/>
+                <a:cs typeface="Cambria" pitchFamily="34" charset="-120"/>
               </a:rPr>
-              <a:t>Northline Care — AI, operations, and the business model underneath it</a:t>
+              <a:t>AI lets you pivot fast</a:t>
             </a:r>
-            <a:endParaRPr lang="en-US" sz="1800" dirty="0"/>
+            <a:endParaRPr lang="en-US" sz="3200" dirty="0"/>
           </a:p>
         </p:txBody>
       </p:sp>
-      <p:sp>
-        <p:nvSpPr>
-          <p:cNvPr id="4" name="Shape 2"/>
-          <p:cNvSpPr/>
+      <p:graphicFrame>
+        <p:nvGraphicFramePr>
+          <p:cNvPr id="4" name="Chart 0" descr=""/>
+          <p:cNvGraphicFramePr/>
+          <p:nvPr/>
+        </p:nvGraphicFramePr>
+        <p:xfrm>
+          <a:off x="548640" y="1508760"/>
+          <a:ext cx="11094415" cy="3840480"/>
+        </p:xfrm>
+        <a:graphic xmlns:a="http://schemas.openxmlformats.org/drawingml/2006/main">
+          <a:graphicData uri="http://schemas.openxmlformats.org/drawingml/2006/chart">
+            <c:chart xmlns:c="http://schemas.openxmlformats.org/drawingml/2006/chart" r:id="rId1"/>
+          </a:graphicData>
+        </a:graphic>
+      </p:graphicFrame>
+      <p:sp>
+        <p:nvSpPr>
+          <p:cNvPr id="5" name="Text 2"/>
+          <p:cNvSpPr txBox="1"/>
           <p:nvPr/>
         </p:nvSpPr>
         <p:spPr>
           <a:xfrm>
-            <a:off x="548640" y="4206240"/>
-            <a:ext cx="3454298" cy="1463040"/>
-          </a:xfrm>
-          <a:prstGeom prst="roundRect">
-            <a:avLst>
-              <a:gd name="adj" fmla="val 5000"/>
-            </a:avLst>
-          </a:prstGeom>
-          <a:solidFill>
-            <a:srgbClr val="1B2350"/>
-          </a:solidFill>
-          <a:ln w="12700">
-            <a:solidFill>
-              <a:srgbClr val="1C7293"/>
-            </a:solidFill>
-            <a:prstDash val="solid"/>
-          </a:ln>
-        </p:spPr>
-        <p:txBody>
-          <a:bodyPr/>
-          <a:p/>
-        </p:txBody>
-      </p:sp>
-      <p:sp>
-        <p:nvSpPr>
-          <p:cNvPr id="5" name="Text 3"/>
-          <p:cNvSpPr txBox="1"/>
-          <p:nvPr/>
-        </p:nvSpPr>
-        <p:spPr>
-          <a:xfrm>
-            <a:off x="777240" y="4370832"/>
-            <a:ext cx="2997098" cy="502920"/>
+            <a:off x="548640" y="5486400"/>
+            <a:ext cx="11094415" cy="292608"/>
           </a:xfrm>
           <a:prstGeom prst="rect">
             <a:avLst/>
@@ -3342,30 +4205,30 @@
               <a:buNone/>
             </a:pPr>
             <a:r>
-              <a:rPr lang="en-US" sz="2400" b="1" dirty="0">
+              <a:rPr lang="en-US" sz="1250" i="1" dirty="0">
                 <a:solidFill>
-                  <a:srgbClr val="CADCFC"/>
+                  <a:srgbClr val="5B6472"/>
                 </a:solidFill>
-                <a:latin typeface="Cambria" pitchFamily="34" charset="0"/>
-                <a:ea typeface="Cambria" pitchFamily="34" charset="-122"/>
-                <a:cs typeface="Cambria" pitchFamily="34" charset="-120"/>
+                <a:latin typeface="Calibri" pitchFamily="34" charset="0"/>
+                <a:ea typeface="Calibri" pitchFamily="34" charset="-122"/>
+                <a:cs typeface="Calibri" pitchFamily="34" charset="-120"/>
               </a:rPr>
-              <a:t>75 minutes</a:t>
+              <a:t>Median nurse response: 31.1h → 4.0h — but 90.0 urgent cases a week are now missed.</a:t>
             </a:r>
-            <a:endParaRPr lang="en-US" sz="2400" dirty="0"/>
+            <a:endParaRPr lang="en-US" sz="1250" dirty="0"/>
           </a:p>
         </p:txBody>
       </p:sp>
       <p:sp>
         <p:nvSpPr>
-          <p:cNvPr id="6" name="Text 4"/>
+          <p:cNvPr id="6" name="Text 3"/>
           <p:cNvSpPr txBox="1"/>
           <p:nvPr/>
         </p:nvSpPr>
         <p:spPr>
           <a:xfrm>
-            <a:off x="777240" y="4892040"/>
-            <a:ext cx="2997098" cy="685800"/>
+            <a:off x="548640" y="5806440"/>
+            <a:ext cx="11094415" cy="292608"/>
           </a:xfrm>
           <a:prstGeom prst="rect">
             <a:avLst/>
@@ -3381,61 +4244,30 @@
               <a:buNone/>
             </a:pPr>
             <a:r>
-              <a:rPr lang="en-US" sz="1250" dirty="0">
+              <a:rPr lang="en-US" sz="1200" i="1" dirty="0">
                 <a:solidFill>
-                  <a:srgbClr val="FFFFFF"/>
+                  <a:srgbClr val="1C7293"/>
                 </a:solidFill>
                 <a:latin typeface="Calibri" pitchFamily="34" charset="0"/>
                 <a:ea typeface="Calibri" pitchFamily="34" charset="-122"/>
                 <a:cs typeface="Calibri" pitchFamily="34" charset="-120"/>
               </a:rPr>
-              <a:t>paper case, live tools, a board meeting</a:t>
+              <a:t>Numbers from a triage deployment made with the 190/115 decisions on this laptop; your room's numbers will differ. Show the live dashboard.</a:t>
             </a:r>
-            <a:endParaRPr lang="en-US" sz="1250" dirty="0"/>
+            <a:endParaRPr lang="en-US" sz="1200" dirty="0"/>
           </a:p>
         </p:txBody>
       </p:sp>
       <p:sp>
         <p:nvSpPr>
-          <p:cNvPr id="7" name="Shape 5"/>
-          <p:cNvSpPr/>
+          <p:cNvPr id="7" name="Text 4"/>
+          <p:cNvSpPr txBox="1"/>
           <p:nvPr/>
         </p:nvSpPr>
         <p:spPr>
           <a:xfrm>
-            <a:off x="4368698" y="4206240"/>
-            <a:ext cx="3454298" cy="1463040"/>
-          </a:xfrm>
-          <a:prstGeom prst="roundRect">
-            <a:avLst>
-              <a:gd name="adj" fmla="val 5000"/>
-            </a:avLst>
-          </a:prstGeom>
-          <a:solidFill>
-            <a:srgbClr val="1B2350"/>
-          </a:solidFill>
-          <a:ln w="12700">
-            <a:solidFill>
-              <a:srgbClr val="1C7293"/>
-            </a:solidFill>
-            <a:prstDash val="solid"/>
-          </a:ln>
-        </p:spPr>
-        <p:txBody>
-          <a:bodyPr/>
-          <a:p/>
-        </p:txBody>
-      </p:sp>
-      <p:sp>
-        <p:nvSpPr>
-          <p:cNvPr id="8" name="Text 6"/>
-          <p:cNvSpPr txBox="1"/>
-          <p:nvPr/>
-        </p:nvSpPr>
-        <p:spPr>
-          <a:xfrm>
-            <a:off x="4597298" y="4370832"/>
-            <a:ext cx="2997098" cy="502920"/>
+            <a:off x="9265615" y="6400800"/>
+            <a:ext cx="2377440" cy="274320"/>
           </a:xfrm>
           <a:prstGeom prst="rect">
             <a:avLst/>
@@ -3447,169 +4279,21 @@
           <a:bodyPr wrap="square" lIns="0" tIns="0" rIns="0" bIns="0" rtlCol="0" anchor="ctr"/>
           <a:lstStyle/>
           <a:p>
-            <a:pPr indent="0" marL="0">
+            <a:pPr algn="r" indent="0" marL="0">
               <a:buNone/>
             </a:pPr>
             <a:r>
-              <a:rPr lang="en-US" sz="2400" b="1" dirty="0">
+              <a:rPr lang="en-US" sz="1000" dirty="0">
                 <a:solidFill>
-                  <a:srgbClr val="CADCFC"/>
-                </a:solidFill>
-                <a:latin typeface="Cambria" pitchFamily="34" charset="0"/>
-                <a:ea typeface="Cambria" pitchFamily="34" charset="-122"/>
-                <a:cs typeface="Cambria" pitchFamily="34" charset="-120"/>
-              </a:rPr>
-              <a:t>Two roles</a:t>
-            </a:r>
-            <a:endParaRPr lang="en-US" sz="2400" dirty="0"/>
-          </a:p>
-        </p:txBody>
-      </p:sp>
-      <p:sp>
-        <p:nvSpPr>
-          <p:cNvPr id="9" name="Text 7"/>
-          <p:cNvSpPr txBox="1"/>
-          <p:nvPr/>
-        </p:nvSpPr>
-        <p:spPr>
-          <a:xfrm>
-            <a:off x="4597298" y="4892040"/>
-            <a:ext cx="2997098" cy="685800"/>
-          </a:xfrm>
-          <a:prstGeom prst="rect">
-            <a:avLst/>
-          </a:prstGeom>
-          <a:noFill/>
-          <a:ln/>
-        </p:spPr>
-        <p:txBody>
-          <a:bodyPr wrap="square" lIns="0" tIns="0" rIns="0" bIns="0" rtlCol="0" anchor="ctr"/>
-          <a:lstStyle/>
-          <a:p>
-            <a:pPr indent="0" marL="0">
-              <a:buNone/>
-            </a:pPr>
-            <a:r>
-              <a:rPr lang="en-US" sz="1250" dirty="0">
-                <a:solidFill>
-                  <a:srgbClr val="FFFFFF"/>
+                  <a:srgbClr val="5B6472"/>
                 </a:solidFill>
                 <a:latin typeface="Calibri" pitchFamily="34" charset="0"/>
                 <a:ea typeface="Calibri" pitchFamily="34" charset="-122"/>
                 <a:cs typeface="Calibri" pitchFamily="34" charset="-120"/>
               </a:rPr>
-              <a:t>Room reads and asks; Screen drives the machine</a:t>
+              <a:t>Northline Care  ·  10</a:t>
             </a:r>
-            <a:endParaRPr lang="en-US" sz="1250" dirty="0"/>
-          </a:p>
-        </p:txBody>
-      </p:sp>
-      <p:sp>
-        <p:nvSpPr>
-          <p:cNvPr id="10" name="Shape 8"/>
-          <p:cNvSpPr/>
-          <p:nvPr/>
-        </p:nvSpPr>
-        <p:spPr>
-          <a:xfrm>
-            <a:off x="8188757" y="4206240"/>
-            <a:ext cx="3454298" cy="1463040"/>
-          </a:xfrm>
-          <a:prstGeom prst="roundRect">
-            <a:avLst>
-              <a:gd name="adj" fmla="val 5000"/>
-            </a:avLst>
-          </a:prstGeom>
-          <a:solidFill>
-            <a:srgbClr val="1B2350"/>
-          </a:solidFill>
-          <a:ln w="12700">
-            <a:solidFill>
-              <a:srgbClr val="1C7293"/>
-            </a:solidFill>
-            <a:prstDash val="solid"/>
-          </a:ln>
-        </p:spPr>
-        <p:txBody>
-          <a:bodyPr/>
-          <a:p/>
-        </p:txBody>
-      </p:sp>
-      <p:sp>
-        <p:nvSpPr>
-          <p:cNvPr id="11" name="Text 9"/>
-          <p:cNvSpPr txBox="1"/>
-          <p:nvPr/>
-        </p:nvSpPr>
-        <p:spPr>
-          <a:xfrm>
-            <a:off x="8417357" y="4370832"/>
-            <a:ext cx="2997098" cy="502920"/>
-          </a:xfrm>
-          <a:prstGeom prst="rect">
-            <a:avLst/>
-          </a:prstGeom>
-          <a:noFill/>
-          <a:ln/>
-        </p:spPr>
-        <p:txBody>
-          <a:bodyPr wrap="square" lIns="0" tIns="0" rIns="0" bIns="0" rtlCol="0" anchor="ctr"/>
-          <a:lstStyle/>
-          <a:p>
-            <a:pPr indent="0" marL="0">
-              <a:buNone/>
-            </a:pPr>
-            <a:r>
-              <a:rPr lang="en-US" sz="2400" b="1" dirty="0">
-                <a:solidFill>
-                  <a:srgbClr val="CADCFC"/>
-                </a:solidFill>
-                <a:latin typeface="Cambria" pitchFamily="34" charset="0"/>
-                <a:ea typeface="Cambria" pitchFamily="34" charset="-122"/>
-                <a:cs typeface="Cambria" pitchFamily="34" charset="-120"/>
-              </a:rPr>
-              <a:t>Two commands</a:t>
-            </a:r>
-            <a:endParaRPr lang="en-US" sz="2400" dirty="0"/>
-          </a:p>
-        </p:txBody>
-      </p:sp>
-      <p:sp>
-        <p:nvSpPr>
-          <p:cNvPr id="12" name="Text 10"/>
-          <p:cNvSpPr txBox="1"/>
-          <p:nvPr/>
-        </p:nvSpPr>
-        <p:spPr>
-          <a:xfrm>
-            <a:off x="8417357" y="4892040"/>
-            <a:ext cx="2997098" cy="685800"/>
-          </a:xfrm>
-          <a:prstGeom prst="rect">
-            <a:avLst/>
-          </a:prstGeom>
-          <a:noFill/>
-          <a:ln/>
-        </p:spPr>
-        <p:txBody>
-          <a:bodyPr wrap="square" lIns="0" tIns="0" rIns="0" bIns="0" rtlCol="0" anchor="ctr"/>
-          <a:lstStyle/>
-          <a:p>
-            <a:pPr indent="0" marL="0">
-              <a:buNone/>
-            </a:pPr>
-            <a:r>
-              <a:rPr lang="en-US" sz="1250" dirty="0">
-                <a:solidFill>
-                  <a:srgbClr val="FFFFFF"/>
-                </a:solidFill>
-                <a:latin typeface="Calibri" pitchFamily="34" charset="0"/>
-                <a:ea typeface="Calibri" pitchFamily="34" charset="-122"/>
-                <a:cs typeface="Calibri" pitchFamily="34" charset="-120"/>
-              </a:rPr>
-              <a:t>/pm-run and /deploy triage, all session</a:t>
-            </a:r>
-            <a:endParaRPr lang="en-US" sz="1250" dirty="0"/>
+            <a:endParaRPr lang="en-US" sz="1000" dirty="0"/>
           </a:p>
         </p:txBody>
       </p:sp>
@@ -3621,7 +4305,7 @@
 </p:sld>
 </file>
 
-<file path=ppt/slides/slide10.xml><?xml version="1.0" encoding="utf-8"?>
+<file path=ppt/slides/slide11.xml><?xml version="1.0" encoding="utf-8"?>
 <p:sld xmlns:a="http://schemas.openxmlformats.org/drawingml/2006/main" xmlns:r="http://schemas.openxmlformats.org/officeDocument/2006/relationships" xmlns:p="http://schemas.openxmlformats.org/presentationml/2006/main">
   <p:cSld name="Slide 10">
     <p:bg>
@@ -4870,7 +5554,7 @@
 </p:sld>
 </file>
 
-<file path=ppt/slides/slide11.xml><?xml version="1.0" encoding="utf-8"?>
+<file path=ppt/slides/slide12.xml><?xml version="1.0" encoding="utf-8"?>
 <p:sld xmlns:a="http://schemas.openxmlformats.org/drawingml/2006/main" xmlns:r="http://schemas.openxmlformats.org/officeDocument/2006/relationships" xmlns:p="http://schemas.openxmlformats.org/presentationml/2006/main">
   <p:cSld name="Slide 11">
     <p:bg>
@@ -5113,7 +5797,7 @@
 </p:sld>
 </file>
 
-<file path=ppt/slides/slide12.xml><?xml version="1.0" encoding="utf-8"?>
+<file path=ppt/slides/slide13.xml><?xml version="1.0" encoding="utf-8"?>
 <p:sld xmlns:a="http://schemas.openxmlformats.org/drawingml/2006/main" xmlns:r="http://schemas.openxmlformats.org/officeDocument/2006/relationships" xmlns:p="http://schemas.openxmlformats.org/presentationml/2006/main">
   <p:cSld name="Slide 12">
     <p:bg>
@@ -7353,7 +8037,7 @@
 </p:sld>
 </file>
 
-<file path=ppt/slides/slide13.xml><?xml version="1.0" encoding="utf-8"?>
+<file path=ppt/slides/slide14.xml><?xml version="1.0" encoding="utf-8"?>
 <p:sld xmlns:a="http://schemas.openxmlformats.org/drawingml/2006/main" xmlns:r="http://schemas.openxmlformats.org/officeDocument/2006/relationships" xmlns:p="http://schemas.openxmlformats.org/presentationml/2006/main">
   <p:cSld name="Slide 13">
     <p:bg>
@@ -7607,7 +8291,7 @@
 </p:sld>
 </file>
 
-<file path=ppt/slides/slide14.xml><?xml version="1.0" encoding="utf-8"?>
+<file path=ppt/slides/slide15.xml><?xml version="1.0" encoding="utf-8"?>
 <p:sld xmlns:a="http://schemas.openxmlformats.org/drawingml/2006/main" xmlns:r="http://schemas.openxmlformats.org/officeDocument/2006/relationships" xmlns:p="http://schemas.openxmlformats.org/presentationml/2006/main">
   <p:cSld name="Slide 14">
     <p:bg>
@@ -8482,15 +9166,14 @@
 </p:sld>
 </file>
 
-<file path=ppt/slides/slide15.xml><?xml version="1.0" encoding="utf-8"?>
-<p:sld xmlns:a="http://schemas.openxmlformats.org/drawingml/2006/main" xmlns:p="http://schemas.openxmlformats.org/presentationml/2006/main" xmlns:r="http://schemas.openxmlformats.org/officeDocument/2006/relationships">
-  <p:cSld>
+<file path=ppt/slides/slide2.xml><?xml version="1.0" encoding="utf-8"?>
+<p:sld xmlns:a="http://schemas.openxmlformats.org/drawingml/2006/main" xmlns:r="http://schemas.openxmlformats.org/officeDocument/2006/relationships" xmlns:p="http://schemas.openxmlformats.org/presentationml/2006/main">
+  <p:cSld name="Slide 1">
     <p:bg>
       <p:bgPr>
         <a:solidFill>
-          <a:srgbClr val="FFFFFF"/>
+          <a:srgbClr val="21295C"/>
         </a:solidFill>
-        <a:effectLst/>
       </p:bgPr>
     </p:bg>
     <p:spTree>
@@ -8499,1107 +9182,416 @@
         <p:cNvGrpSpPr/>
         <p:nvPr/>
       </p:nvGrpSpPr>
-      <p:grpSpPr/>
-      <p:sp>
-        <p:nvSpPr>
-          <p:cNvPr id="2" name="TextBox 1"/>
+      <p:grpSpPr>
+        <a:xfrm>
+          <a:off x="0" y="0"/>
+          <a:ext cx="0" cy="0"/>
+          <a:chOff x="0" y="0"/>
+          <a:chExt cx="0" cy="0"/>
+        </a:xfrm>
+      </p:grpSpPr>
+      <p:sp>
+        <p:nvSpPr>
+          <p:cNvPr id="2" name="Text 0"/>
           <p:cNvSpPr txBox="1"/>
           <p:nvPr/>
         </p:nvSpPr>
         <p:spPr>
           <a:xfrm>
-            <a:off x="548640" y="164592"/>
-            <a:ext cx="11094415" cy="274320"/>
+            <a:off x="548640" y="2148840"/>
+            <a:ext cx="11094415" cy="1371600"/>
           </a:xfrm>
           <a:prstGeom prst="rect">
             <a:avLst/>
           </a:prstGeom>
           <a:noFill/>
+          <a:ln/>
         </p:spPr>
         <p:txBody>
-          <a:bodyPr wrap="square" lIns="0" rIns="0" tIns="0" bIns="0">
-            <a:spAutoFit/>
-          </a:bodyPr>
+          <a:bodyPr wrap="square" lIns="0" tIns="0" rIns="0" bIns="0" rtlCol="0" anchor="ctr"/>
           <a:lstStyle/>
           <a:p>
+            <a:pPr algn="l" indent="0" marL="0">
+              <a:buNone/>
+            </a:pPr>
             <a:r>
-              <a:rPr sz="1200" b="1">
+              <a:rPr lang="en-US" sz="4400" b="1" dirty="0">
                 <a:solidFill>
-                  <a:srgbClr val="1C7293"/>
+                  <a:srgbClr val="FFFFFF"/>
                 </a:solidFill>
-                <a:latin typeface="Calibri"/>
+                <a:latin typeface="Cambria" pitchFamily="34" charset="0"/>
+                <a:ea typeface="Cambria" pitchFamily="34" charset="-122"/>
+                <a:cs typeface="Cambria" pitchFamily="34" charset="-120"/>
               </a:rPr>
-              <a:t>BEFORE WE START  ·  ABOUT 10 MINUTES</a:t>
+              <a:t>MOVING THE BOTTLENECK, LIVE</a:t>
             </a:r>
+            <a:endParaRPr lang="en-US" sz="4400" dirty="0"/>
           </a:p>
         </p:txBody>
       </p:sp>
       <p:sp>
         <p:nvSpPr>
-          <p:cNvPr id="3" name="TextBox 2"/>
+          <p:cNvPr id="3" name="Text 1"/>
           <p:cNvSpPr txBox="1"/>
           <p:nvPr/>
         </p:nvSpPr>
         <p:spPr>
           <a:xfrm>
-            <a:off x="548640" y="411480"/>
-            <a:ext cx="11094415" cy="822960"/>
+            <a:off x="548640" y="3246120"/>
+            <a:ext cx="11094415" cy="548640"/>
           </a:xfrm>
           <a:prstGeom prst="rect">
             <a:avLst/>
           </a:prstGeom>
           <a:noFill/>
+          <a:ln/>
         </p:spPr>
         <p:txBody>
-          <a:bodyPr wrap="square" lIns="0" rIns="0" tIns="0" bIns="0">
-            <a:spAutoFit/>
-          </a:bodyPr>
+          <a:bodyPr wrap="square" lIns="0" tIns="0" rIns="0" bIns="0" rtlCol="0" anchor="ctr"/>
           <a:lstStyle/>
           <a:p>
+            <a:pPr algn="l" indent="0" marL="0">
+              <a:buNone/>
+            </a:pPr>
             <a:r>
-              <a:rPr sz="3200" b="1">
+              <a:rPr lang="en-US" sz="1800" i="1" dirty="0">
                 <a:solidFill>
-                  <a:srgbClr val="1B1F27"/>
+                  <a:srgbClr val="CADCFC"/>
                 </a:solidFill>
-                <a:latin typeface="Cambria"/>
+                <a:latin typeface="Calibri" pitchFamily="34" charset="0"/>
+                <a:ea typeface="Calibri" pitchFamily="34" charset="-122"/>
+                <a:cs typeface="Calibri" pitchFamily="34" charset="-120"/>
               </a:rPr>
-              <a:t>Get set up</a:t>
+              <a:t>Northline Care — AI, operations, and the business model underneath it</a:t>
             </a:r>
+            <a:endParaRPr lang="en-US" sz="1800" dirty="0"/>
           </a:p>
         </p:txBody>
       </p:sp>
       <p:sp>
         <p:nvSpPr>
-          <p:cNvPr id="4" name="Rounded Rectangle 3"/>
+          <p:cNvPr id="4" name="Shape 2"/>
           <p:cNvSpPr/>
           <p:nvPr/>
         </p:nvSpPr>
         <p:spPr>
           <a:xfrm>
-            <a:off x="548640" y="1417320"/>
-            <a:ext cx="5318608" cy="1783080"/>
+            <a:off x="548640" y="4206240"/>
+            <a:ext cx="3454298" cy="1463040"/>
           </a:xfrm>
           <a:prstGeom prst="roundRect">
             <a:avLst>
-              <a:gd name="adj" fmla="val 3400"/>
+              <a:gd name="adj" fmla="val 5000"/>
             </a:avLst>
           </a:prstGeom>
           <a:solidFill>
-            <a:srgbClr val="F4F7FA"/>
+            <a:srgbClr val="1B2350"/>
           </a:solidFill>
-          <a:ln w="9525">
+          <a:ln w="12700">
             <a:solidFill>
-              <a:srgbClr val="D8E1EA"/>
+              <a:srgbClr val="1C7293"/>
             </a:solidFill>
+            <a:prstDash val="solid"/>
           </a:ln>
-          <a:effectLst/>
         </p:spPr>
-        <p:style>
-          <a:lnRef idx="1">
-            <a:schemeClr val="accent1"/>
-          </a:lnRef>
-          <a:fillRef idx="3">
-            <a:schemeClr val="accent1"/>
-          </a:fillRef>
-          <a:effectRef idx="2">
-            <a:schemeClr val="accent1"/>
-          </a:effectRef>
-          <a:fontRef idx="minor">
-            <a:schemeClr val="lt1"/>
-          </a:fontRef>
-        </p:style>
-        <p:txBody>
-          <a:bodyPr rtlCol="0" anchor="ctr"/>
-          <a:lstStyle/>
-          <a:p>
-            <a:pPr algn="ctr"/>
-          </a:p>
-        </p:txBody>
-      </p:sp>
-      <p:sp>
-        <p:nvSpPr>
-          <p:cNvPr id="5" name="TextBox 4"/>
+        <p:txBody>
+          <a:bodyPr/>
+          <a:p/>
+        </p:txBody>
+      </p:sp>
+      <p:sp>
+        <p:nvSpPr>
+          <p:cNvPr id="5" name="Text 3"/>
           <p:cNvSpPr txBox="1"/>
           <p:nvPr/>
         </p:nvSpPr>
         <p:spPr>
           <a:xfrm>
-            <a:off x="822960" y="1618488"/>
-            <a:ext cx="4769968" cy="365760"/>
+            <a:off x="777240" y="4370832"/>
+            <a:ext cx="2997098" cy="502920"/>
           </a:xfrm>
           <a:prstGeom prst="rect">
             <a:avLst/>
           </a:prstGeom>
           <a:noFill/>
+          <a:ln/>
         </p:spPr>
         <p:txBody>
-          <a:bodyPr wrap="square" lIns="0" rIns="0" tIns="0" bIns="0">
-            <a:spAutoFit/>
-          </a:bodyPr>
+          <a:bodyPr wrap="square" lIns="0" tIns="0" rIns="0" bIns="0" rtlCol="0" anchor="ctr"/>
           <a:lstStyle/>
           <a:p>
+            <a:pPr indent="0" marL="0">
+              <a:buNone/>
+            </a:pPr>
             <a:r>
-              <a:rPr sz="1700" b="1">
+              <a:rPr lang="en-US" sz="2400" b="1" dirty="0">
                 <a:solidFill>
-                  <a:srgbClr val="21295C"/>
+                  <a:srgbClr val="CADCFC"/>
                 </a:solidFill>
-                <a:latin typeface="Cambria"/>
+                <a:latin typeface="Cambria" pitchFamily="34" charset="0"/>
+                <a:ea typeface="Cambria" pitchFamily="34" charset="-122"/>
+                <a:cs typeface="Cambria" pitchFamily="34" charset="-120"/>
               </a:rPr>
-              <a:t>1. Claude Code, signed in</a:t>
+              <a:t>75 minutes</a:t>
             </a:r>
+            <a:endParaRPr lang="en-US" sz="2400" dirty="0"/>
           </a:p>
         </p:txBody>
       </p:sp>
       <p:sp>
         <p:nvSpPr>
-          <p:cNvPr id="6" name="TextBox 5"/>
+          <p:cNvPr id="6" name="Text 4"/>
           <p:cNvSpPr txBox="1"/>
           <p:nvPr/>
         </p:nvSpPr>
         <p:spPr>
           <a:xfrm>
-            <a:off x="822960" y="2029968"/>
-            <a:ext cx="4769968" cy="1078992"/>
+            <a:off x="777240" y="4892040"/>
+            <a:ext cx="2997098" cy="685800"/>
           </a:xfrm>
           <a:prstGeom prst="rect">
             <a:avLst/>
           </a:prstGeom>
           <a:noFill/>
+          <a:ln/>
         </p:spPr>
         <p:txBody>
-          <a:bodyPr wrap="square" lIns="0" rIns="0" tIns="0" bIns="0">
-            <a:spAutoFit/>
-          </a:bodyPr>
+          <a:bodyPr wrap="square" lIns="0" tIns="0" rIns="0" bIns="0" rtlCol="0" anchor="ctr"/>
           <a:lstStyle/>
           <a:p>
-            <a:pPr>
-              <a:spcAft>
-                <a:spcPts val="600"/>
-              </a:spcAft>
+            <a:pPr indent="0" marL="0">
+              <a:buNone/>
             </a:pPr>
             <a:r>
-              <a:rPr sz="1200">
+              <a:rPr lang="en-US" sz="1250" dirty="0">
                 <a:solidFill>
-                  <a:srgbClr val="5B6472"/>
+                  <a:srgbClr val="FFFFFF"/>
                 </a:solidFill>
-                <a:latin typeface="Calibri"/>
+                <a:latin typeface="Calibri" pitchFamily="34" charset="0"/>
+                <a:ea typeface="Calibri" pitchFamily="34" charset="-122"/>
+                <a:cs typeface="Calibri" pitchFamily="34" charset="-120"/>
               </a:rPr>
-              <a:t>Install the command-line tool and sign in with your Claude account. In a terminal, </a:t>
+              <a:t>paper case, live tools, a board meeting</a:t>
             </a:r>
-            <a:r>
-              <a:rPr sz="1200" b="1">
-                <a:solidFill>
-                  <a:srgbClr val="1C7293"/>
-                </a:solidFill>
-                <a:latin typeface="Consolas"/>
-              </a:rPr>
-              <a:t>claude --version</a:t>
-            </a:r>
-            <a:r>
-              <a:rPr sz="1200">
-                <a:solidFill>
-                  <a:srgbClr val="5B6472"/>
-                </a:solidFill>
-                <a:latin typeface="Calibri"/>
-              </a:rPr>
-              <a:t> should print a version.</a:t>
-            </a:r>
+            <a:endParaRPr lang="en-US" sz="1250" dirty="0"/>
           </a:p>
-          <a:p>
-            <a:pPr>
-              <a:spcAft>
-                <a:spcPts val="600"/>
-              </a:spcAft>
-            </a:pPr>
-            <a:r>
-              <a:rPr sz="1200">
-                <a:solidFill>
-                  <a:srgbClr val="5B6472"/>
-                </a:solidFill>
-                <a:latin typeface="Calibri"/>
-              </a:rPr>
-              <a:t>Windows: use the native installer, not npm. Use PowerShell for the commands below.</a:t>
-            </a:r>
-          </a:p>
-        </p:txBody>
-      </p:sp>
-      <p:sp>
-        <p:nvSpPr>
-          <p:cNvPr id="7" name="Rounded Rectangle 6"/>
+        </p:txBody>
+      </p:sp>
+      <p:sp>
+        <p:nvSpPr>
+          <p:cNvPr id="7" name="Shape 5"/>
           <p:cNvSpPr/>
           <p:nvPr/>
         </p:nvSpPr>
         <p:spPr>
           <a:xfrm>
-            <a:off x="6324448" y="1417320"/>
-            <a:ext cx="5318608" cy="1783080"/>
+            <a:off x="4368698" y="4206240"/>
+            <a:ext cx="3454298" cy="1463040"/>
           </a:xfrm>
           <a:prstGeom prst="roundRect">
             <a:avLst>
-              <a:gd name="adj" fmla="val 3400"/>
+              <a:gd name="adj" fmla="val 5000"/>
             </a:avLst>
           </a:prstGeom>
           <a:solidFill>
-            <a:srgbClr val="F4F7FA"/>
+            <a:srgbClr val="1B2350"/>
           </a:solidFill>
-          <a:ln w="9525">
+          <a:ln w="12700">
             <a:solidFill>
-              <a:srgbClr val="D8E1EA"/>
+              <a:srgbClr val="1C7293"/>
             </a:solidFill>
+            <a:prstDash val="solid"/>
           </a:ln>
-          <a:effectLst/>
         </p:spPr>
-        <p:style>
-          <a:lnRef idx="1">
-            <a:schemeClr val="accent1"/>
-          </a:lnRef>
-          <a:fillRef idx="3">
-            <a:schemeClr val="accent1"/>
-          </a:fillRef>
-          <a:effectRef idx="2">
-            <a:schemeClr val="accent1"/>
-          </a:effectRef>
-          <a:fontRef idx="minor">
-            <a:schemeClr val="lt1"/>
-          </a:fontRef>
-        </p:style>
-        <p:txBody>
-          <a:bodyPr rtlCol="0" anchor="ctr"/>
-          <a:lstStyle/>
-          <a:p>
-            <a:pPr algn="ctr"/>
-          </a:p>
-        </p:txBody>
-      </p:sp>
-      <p:sp>
-        <p:nvSpPr>
-          <p:cNvPr id="8" name="TextBox 7"/>
+        <p:txBody>
+          <a:bodyPr/>
+          <a:p/>
+        </p:txBody>
+      </p:sp>
+      <p:sp>
+        <p:nvSpPr>
+          <p:cNvPr id="8" name="Text 6"/>
           <p:cNvSpPr txBox="1"/>
           <p:nvPr/>
         </p:nvSpPr>
         <p:spPr>
           <a:xfrm>
-            <a:off x="6598768" y="1618488"/>
-            <a:ext cx="4769968" cy="365760"/>
+            <a:off x="4597298" y="4370832"/>
+            <a:ext cx="2997098" cy="502920"/>
           </a:xfrm>
           <a:prstGeom prst="rect">
             <a:avLst/>
           </a:prstGeom>
           <a:noFill/>
+          <a:ln/>
         </p:spPr>
         <p:txBody>
-          <a:bodyPr wrap="square" lIns="0" rIns="0" tIns="0" bIns="0">
-            <a:spAutoFit/>
-          </a:bodyPr>
+          <a:bodyPr wrap="square" lIns="0" tIns="0" rIns="0" bIns="0" rtlCol="0" anchor="ctr"/>
           <a:lstStyle/>
           <a:p>
+            <a:pPr indent="0" marL="0">
+              <a:buNone/>
+            </a:pPr>
             <a:r>
-              <a:rPr sz="1700" b="1">
+              <a:rPr lang="en-US" sz="2400" b="1" dirty="0">
                 <a:solidFill>
-                  <a:srgbClr val="21295C"/>
+                  <a:srgbClr val="CADCFC"/>
                 </a:solidFill>
-                <a:latin typeface="Cambria"/>
+                <a:latin typeface="Cambria" pitchFamily="34" charset="0"/>
+                <a:ea typeface="Cambria" pitchFamily="34" charset="-122"/>
+                <a:cs typeface="Cambria" pitchFamily="34" charset="-120"/>
               </a:rPr>
-              <a:t>2. The course folder</a:t>
+              <a:t>Two roles</a:t>
             </a:r>
+            <a:endParaRPr lang="en-US" sz="2400" dirty="0"/>
           </a:p>
         </p:txBody>
       </p:sp>
       <p:sp>
         <p:nvSpPr>
-          <p:cNvPr id="9" name="TextBox 8"/>
+          <p:cNvPr id="9" name="Text 7"/>
           <p:cNvSpPr txBox="1"/>
           <p:nvPr/>
         </p:nvSpPr>
         <p:spPr>
           <a:xfrm>
-            <a:off x="6598768" y="2029968"/>
-            <a:ext cx="4769968" cy="1078992"/>
+            <a:off x="4597298" y="4892040"/>
+            <a:ext cx="2997098" cy="685800"/>
           </a:xfrm>
           <a:prstGeom prst="rect">
             <a:avLst/>
           </a:prstGeom>
           <a:noFill/>
+          <a:ln/>
         </p:spPr>
         <p:txBody>
-          <a:bodyPr wrap="square" lIns="0" rIns="0" tIns="0" bIns="0">
-            <a:spAutoFit/>
-          </a:bodyPr>
+          <a:bodyPr wrap="square" lIns="0" tIns="0" rIns="0" bIns="0" rtlCol="0" anchor="ctr"/>
           <a:lstStyle/>
           <a:p>
-            <a:pPr>
-              <a:spcAft>
-                <a:spcPts val="600"/>
-              </a:spcAft>
+            <a:pPr indent="0" marL="0">
+              <a:buNone/>
             </a:pPr>
             <a:r>
-              <a:rPr sz="1200">
+              <a:rPr lang="en-US" sz="1250" dirty="0">
                 <a:solidFill>
-                  <a:srgbClr val="5B6472"/>
+                  <a:srgbClr val="FFFFFF"/>
                 </a:solidFill>
-                <a:latin typeface="Calibri"/>
+                <a:latin typeface="Calibri" pitchFamily="34" charset="0"/>
+                <a:ea typeface="Calibri" pitchFamily="34" charset="-122"/>
+                <a:cs typeface="Calibri" pitchFamily="34" charset="-120"/>
               </a:rPr>
-              <a:t>Open the link at the bottom, click </a:t>
+              <a:t>Room reads and asks; Screen drives the machine</a:t>
             </a:r>
-            <a:r>
-              <a:rPr sz="1200" b="1">
-                <a:solidFill>
-                  <a:srgbClr val="5B6472"/>
-                </a:solidFill>
-                <a:latin typeface="Calibri"/>
-              </a:rPr>
-              <a:t>Code → Download ZIP</a:t>
-            </a:r>
-            <a:r>
-              <a:rPr sz="1200">
-                <a:solidFill>
-                  <a:srgbClr val="5B6472"/>
-                </a:solidFill>
-                <a:latin typeface="Calibri"/>
-              </a:rPr>
-              <a:t>, and unzip it into your home folder. It should be called </a:t>
-            </a:r>
-            <a:r>
-              <a:rPr sz="1200" b="1">
-                <a:solidFill>
-                  <a:srgbClr val="1C7293"/>
-                </a:solidFill>
-                <a:latin typeface="Consolas"/>
-              </a:rPr>
-              <a:t>northline-course</a:t>
-            </a:r>
-            <a:r>
-              <a:rPr sz="1200">
-                <a:solidFill>
-                  <a:srgbClr val="5B6472"/>
-                </a:solidFill>
-                <a:latin typeface="Calibri"/>
-              </a:rPr>
-              <a:t>.</a:t>
-            </a:r>
+            <a:endParaRPr lang="en-US" sz="1250" dirty="0"/>
           </a:p>
-          <a:p>
-            <a:pPr>
-              <a:spcAft>
-                <a:spcPts val="600"/>
-              </a:spcAft>
-            </a:pPr>
-            <a:r>
-              <a:rPr sz="1200">
-                <a:solidFill>
-                  <a:srgbClr val="5B6472"/>
-                </a:solidFill>
-                <a:latin typeface="Calibri"/>
-              </a:rPr>
-              <a:t>Or, if you have git: </a:t>
-            </a:r>
-            <a:r>
-              <a:rPr sz="1200" b="1">
-                <a:solidFill>
-                  <a:srgbClr val="1C7293"/>
-                </a:solidFill>
-                <a:latin typeface="Consolas"/>
-              </a:rPr>
-              <a:t>git clone &lt;the link&gt;</a:t>
-            </a:r>
-          </a:p>
-        </p:txBody>
-      </p:sp>
-      <p:sp>
-        <p:nvSpPr>
-          <p:cNvPr id="10" name="Rounded Rectangle 9"/>
+        </p:txBody>
+      </p:sp>
+      <p:sp>
+        <p:nvSpPr>
+          <p:cNvPr id="10" name="Shape 8"/>
           <p:cNvSpPr/>
           <p:nvPr/>
         </p:nvSpPr>
         <p:spPr>
           <a:xfrm>
-            <a:off x="548640" y="3429000"/>
-            <a:ext cx="5318608" cy="1783080"/>
+            <a:off x="8188757" y="4206240"/>
+            <a:ext cx="3454298" cy="1463040"/>
           </a:xfrm>
           <a:prstGeom prst="roundRect">
             <a:avLst>
-              <a:gd name="adj" fmla="val 3400"/>
+              <a:gd name="adj" fmla="val 5000"/>
             </a:avLst>
           </a:prstGeom>
           <a:solidFill>
-            <a:srgbClr val="F4F7FA"/>
+            <a:srgbClr val="1B2350"/>
           </a:solidFill>
-          <a:ln w="9525">
+          <a:ln w="12700">
             <a:solidFill>
-              <a:srgbClr val="D8E1EA"/>
+              <a:srgbClr val="1C7293"/>
             </a:solidFill>
+            <a:prstDash val="solid"/>
           </a:ln>
-          <a:effectLst/>
         </p:spPr>
-        <p:style>
-          <a:lnRef idx="1">
-            <a:schemeClr val="accent1"/>
-          </a:lnRef>
-          <a:fillRef idx="3">
-            <a:schemeClr val="accent1"/>
-          </a:fillRef>
-          <a:effectRef idx="2">
-            <a:schemeClr val="accent1"/>
-          </a:effectRef>
-          <a:fontRef idx="minor">
-            <a:schemeClr val="lt1"/>
-          </a:fontRef>
-        </p:style>
-        <p:txBody>
-          <a:bodyPr rtlCol="0" anchor="ctr"/>
-          <a:lstStyle/>
-          <a:p>
-            <a:pPr algn="ctr"/>
-          </a:p>
-        </p:txBody>
-      </p:sp>
-      <p:sp>
-        <p:nvSpPr>
-          <p:cNvPr id="11" name="TextBox 10"/>
+        <p:txBody>
+          <a:bodyPr/>
+          <a:p/>
+        </p:txBody>
+      </p:sp>
+      <p:sp>
+        <p:nvSpPr>
+          <p:cNvPr id="11" name="Text 9"/>
           <p:cNvSpPr txBox="1"/>
           <p:nvPr/>
         </p:nvSpPr>
         <p:spPr>
           <a:xfrm>
-            <a:off x="822960" y="3630168"/>
-            <a:ext cx="4769968" cy="365760"/>
+            <a:off x="8417357" y="4370832"/>
+            <a:ext cx="2997098" cy="502920"/>
           </a:xfrm>
           <a:prstGeom prst="rect">
             <a:avLst/>
           </a:prstGeom>
           <a:noFill/>
+          <a:ln/>
         </p:spPr>
         <p:txBody>
-          <a:bodyPr wrap="square" lIns="0" rIns="0" tIns="0" bIns="0">
-            <a:spAutoFit/>
-          </a:bodyPr>
+          <a:bodyPr wrap="square" lIns="0" tIns="0" rIns="0" bIns="0" rtlCol="0" anchor="ctr"/>
           <a:lstStyle/>
           <a:p>
+            <a:pPr indent="0" marL="0">
+              <a:buNone/>
+            </a:pPr>
             <a:r>
-              <a:rPr sz="1700" b="1">
+              <a:rPr lang="en-US" sz="2400" b="1" dirty="0">
                 <a:solidFill>
-                  <a:srgbClr val="21295C"/>
+                  <a:srgbClr val="CADCFC"/>
                 </a:solidFill>
-                <a:latin typeface="Cambria"/>
+                <a:latin typeface="Cambria" pitchFamily="34" charset="0"/>
+                <a:ea typeface="Cambria" pitchFamily="34" charset="-122"/>
+                <a:cs typeface="Cambria" pitchFamily="34" charset="-120"/>
               </a:rPr>
-              <a:t>3. /setup</a:t>
+              <a:t>Two commands</a:t>
             </a:r>
+            <a:endParaRPr lang="en-US" sz="2400" dirty="0"/>
           </a:p>
         </p:txBody>
       </p:sp>
       <p:sp>
         <p:nvSpPr>
-          <p:cNvPr id="12" name="TextBox 11"/>
+          <p:cNvPr id="12" name="Text 10"/>
           <p:cNvSpPr txBox="1"/>
           <p:nvPr/>
         </p:nvSpPr>
         <p:spPr>
           <a:xfrm>
-            <a:off x="822960" y="4041648"/>
-            <a:ext cx="4769968" cy="1078992"/>
+            <a:off x="8417357" y="4892040"/>
+            <a:ext cx="2997098" cy="685800"/>
           </a:xfrm>
           <a:prstGeom prst="rect">
             <a:avLst/>
           </a:prstGeom>
           <a:noFill/>
+          <a:ln/>
         </p:spPr>
         <p:txBody>
-          <a:bodyPr wrap="square" lIns="0" rIns="0" tIns="0" bIns="0">
-            <a:spAutoFit/>
-          </a:bodyPr>
+          <a:bodyPr wrap="square" lIns="0" tIns="0" rIns="0" bIns="0" rtlCol="0" anchor="ctr"/>
           <a:lstStyle/>
           <a:p>
-            <a:pPr>
-              <a:spcAft>
-                <a:spcPts val="600"/>
-              </a:spcAft>
+            <a:pPr indent="0" marL="0">
+              <a:buNone/>
             </a:pPr>
             <a:r>
-              <a:rPr sz="1200">
-                <a:solidFill>
-                  <a:srgbClr val="5B6472"/>
-                </a:solidFill>
-                <a:latin typeface="Calibri"/>
-              </a:rPr>
-              <a:t>Terminal: </a:t>
-            </a:r>
-            <a:r>
-              <a:rPr sz="1200" b="1">
-                <a:solidFill>
-                  <a:srgbClr val="1C7293"/>
-                </a:solidFill>
-                <a:latin typeface="Consolas"/>
-              </a:rPr>
-              <a:t>cd ~/northline-course</a:t>
-            </a:r>
-            <a:r>
-              <a:rPr sz="1200">
-                <a:solidFill>
-                  <a:srgbClr val="5B6472"/>
-                </a:solidFill>
-                <a:latin typeface="Calibri"/>
-              </a:rPr>
-              <a:t> then </a:t>
-            </a:r>
-            <a:r>
-              <a:rPr sz="1200" b="1">
-                <a:solidFill>
-                  <a:srgbClr val="1C7293"/>
-                </a:solidFill>
-                <a:latin typeface="Consolas"/>
-              </a:rPr>
-              <a:t>claude</a:t>
-            </a:r>
-            <a:r>
-              <a:rPr sz="1200">
-                <a:solidFill>
-                  <a:srgbClr val="5B6472"/>
-                </a:solidFill>
-                <a:latin typeface="Calibri"/>
-              </a:rPr>
-              <a:t>. Type </a:t>
-            </a:r>
-            <a:r>
-              <a:rPr sz="1200" b="1">
-                <a:solidFill>
-                  <a:srgbClr val="1C7293"/>
-                </a:solidFill>
-                <a:latin typeface="Consolas"/>
-              </a:rPr>
-              <a:t>/setup</a:t>
-            </a:r>
-            <a:r>
-              <a:rPr sz="1200">
-                <a:solidFill>
-                  <a:srgbClr val="5B6472"/>
-                </a:solidFill>
-                <a:latin typeface="Calibri"/>
-              </a:rPr>
-              <a:t>. It installs uv, runs the checks, and prints a </a:t>
-            </a:r>
-            <a:r>
-              <a:rPr sz="1200" b="1">
-                <a:solidFill>
-                  <a:srgbClr val="1C7293"/>
-                </a:solidFill>
-                <a:latin typeface="Consolas"/>
-              </a:rPr>
-              <a:t>READY:</a:t>
-            </a:r>
-            <a:r>
-              <a:rPr sz="1200">
-                <a:solidFill>
-                  <a:srgbClr val="5B6472"/>
-                </a:solidFill>
-                <a:latin typeface="Calibri"/>
-              </a:rPr>
-              <a:t> line.</a:t>
-            </a:r>
-          </a:p>
-          <a:p>
-            <a:pPr>
-              <a:spcAft>
-                <a:spcPts val="600"/>
-              </a:spcAft>
-            </a:pPr>
-            <a:r>
-              <a:rPr sz="1200">
-                <a:solidFill>
-                  <a:srgbClr val="5B6472"/>
-                </a:solidFill>
-                <a:latin typeface="Calibri"/>
-              </a:rPr>
-              <a:t>Then quit, run </a:t>
-            </a:r>
-            <a:r>
-              <a:rPr sz="1200" b="1">
-                <a:solidFill>
-                  <a:srgbClr val="1C7293"/>
-                </a:solidFill>
-                <a:latin typeface="Consolas"/>
-              </a:rPr>
-              <a:t>claude</a:t>
-            </a:r>
-            <a:r>
-              <a:rPr sz="1200">
-                <a:solidFill>
-                  <a:srgbClr val="5B6472"/>
-                </a:solidFill>
-                <a:latin typeface="Calibri"/>
-              </a:rPr>
-              <a:t> again in the same folder, and approve the </a:t>
-            </a:r>
-            <a:r>
-              <a:rPr sz="1200" b="1">
-                <a:solidFill>
-                  <a:srgbClr val="1C7293"/>
-                </a:solidFill>
-                <a:latin typeface="Consolas"/>
-              </a:rPr>
-              <a:t>northline</a:t>
-            </a:r>
-            <a:r>
-              <a:rPr sz="1200">
-                <a:solidFill>
-                  <a:srgbClr val="5B6472"/>
-                </a:solidFill>
-                <a:latin typeface="Calibri"/>
-              </a:rPr>
-              <a:t> server when asked.</a:t>
-            </a:r>
-          </a:p>
-        </p:txBody>
-      </p:sp>
-      <p:sp>
-        <p:nvSpPr>
-          <p:cNvPr id="13" name="Rounded Rectangle 12"/>
-          <p:cNvSpPr/>
-          <p:nvPr/>
-        </p:nvSpPr>
-        <p:spPr>
-          <a:xfrm>
-            <a:off x="6324448" y="3429000"/>
-            <a:ext cx="5318608" cy="1783080"/>
-          </a:xfrm>
-          <a:prstGeom prst="roundRect">
-            <a:avLst>
-              <a:gd name="adj" fmla="val 3400"/>
-            </a:avLst>
-          </a:prstGeom>
-          <a:solidFill>
-            <a:srgbClr val="F4F7FA"/>
-          </a:solidFill>
-          <a:ln w="9525">
-            <a:solidFill>
-              <a:srgbClr val="D8E1EA"/>
-            </a:solidFill>
-          </a:ln>
-          <a:effectLst/>
-        </p:spPr>
-        <p:style>
-          <a:lnRef idx="1">
-            <a:schemeClr val="accent1"/>
-          </a:lnRef>
-          <a:fillRef idx="3">
-            <a:schemeClr val="accent1"/>
-          </a:fillRef>
-          <a:effectRef idx="2">
-            <a:schemeClr val="accent1"/>
-          </a:effectRef>
-          <a:fontRef idx="minor">
-            <a:schemeClr val="lt1"/>
-          </a:fontRef>
-        </p:style>
-        <p:txBody>
-          <a:bodyPr rtlCol="0" anchor="ctr"/>
-          <a:lstStyle/>
-          <a:p>
-            <a:pPr algn="ctr"/>
-          </a:p>
-        </p:txBody>
-      </p:sp>
-      <p:sp>
-        <p:nvSpPr>
-          <p:cNvPr id="14" name="TextBox 13"/>
-          <p:cNvSpPr txBox="1"/>
-          <p:nvPr/>
-        </p:nvSpPr>
-        <p:spPr>
-          <a:xfrm>
-            <a:off x="6598768" y="3630168"/>
-            <a:ext cx="4769968" cy="365760"/>
-          </a:xfrm>
-          <a:prstGeom prst="rect">
-            <a:avLst/>
-          </a:prstGeom>
-          <a:noFill/>
-        </p:spPr>
-        <p:txBody>
-          <a:bodyPr wrap="square" lIns="0" rIns="0" tIns="0" bIns="0">
-            <a:spAutoFit/>
-          </a:bodyPr>
-          <a:lstStyle/>
-          <a:p>
-            <a:r>
-              <a:rPr sz="1700" b="1">
-                <a:solidFill>
-                  <a:srgbClr val="21295C"/>
-                </a:solidFill>
-                <a:latin typeface="Cambria"/>
-              </a:rPr>
-              <a:t>4. The server, in a second window</a:t>
-            </a:r>
-          </a:p>
-        </p:txBody>
-      </p:sp>
-      <p:sp>
-        <p:nvSpPr>
-          <p:cNvPr id="15" name="TextBox 14"/>
-          <p:cNvSpPr txBox="1"/>
-          <p:nvPr/>
-        </p:nvSpPr>
-        <p:spPr>
-          <a:xfrm>
-            <a:off x="6598768" y="4041648"/>
-            <a:ext cx="4769968" cy="1078992"/>
-          </a:xfrm>
-          <a:prstGeom prst="rect">
-            <a:avLst/>
-          </a:prstGeom>
-          <a:noFill/>
-        </p:spPr>
-        <p:txBody>
-          <a:bodyPr wrap="square" lIns="0" rIns="0" tIns="0" bIns="0">
-            <a:spAutoFit/>
-          </a:bodyPr>
-          <a:lstStyle/>
-          <a:p>
-            <a:pPr>
-              <a:spcAft>
-                <a:spcPts val="600"/>
-              </a:spcAft>
-            </a:pPr>
-            <a:r>
-              <a:rPr sz="1200">
-                <a:solidFill>
-                  <a:srgbClr val="5B6472"/>
-                </a:solidFill>
-                <a:latin typeface="Calibri"/>
-              </a:rPr>
-              <a:t>New terminal window: </a:t>
-            </a:r>
-            <a:r>
-              <a:rPr sz="1200" b="1">
-                <a:solidFill>
-                  <a:srgbClr val="1C7293"/>
-                </a:solidFill>
-                <a:latin typeface="Consolas"/>
-              </a:rPr>
-              <a:t>cd ~/northline-course</a:t>
-            </a:r>
-            <a:r>
-              <a:rPr sz="1200">
-                <a:solidFill>
-                  <a:srgbClr val="5B6472"/>
-                </a:solidFill>
-                <a:latin typeface="Calibri"/>
-              </a:rPr>
-              <a:t> then </a:t>
-            </a:r>
-            <a:r>
-              <a:rPr sz="1200" b="1">
-                <a:solidFill>
-                  <a:srgbClr val="1C7293"/>
-                </a:solidFill>
-                <a:latin typeface="Consolas"/>
-              </a:rPr>
-              <a:t>uv run python -m northline.agent.server</a:t>
-            </a:r>
-            <a:r>
-              <a:rPr sz="1200">
-                <a:solidFill>
-                  <a:srgbClr val="5B6472"/>
-                </a:solidFill>
-                <a:latin typeface="Calibri"/>
-              </a:rPr>
-              <a:t>. Leave it open.</a:t>
-            </a:r>
-          </a:p>
-          <a:p>
-            <a:pPr>
-              <a:spcAft>
-                <a:spcPts val="600"/>
-              </a:spcAft>
-            </a:pPr>
-            <a:r>
-              <a:rPr sz="1200">
-                <a:solidFill>
-                  <a:srgbClr val="5B6472"/>
-                </a:solidFill>
-                <a:latin typeface="Calibri"/>
-              </a:rPr>
-              <a:t>Open </a:t>
-            </a:r>
-            <a:r>
-              <a:rPr sz="1200" b="1">
-                <a:solidFill>
-                  <a:srgbClr val="1C7293"/>
-                </a:solidFill>
-                <a:latin typeface="Consolas"/>
-              </a:rPr>
-              <a:t>127.0.0.1:8765</a:t>
-            </a:r>
-            <a:r>
-              <a:rPr sz="1200">
-                <a:solidFill>
-                  <a:srgbClr val="5B6472"/>
-                </a:solidFill>
-                <a:latin typeface="Calibri"/>
-              </a:rPr>
-              <a:t> and text the agent </a:t>
-            </a:r>
-            <a:r>
-              <a:rPr sz="1200" b="1">
-                <a:solidFill>
-                  <a:srgbClr val="5B6472"/>
-                </a:solidFill>
-                <a:latin typeface="Calibri"/>
-              </a:rPr>
-              <a:t>“my BP was 184/112”</a:t>
-            </a:r>
-            <a:r>
-              <a:rPr sz="1200">
-                <a:solidFill>
-                  <a:srgbClr val="5B6472"/>
-                </a:solidFill>
-                <a:latin typeface="Calibri"/>
-              </a:rPr>
-              <a:t>. Dashboard: </a:t>
-            </a:r>
-            <a:r>
-              <a:rPr sz="1200" b="1">
-                <a:solidFill>
-                  <a:srgbClr val="1C7293"/>
-                </a:solidFill>
-                <a:latin typeface="Consolas"/>
-              </a:rPr>
-              <a:t>127.0.0.1:8765/dashboard</a:t>
-            </a:r>
-          </a:p>
-        </p:txBody>
-      </p:sp>
-      <p:sp>
-        <p:nvSpPr>
-          <p:cNvPr id="16" name="Rounded Rectangle 15"/>
-          <p:cNvSpPr/>
-          <p:nvPr/>
-        </p:nvSpPr>
-        <p:spPr>
-          <a:xfrm>
-            <a:off x="548640" y="5440680"/>
-            <a:ext cx="11094415" cy="822960"/>
-          </a:xfrm>
-          <a:prstGeom prst="roundRect">
-            <a:avLst>
-              <a:gd name="adj" fmla="val 3400"/>
-            </a:avLst>
-          </a:prstGeom>
-          <a:solidFill>
-            <a:srgbClr val="065A82"/>
-          </a:solidFill>
-          <a:ln>
-            <a:noFill/>
-          </a:ln>
-          <a:effectLst/>
-        </p:spPr>
-        <p:style>
-          <a:lnRef idx="1">
-            <a:schemeClr val="accent1"/>
-          </a:lnRef>
-          <a:fillRef idx="3">
-            <a:schemeClr val="accent1"/>
-          </a:fillRef>
-          <a:effectRef idx="2">
-            <a:schemeClr val="accent1"/>
-          </a:effectRef>
-          <a:fontRef idx="minor">
-            <a:schemeClr val="lt1"/>
-          </a:fontRef>
-        </p:style>
-        <p:txBody>
-          <a:bodyPr rtlCol="0" anchor="ctr"/>
-          <a:lstStyle/>
-          <a:p>
-            <a:pPr algn="ctr"/>
-          </a:p>
-        </p:txBody>
-      </p:sp>
-      <p:sp>
-        <p:nvSpPr>
-          <p:cNvPr id="17" name="TextBox 16"/>
-          <p:cNvSpPr txBox="1"/>
-          <p:nvPr/>
-        </p:nvSpPr>
-        <p:spPr>
-          <a:xfrm>
-            <a:off x="868680" y="5568696"/>
-            <a:ext cx="7040880" cy="320040"/>
-          </a:xfrm>
-          <a:prstGeom prst="rect">
-            <a:avLst/>
-          </a:prstGeom>
-          <a:noFill/>
-        </p:spPr>
-        <p:txBody>
-          <a:bodyPr wrap="square" lIns="0" rIns="0" tIns="0" bIns="0">
-            <a:spAutoFit/>
-          </a:bodyPr>
-          <a:lstStyle/>
-          <a:p>
-            <a:r>
-              <a:rPr sz="1100" b="1">
-                <a:solidFill>
-                  <a:srgbClr val="CADCFC"/>
-                </a:solidFill>
-                <a:latin typeface="Calibri"/>
-              </a:rPr>
-              <a:t>The folder</a:t>
-            </a:r>
-          </a:p>
-        </p:txBody>
-      </p:sp>
-      <p:sp>
-        <p:nvSpPr>
-          <p:cNvPr id="18" name="TextBox 17"/>
-          <p:cNvSpPr txBox="1"/>
-          <p:nvPr/>
-        </p:nvSpPr>
-        <p:spPr>
-          <a:xfrm>
-            <a:off x="868680" y="5843016"/>
-            <a:ext cx="7040880" cy="411480"/>
-          </a:xfrm>
-          <a:prstGeom prst="rect">
-            <a:avLst/>
-          </a:prstGeom>
-          <a:noFill/>
-        </p:spPr>
-        <p:txBody>
-          <a:bodyPr wrap="square" lIns="0" rIns="0" tIns="0" bIns="0">
-            <a:spAutoFit/>
-          </a:bodyPr>
-          <a:lstStyle/>
-          <a:p>
-            <a:r>
-              <a:rPr sz="1800" b="1">
+              <a:rPr lang="en-US" sz="1250" dirty="0">
                 <a:solidFill>
                   <a:srgbClr val="FFFFFF"/>
                 </a:solidFill>
-                <a:latin typeface="Consolas"/>
+                <a:latin typeface="Calibri" pitchFamily="34" charset="0"/>
+                <a:ea typeface="Calibri" pitchFamily="34" charset="-122"/>
+                <a:cs typeface="Calibri" pitchFamily="34" charset="-120"/>
               </a:rPr>
-              <a:t>github.com/anthonymorrisjohnson/northline-course</a:t>
+              <a:t>/pm-run and /deploy triage, all session</a:t>
             </a:r>
-          </a:p>
-        </p:txBody>
-      </p:sp>
-      <p:sp>
-        <p:nvSpPr>
-          <p:cNvPr id="19" name="TextBox 18"/>
-          <p:cNvSpPr txBox="1"/>
-          <p:nvPr/>
-        </p:nvSpPr>
-        <p:spPr>
-          <a:xfrm>
-            <a:off x="8138160" y="5568696"/>
-            <a:ext cx="3200400" cy="320040"/>
-          </a:xfrm>
-          <a:prstGeom prst="rect">
-            <a:avLst/>
-          </a:prstGeom>
-          <a:noFill/>
-        </p:spPr>
-        <p:txBody>
-          <a:bodyPr wrap="square" lIns="0" rIns="0" tIns="0" bIns="0">
-            <a:spAutoFit/>
-          </a:bodyPr>
-          <a:lstStyle/>
-          <a:p>
-            <a:r>
-              <a:rPr sz="1100" b="1">
-                <a:solidFill>
-                  <a:srgbClr val="CADCFC"/>
-                </a:solidFill>
-                <a:latin typeface="Calibri"/>
-              </a:rPr>
-              <a:t>In the room</a:t>
-            </a:r>
-          </a:p>
-        </p:txBody>
-      </p:sp>
-      <p:sp>
-        <p:nvSpPr>
-          <p:cNvPr id="20" name="TextBox 19"/>
-          <p:cNvSpPr txBox="1"/>
-          <p:nvPr/>
-        </p:nvSpPr>
-        <p:spPr>
-          <a:xfrm>
-            <a:off x="8138160" y="5843016"/>
-            <a:ext cx="3200400" cy="411480"/>
-          </a:xfrm>
-          <a:prstGeom prst="rect">
-            <a:avLst/>
-          </a:prstGeom>
-          <a:noFill/>
-        </p:spPr>
-        <p:txBody>
-          <a:bodyPr wrap="square" lIns="0" rIns="0" tIns="0" bIns="0">
-            <a:spAutoFit/>
-          </a:bodyPr>
-          <a:lstStyle/>
-          <a:p>
-            <a:r>
-              <a:rPr sz="1500" b="1">
-                <a:solidFill>
-                  <a:srgbClr val="FFFFFF"/>
-                </a:solidFill>
-                <a:latin typeface="Consolas"/>
-              </a:rPr>
-              <a:t>/pm-run</a:t>
-            </a:r>
-            <a:r>
-              <a:rPr sz="1200">
-                <a:solidFill>
-                  <a:srgbClr val="CADCFC"/>
-                </a:solidFill>
-                <a:latin typeface="Calibri"/>
-              </a:rPr>
-              <a:t>   then   </a:t>
-            </a:r>
-            <a:r>
-              <a:rPr sz="1500" b="1">
-                <a:solidFill>
-                  <a:srgbClr val="FFFFFF"/>
-                </a:solidFill>
-                <a:latin typeface="Consolas"/>
-              </a:rPr>
-              <a:t>/deploy triage</a:t>
-            </a:r>
-          </a:p>
-        </p:txBody>
-      </p:sp>
-      <p:sp>
-        <p:nvSpPr>
-          <p:cNvPr id="21" name="TextBox 20"/>
-          <p:cNvSpPr txBox="1"/>
-          <p:nvPr/>
-        </p:nvSpPr>
-        <p:spPr>
-          <a:xfrm>
-            <a:off x="9265615" y="6400800"/>
-            <a:ext cx="2377440" cy="274320"/>
-          </a:xfrm>
-          <a:prstGeom prst="rect">
-            <a:avLst/>
-          </a:prstGeom>
-          <a:noFill/>
-        </p:spPr>
-        <p:txBody>
-          <a:bodyPr wrap="square" lIns="0" rIns="0" tIns="0" bIns="0">
-            <a:spAutoFit/>
-          </a:bodyPr>
-          <a:lstStyle/>
-          <a:p>
-            <a:pPr algn="r"/>
-            <a:r>
-              <a:rPr sz="1000">
-                <a:solidFill>
-                  <a:srgbClr val="5B6472"/>
-                </a:solidFill>
-                <a:latin typeface="Calibri"/>
-              </a:rPr>
-              <a:t>Northline Care  ·  1</a:t>
-            </a:r>
+            <a:endParaRPr lang="en-US" sz="1250" dirty="0"/>
           </a:p>
         </p:txBody>
       </p:sp>
@@ -9611,7 +9603,7 @@
 </p:sld>
 </file>
 
-<file path=ppt/slides/slide2.xml><?xml version="1.0" encoding="utf-8"?>
+<file path=ppt/slides/slide3.xml><?xml version="1.0" encoding="utf-8"?>
 <p:sld xmlns:a="http://schemas.openxmlformats.org/drawingml/2006/main" xmlns:r="http://schemas.openxmlformats.org/officeDocument/2006/relationships" xmlns:p="http://schemas.openxmlformats.org/presentationml/2006/main">
   <p:cSld name="Slide 2">
     <p:bg>
@@ -10026,7 +10018,7 @@
 </p:sld>
 </file>
 
-<file path=ppt/slides/slide3.xml><?xml version="1.0" encoding="utf-8"?>
+<file path=ppt/slides/slide4.xml><?xml version="1.0" encoding="utf-8"?>
 <p:sld xmlns:a="http://schemas.openxmlformats.org/drawingml/2006/main" xmlns:r="http://schemas.openxmlformats.org/officeDocument/2006/relationships" xmlns:p="http://schemas.openxmlformats.org/presentationml/2006/main">
   <p:cSld name="Slide 3">
     <p:bg>
@@ -10886,7 +10878,7 @@
 </p:sld>
 </file>
 
-<file path=ppt/slides/slide4.xml><?xml version="1.0" encoding="utf-8"?>
+<file path=ppt/slides/slide5.xml><?xml version="1.0" encoding="utf-8"?>
 <p:sld xmlns:a="http://schemas.openxmlformats.org/drawingml/2006/main" xmlns:r="http://schemas.openxmlformats.org/officeDocument/2006/relationships" xmlns:p="http://schemas.openxmlformats.org/presentationml/2006/main">
   <p:cSld name="Slide 4">
     <p:bg>
@@ -12416,7 +12408,7 @@
 </p:sld>
 </file>
 
-<file path=ppt/slides/slide5.xml><?xml version="1.0" encoding="utf-8"?>
+<file path=ppt/slides/slide6.xml><?xml version="1.0" encoding="utf-8"?>
 <p:sld xmlns:a="http://schemas.openxmlformats.org/drawingml/2006/main" xmlns:r="http://schemas.openxmlformats.org/officeDocument/2006/relationships" xmlns:p="http://schemas.openxmlformats.org/presentationml/2006/main">
   <p:cSld name="Slide 5">
     <p:bg>
@@ -13157,7 +13149,7 @@
 </p:sld>
 </file>
 
-<file path=ppt/slides/slide6.xml><?xml version="1.0" encoding="utf-8"?>
+<file path=ppt/slides/slide7.xml><?xml version="1.0" encoding="utf-8"?>
 <p:sld xmlns:a="http://schemas.openxmlformats.org/drawingml/2006/main" xmlns:r="http://schemas.openxmlformats.org/officeDocument/2006/relationships" xmlns:p="http://schemas.openxmlformats.org/presentationml/2006/main">
   <p:cSld name="Slide 6">
     <p:bg>
@@ -13816,7 +13808,7 @@
 </p:sld>
 </file>
 
-<file path=ppt/slides/slide7.xml><?xml version="1.0" encoding="utf-8"?>
+<file path=ppt/slides/slide8.xml><?xml version="1.0" encoding="utf-8"?>
 <p:sld xmlns:a="http://schemas.openxmlformats.org/drawingml/2006/main" xmlns:r="http://schemas.openxmlformats.org/officeDocument/2006/relationships" xmlns:p="http://schemas.openxmlformats.org/presentationml/2006/main">
   <p:cSld name="Slide 7">
     <p:bg>
@@ -16095,7 +16087,7 @@
 </p:sld>
 </file>
 
-<file path=ppt/slides/slide8.xml><?xml version="1.0" encoding="utf-8"?>
+<file path=ppt/slides/slide9.xml><?xml version="1.0" encoding="utf-8"?>
 <p:sld xmlns:a="http://schemas.openxmlformats.org/drawingml/2006/main" xmlns:r="http://schemas.openxmlformats.org/officeDocument/2006/relationships" xmlns:p="http://schemas.openxmlformats.org/presentationml/2006/main">
   <p:cSld name="Slide 8">
     <p:bg>
@@ -21693,249 +21685,6 @@
                 <a:cs typeface="Calibri" pitchFamily="34" charset="-120"/>
               </a:rPr>
               <a:t>Northline Care  ·  9</a:t>
-            </a:r>
-            <a:endParaRPr lang="en-US" sz="1000" dirty="0"/>
-          </a:p>
-        </p:txBody>
-      </p:sp>
-    </p:spTree>
-  </p:cSld>
-  <p:clrMapOvr>
-    <a:masterClrMapping/>
-  </p:clrMapOvr>
-</p:sld>
-</file>
-
-<file path=ppt/slides/slide9.xml><?xml version="1.0" encoding="utf-8"?>
-<p:sld xmlns:a="http://schemas.openxmlformats.org/drawingml/2006/main" xmlns:r="http://schemas.openxmlformats.org/officeDocument/2006/relationships" xmlns:p="http://schemas.openxmlformats.org/presentationml/2006/main">
-  <p:cSld name="Slide 9">
-    <p:bg>
-      <p:bgPr>
-        <a:solidFill>
-          <a:srgbClr val="FFFFFF"/>
-        </a:solidFill>
-      </p:bgPr>
-    </p:bg>
-    <p:spTree>
-      <p:nvGrpSpPr>
-        <p:cNvPr id="1" name=""/>
-        <p:cNvGrpSpPr/>
-        <p:nvPr/>
-      </p:nvGrpSpPr>
-      <p:grpSpPr>
-        <a:xfrm>
-          <a:off x="0" y="0"/>
-          <a:ext cx="0" cy="0"/>
-          <a:chOff x="0" y="0"/>
-          <a:chExt cx="0" cy="0"/>
-        </a:xfrm>
-      </p:grpSpPr>
-      <p:sp>
-        <p:nvSpPr>
-          <p:cNvPr id="2" name="Text 0"/>
-          <p:cNvSpPr txBox="1"/>
-          <p:nvPr/>
-        </p:nvSpPr>
-        <p:spPr>
-          <a:xfrm>
-            <a:off x="548640" y="164592"/>
-            <a:ext cx="11094415" cy="274320"/>
-          </a:xfrm>
-          <a:prstGeom prst="rect">
-            <a:avLst/>
-          </a:prstGeom>
-          <a:noFill/>
-          <a:ln/>
-        </p:spPr>
-        <p:txBody>
-          <a:bodyPr wrap="square" lIns="0" tIns="0" rIns="0" bIns="0" rtlCol="0" anchor="ctr"/>
-          <a:lstStyle/>
-          <a:p>
-            <a:pPr algn="l" indent="0" marL="0">
-              <a:buNone/>
-            </a:pPr>
-            <a:r>
-              <a:rPr lang="en-US" sz="1200" b="1" spc="200" kern="0" dirty="0">
-                <a:solidFill>
-                  <a:srgbClr val="1C7293"/>
-                </a:solidFill>
-                <a:latin typeface="Calibri" pitchFamily="34" charset="0"/>
-                <a:ea typeface="Calibri" pitchFamily="34" charset="-122"/>
-                <a:cs typeface="Calibri" pitchFamily="34" charset="-120"/>
-              </a:rPr>
-              <a:t>TREND, WEEKS 1-52</a:t>
-            </a:r>
-            <a:endParaRPr lang="en-US" sz="1200" dirty="0"/>
-          </a:p>
-        </p:txBody>
-      </p:sp>
-      <p:sp>
-        <p:nvSpPr>
-          <p:cNvPr id="3" name="Text 1"/>
-          <p:cNvSpPr txBox="1"/>
-          <p:nvPr/>
-        </p:nvSpPr>
-        <p:spPr>
-          <a:xfrm>
-            <a:off x="548640" y="411480"/>
-            <a:ext cx="11094415" cy="822960"/>
-          </a:xfrm>
-          <a:prstGeom prst="rect">
-            <a:avLst/>
-          </a:prstGeom>
-          <a:noFill/>
-          <a:ln/>
-        </p:spPr>
-        <p:txBody>
-          <a:bodyPr wrap="square" lIns="0" tIns="0" rIns="0" bIns="0" rtlCol="0" anchor="ctr"/>
-          <a:lstStyle/>
-          <a:p>
-            <a:pPr algn="l" indent="0" marL="0">
-              <a:buNone/>
-            </a:pPr>
-            <a:r>
-              <a:rPr lang="en-US" sz="3200" b="1" dirty="0">
-                <a:solidFill>
-                  <a:srgbClr val="1B1F27"/>
-                </a:solidFill>
-                <a:latin typeface="Cambria" pitchFamily="34" charset="0"/>
-                <a:ea typeface="Cambria" pitchFamily="34" charset="-122"/>
-                <a:cs typeface="Cambria" pitchFamily="34" charset="-120"/>
-              </a:rPr>
-              <a:t>AI lets you pivot fast</a:t>
-            </a:r>
-            <a:endParaRPr lang="en-US" sz="3200" dirty="0"/>
-          </a:p>
-        </p:txBody>
-      </p:sp>
-      <p:graphicFrame>
-        <p:nvGraphicFramePr>
-          <p:cNvPr id="4" name="Chart 0" descr=""/>
-          <p:cNvGraphicFramePr/>
-          <p:nvPr/>
-        </p:nvGraphicFramePr>
-        <p:xfrm>
-          <a:off x="548640" y="1508760"/>
-          <a:ext cx="11094415" cy="3840480"/>
-        </p:xfrm>
-        <a:graphic xmlns:a="http://schemas.openxmlformats.org/drawingml/2006/main">
-          <a:graphicData uri="http://schemas.openxmlformats.org/drawingml/2006/chart">
-            <c:chart xmlns:c="http://schemas.openxmlformats.org/drawingml/2006/chart" r:id="rId1"/>
-          </a:graphicData>
-        </a:graphic>
-      </p:graphicFrame>
-      <p:sp>
-        <p:nvSpPr>
-          <p:cNvPr id="5" name="Text 2"/>
-          <p:cNvSpPr txBox="1"/>
-          <p:nvPr/>
-        </p:nvSpPr>
-        <p:spPr>
-          <a:xfrm>
-            <a:off x="548640" y="5486400"/>
-            <a:ext cx="11094415" cy="292608"/>
-          </a:xfrm>
-          <a:prstGeom prst="rect">
-            <a:avLst/>
-          </a:prstGeom>
-          <a:noFill/>
-          <a:ln/>
-        </p:spPr>
-        <p:txBody>
-          <a:bodyPr wrap="square" lIns="0" tIns="0" rIns="0" bIns="0" rtlCol="0" anchor="ctr"/>
-          <a:lstStyle/>
-          <a:p>
-            <a:pPr indent="0" marL="0">
-              <a:buNone/>
-            </a:pPr>
-            <a:r>
-              <a:rPr lang="en-US" sz="1250" i="1" dirty="0">
-                <a:solidFill>
-                  <a:srgbClr val="5B6472"/>
-                </a:solidFill>
-                <a:latin typeface="Calibri" pitchFamily="34" charset="0"/>
-                <a:ea typeface="Calibri" pitchFamily="34" charset="-122"/>
-                <a:cs typeface="Calibri" pitchFamily="34" charset="-120"/>
-              </a:rPr>
-              <a:t>Median nurse response: 31.1h → 4.0h — but 90.0 urgent cases a week are now missed.</a:t>
-            </a:r>
-            <a:endParaRPr lang="en-US" sz="1250" dirty="0"/>
-          </a:p>
-        </p:txBody>
-      </p:sp>
-      <p:sp>
-        <p:nvSpPr>
-          <p:cNvPr id="6" name="Text 3"/>
-          <p:cNvSpPr txBox="1"/>
-          <p:nvPr/>
-        </p:nvSpPr>
-        <p:spPr>
-          <a:xfrm>
-            <a:off x="548640" y="5806440"/>
-            <a:ext cx="11094415" cy="292608"/>
-          </a:xfrm>
-          <a:prstGeom prst="rect">
-            <a:avLst/>
-          </a:prstGeom>
-          <a:noFill/>
-          <a:ln/>
-        </p:spPr>
-        <p:txBody>
-          <a:bodyPr wrap="square" lIns="0" tIns="0" rIns="0" bIns="0" rtlCol="0" anchor="ctr"/>
-          <a:lstStyle/>
-          <a:p>
-            <a:pPr indent="0" marL="0">
-              <a:buNone/>
-            </a:pPr>
-            <a:r>
-              <a:rPr lang="en-US" sz="1200" i="1" dirty="0">
-                <a:solidFill>
-                  <a:srgbClr val="1C7293"/>
-                </a:solidFill>
-                <a:latin typeface="Calibri" pitchFamily="34" charset="0"/>
-                <a:ea typeface="Calibri" pitchFamily="34" charset="-122"/>
-                <a:cs typeface="Calibri" pitchFamily="34" charset="-120"/>
-              </a:rPr>
-              <a:t>Numbers from a triage deployment made with the 190/115 decisions on this laptop; your room's numbers will differ. Show the live dashboard.</a:t>
-            </a:r>
-            <a:endParaRPr lang="en-US" sz="1200" dirty="0"/>
-          </a:p>
-        </p:txBody>
-      </p:sp>
-      <p:sp>
-        <p:nvSpPr>
-          <p:cNvPr id="7" name="Text 4"/>
-          <p:cNvSpPr txBox="1"/>
-          <p:nvPr/>
-        </p:nvSpPr>
-        <p:spPr>
-          <a:xfrm>
-            <a:off x="9265615" y="6400800"/>
-            <a:ext cx="2377440" cy="274320"/>
-          </a:xfrm>
-          <a:prstGeom prst="rect">
-            <a:avLst/>
-          </a:prstGeom>
-          <a:noFill/>
-          <a:ln/>
-        </p:spPr>
-        <p:txBody>
-          <a:bodyPr wrap="square" lIns="0" tIns="0" rIns="0" bIns="0" rtlCol="0" anchor="ctr"/>
-          <a:lstStyle/>
-          <a:p>
-            <a:pPr algn="r" indent="0" marL="0">
-              <a:buNone/>
-            </a:pPr>
-            <a:r>
-              <a:rPr lang="en-US" sz="1000" dirty="0">
-                <a:solidFill>
-                  <a:srgbClr val="5B6472"/>
-                </a:solidFill>
-                <a:latin typeface="Calibri" pitchFamily="34" charset="0"/>
-                <a:ea typeface="Calibri" pitchFamily="34" charset="-122"/>
-                <a:cs typeface="Calibri" pitchFamily="34" charset="-120"/>
-              </a:rPr>
-              <a:t>Northline Care  ·  10</a:t>
             </a:r>
             <a:endParaRPr lang="en-US" sz="1000" dirty="0"/>
           </a:p>

</xml_diff>

<commit_message>
Setup through the Claude desktop app: new project, paste one line, /setup
Slide 1, the README and the session plan now describe a no-terminal path:
open the desktop app, New project in an empty folder called northline,
paste "Download github.com/anthonymorrisjohnson/northline-course as a ZIP,
unzip it so the files sit directly in this folder, then delete the zip",
reopen the project, /setup. The terminal route stays as the alternative.
The server cue in the do-along is a paste line too.

Co-Authored-By: Claude Fable 5.1 <noreply@anthropic.com>
Claude-Session: https://claude.ai/code/session_01Jo9JuGz9sGjCWMSFMqHMPx
</commit_message>
<xml_diff>
--- a/slides/deck.pptx
+++ b/slides/deck.pptx
@@ -3279,7 +3279,7 @@
         <p:spPr>
           <a:xfrm>
             <a:off x="548640" y="1554480"/>
-            <a:ext cx="3535680" cy="2743200"/>
+            <a:ext cx="3535680" cy="2560320"/>
           </a:xfrm>
           <a:prstGeom prst="roundRect">
             <a:avLst>
@@ -3381,7 +3381,7 @@
                 </a:solidFill>
                 <a:latin typeface="Cambria"/>
               </a:rPr>
-              <a:t>Claude Code</a:t>
+              <a:t>Open Claude Code</a:t>
             </a:r>
           </a:p>
         </p:txBody>
@@ -3395,7 +3395,7 @@
         <p:spPr>
           <a:xfrm>
             <a:off x="822960" y="2834640"/>
-            <a:ext cx="2987040" cy="1371600"/>
+            <a:ext cx="2987040" cy="1188720"/>
           </a:xfrm>
           <a:prstGeom prst="rect">
             <a:avLst/>
@@ -3420,7 +3420,7 @@
                 </a:solidFill>
                 <a:latin typeface="Calibri"/>
               </a:rPr>
-              <a:t>Install it and sign in.</a:t>
+              <a:t>The desktop app. Sign in if it asks.</a:t>
             </a:r>
           </a:p>
           <a:p>
@@ -3436,7 +3436,25 @@
                 </a:solidFill>
                 <a:latin typeface="Calibri"/>
               </a:rPr>
-              <a:t>Check: type </a:t>
+              <a:t>Click </a:t>
+            </a:r>
+            <a:r>
+              <a:rPr sz="1400" b="1">
+                <a:solidFill>
+                  <a:srgbClr val="5B6472"/>
+                </a:solidFill>
+                <a:latin typeface="Calibri"/>
+              </a:rPr>
+              <a:t>New project</a:t>
+            </a:r>
+            <a:r>
+              <a:rPr sz="1400">
+                <a:solidFill>
+                  <a:srgbClr val="5B6472"/>
+                </a:solidFill>
+                <a:latin typeface="Calibri"/>
+              </a:rPr>
+              <a:t>, make a new empty folder, and name it </a:t>
             </a:r>
             <a:r>
               <a:rPr sz="1300" b="1">
@@ -3445,7 +3463,7 @@
                 </a:solidFill>
                 <a:latin typeface="Consolas"/>
               </a:rPr>
-              <a:t>claude --version</a:t>
+              <a:t>northline</a:t>
             </a:r>
             <a:r>
               <a:rPr sz="1400">
@@ -3454,23 +3472,7 @@
                 </a:solidFill>
                 <a:latin typeface="Calibri"/>
               </a:rPr>
-              <a:t> in a terminal.</a:t>
-            </a:r>
-          </a:p>
-          <a:p>
-            <a:pPr>
-              <a:spcAft>
-                <a:spcPts val="800"/>
-              </a:spcAft>
-            </a:pPr>
-            <a:r>
-              <a:rPr sz="1100">
-                <a:solidFill>
-                  <a:srgbClr val="5B6472"/>
-                </a:solidFill>
-                <a:latin typeface="Calibri"/>
-              </a:rPr>
-              <a:t>Windows: use the native installer, not npm.</a:t>
+              <a:t>.</a:t>
             </a:r>
           </a:p>
         </p:txBody>
@@ -3484,7 +3486,7 @@
         <p:spPr>
           <a:xfrm>
             <a:off x="4328160" y="1554480"/>
-            <a:ext cx="3535680" cy="2743200"/>
+            <a:ext cx="3535680" cy="2560320"/>
           </a:xfrm>
           <a:prstGeom prst="roundRect">
             <a:avLst>
@@ -3586,7 +3588,7 @@
                 </a:solidFill>
                 <a:latin typeface="Cambria"/>
               </a:rPr>
-              <a:t>The folder</a:t>
+              <a:t>Paste the line below</a:t>
             </a:r>
           </a:p>
         </p:txBody>
@@ -3600,7 +3602,7 @@
         <p:spPr>
           <a:xfrm>
             <a:off x="4602480" y="2834640"/>
-            <a:ext cx="2987040" cy="1371600"/>
+            <a:ext cx="2987040" cy="1188720"/>
           </a:xfrm>
           <a:prstGeom prst="rect">
             <a:avLst/>
@@ -3625,25 +3627,7 @@
                 </a:solidFill>
                 <a:latin typeface="Calibri"/>
               </a:rPr>
-              <a:t>Open the link below, click </a:t>
-            </a:r>
-            <a:r>
-              <a:rPr sz="1400" b="1">
-                <a:solidFill>
-                  <a:srgbClr val="5B6472"/>
-                </a:solidFill>
-                <a:latin typeface="Calibri"/>
-              </a:rPr>
-              <a:t>Code → Download ZIP</a:t>
-            </a:r>
-            <a:r>
-              <a:rPr sz="1400">
-                <a:solidFill>
-                  <a:srgbClr val="5B6472"/>
-                </a:solidFill>
-                <a:latin typeface="Calibri"/>
-              </a:rPr>
-              <a:t>.</a:t>
+              <a:t>Claude downloads the course and unpacks it into your folder.</a:t>
             </a:r>
           </a:p>
           <a:p>
@@ -3659,7 +3643,7 @@
                 </a:solidFill>
                 <a:latin typeface="Calibri"/>
               </a:rPr>
-              <a:t>Unzip it into your home folder.</a:t>
+              <a:t>When it says it is done, close the project and open it again.</a:t>
             </a:r>
           </a:p>
         </p:txBody>
@@ -3673,7 +3657,7 @@
         <p:spPr>
           <a:xfrm>
             <a:off x="8107680" y="1554480"/>
-            <a:ext cx="3535680" cy="2743200"/>
+            <a:ext cx="3535680" cy="2560320"/>
           </a:xfrm>
           <a:prstGeom prst="roundRect">
             <a:avLst>
@@ -3789,7 +3773,7 @@
         <p:spPr>
           <a:xfrm>
             <a:off x="8382000" y="2834640"/>
-            <a:ext cx="2987040" cy="1371600"/>
+            <a:ext cx="2987040" cy="1188720"/>
           </a:xfrm>
           <a:prstGeom prst="rect">
             <a:avLst/>
@@ -3814,7 +3798,7 @@
                 </a:solidFill>
                 <a:latin typeface="Calibri"/>
               </a:rPr>
-              <a:t>In a terminal: </a:t>
+              <a:t>Type </a:t>
             </a:r>
             <a:r>
               <a:rPr sz="1300" b="1">
@@ -3823,7 +3807,16 @@
                 </a:solidFill>
                 <a:latin typeface="Consolas"/>
               </a:rPr>
-              <a:t>cd ~/northline-course</a:t>
+              <a:t>/setup</a:t>
+            </a:r>
+            <a:r>
+              <a:rPr sz="1400">
+                <a:solidFill>
+                  <a:srgbClr val="5B6472"/>
+                </a:solidFill>
+                <a:latin typeface="Calibri"/>
+              </a:rPr>
+              <a:t>. Do what it says.</a:t>
             </a:r>
           </a:p>
           <a:p>
@@ -3839,50 +3832,7 @@
                 </a:solidFill>
                 <a:latin typeface="Calibri"/>
               </a:rPr>
-              <a:t>then </a:t>
-            </a:r>
-            <a:r>
-              <a:rPr sz="1300" b="1">
-                <a:solidFill>
-                  <a:srgbClr val="1C7293"/>
-                </a:solidFill>
-                <a:latin typeface="Consolas"/>
-              </a:rPr>
-              <a:t>claude</a:t>
-            </a:r>
-            <a:r>
-              <a:rPr sz="1400">
-                <a:solidFill>
-                  <a:srgbClr val="5B6472"/>
-                </a:solidFill>
-                <a:latin typeface="Calibri"/>
-              </a:rPr>
-              <a:t>, then type </a:t>
-            </a:r>
-            <a:r>
-              <a:rPr sz="1300" b="1">
-                <a:solidFill>
-                  <a:srgbClr val="1C7293"/>
-                </a:solidFill>
-                <a:latin typeface="Consolas"/>
-              </a:rPr>
-              <a:t>/setup</a:t>
-            </a:r>
-          </a:p>
-          <a:p>
-            <a:pPr>
-              <a:spcAft>
-                <a:spcPts val="800"/>
-              </a:spcAft>
-            </a:pPr>
-            <a:r>
-              <a:rPr sz="1400">
-                <a:solidFill>
-                  <a:srgbClr val="5B6472"/>
-                </a:solidFill>
-                <a:latin typeface="Calibri"/>
-              </a:rPr>
-              <a:t>Do what it says. Stop at </a:t>
+              <a:t>Stop when you see </a:t>
             </a:r>
             <a:r>
               <a:rPr sz="1300" b="1">
@@ -3913,8 +3863,8 @@
         </p:nvSpPr>
         <p:spPr>
           <a:xfrm>
-            <a:off x="548640" y="4754880"/>
-            <a:ext cx="11094415" cy="1005840"/>
+            <a:off x="548640" y="4480560"/>
+            <a:ext cx="11094415" cy="1234440"/>
           </a:xfrm>
           <a:prstGeom prst="roundRect">
             <a:avLst>
@@ -3959,7 +3909,7 @@
         </p:nvSpPr>
         <p:spPr>
           <a:xfrm>
-            <a:off x="868680" y="4882896"/>
+            <a:off x="868680" y="4608576"/>
             <a:ext cx="10454320" cy="320040"/>
           </a:xfrm>
           <a:prstGeom prst="rect">
@@ -3980,7 +3930,7 @@
                 </a:solidFill>
                 <a:latin typeface="Calibri"/>
               </a:rPr>
-              <a:t>The folder</a:t>
+              <a:t>Paste this into Claude Code (step 2)</a:t>
             </a:r>
           </a:p>
         </p:txBody>
@@ -3993,8 +3943,8 @@
         </p:nvSpPr>
         <p:spPr>
           <a:xfrm>
-            <a:off x="868680" y="5157216"/>
-            <a:ext cx="10454320" cy="457200"/>
+            <a:off x="868680" y="4901184"/>
+            <a:ext cx="10454320" cy="822960"/>
           </a:xfrm>
           <a:prstGeom prst="rect">
             <a:avLst/>
@@ -4008,13 +3958,13 @@
           <a:lstStyle/>
           <a:p>
             <a:r>
-              <a:rPr sz="2200" b="1">
+              <a:rPr sz="1600" b="1">
                 <a:solidFill>
                   <a:srgbClr val="FFFFFF"/>
                 </a:solidFill>
                 <a:latin typeface="Consolas"/>
               </a:rPr>
-              <a:t>github.com/anthonymorrisjohnson/northline-course</a:t>
+              <a:t>Download github.com/anthonymorrisjohnson/northline-course as a ZIP, unzip it so the files sit directly in this folder, then delete the zip.</a:t>
             </a:r>
           </a:p>
         </p:txBody>

</xml_diff>

<commit_message>
Rename /setup to /northline-setup so installed plugins cannot shadow it
An attendee with a plugin that ships its own "setup" command (sales:setup,
setup-claude) typed /setup and got that plugin instead of the course. The
skill, slide 1, README, session plan, outline, error messages, and the
new-experience scaffold all use /northline-setup now.

Co-Authored-By: Claude Fable 5.1 <noreply@anthropic.com>
Claude-Session: https://claude.ai/code/session_01Jo9JuGz9sGjCWMSFMqHMPx
</commit_message>
<xml_diff>
--- a/slides/deck.pptx
+++ b/slides/deck.pptx
@@ -3759,7 +3759,7 @@
                 </a:solidFill>
                 <a:latin typeface="Cambria"/>
               </a:rPr>
-              <a:t>/setup</a:t>
+              <a:t>/northline-setup</a:t>
             </a:r>
           </a:p>
         </p:txBody>
@@ -3807,7 +3807,7 @@
                 </a:solidFill>
                 <a:latin typeface="Consolas"/>
               </a:rPr>
-              <a:t>/setup</a:t>
+              <a:t>/northline-setup</a:t>
             </a:r>
             <a:r>
               <a:rPr sz="1400">

</xml_diff>

<commit_message>
Prefix every course command with northline- so no installed plugin can shadow it
/pm-run, /deploy, /expand, /brief, /tools, /agent and /new-experience are
now /northline-pm-run, /northline-deploy, and so on, matching
/northline-setup. Skills, deck, outline, README, docs, exercises,
templates, proposals, error messages and tests all updated. The
new-experience scaffold names its copies after the new company
(/acme-deploy, not /northline-deploy).

Co-Authored-By: Claude Fable 5.1 <noreply@anthropic.com>
Claude-Session: https://claude.ai/code/session_01Jo9JuGz9sGjCWMSFMqHMPx
</commit_message>
<xml_diff>
--- a/slides/deck.pptx
+++ b/slides/deck.pptx
@@ -2483,7 +2483,7 @@
           <a:p>
             <a:r>
               <a:rPr lang="en-US" dirty="0"/>
-              <a:t>four decisions, one at a time, voted by the room during /deploy triage. Each has a Northline default; say so, and don't let the room take all four without a vote.</a:t>
+              <a:t>four decisions, one at a time, voted by the room during /northline-deploy triage. Each has a Northline default; say so, and don't let the room take all four without a vote.</a:t>
             </a:r>
             <a:endParaRPr lang="en-US" dirty="0"/>
           </a:p>
@@ -8783,7 +8783,7 @@
                 <a:ea typeface="Cambria" pitchFamily="34" charset="-122"/>
                 <a:cs typeface="Cambria" pitchFamily="34" charset="-120"/>
               </a:rPr>
-              <a:t>/new-experience</a:t>
+              <a:t>/northline-new-experience</a:t>
             </a:r>
             <a:endParaRPr lang="en-US" sz="1500" dirty="0"/>
           </a:p>
@@ -9539,7 +9539,7 @@
                 <a:ea typeface="Calibri" pitchFamily="34" charset="-122"/>
                 <a:cs typeface="Calibri" pitchFamily="34" charset="-120"/>
               </a:rPr>
-              <a:t>/pm-run and /deploy triage, all session</a:t>
+              <a:t>/northline-pm-run and /northline-deploy triage, all session</a:t>
             </a:r>
             <a:endParaRPr lang="en-US" sz="1250" dirty="0"/>
           </a:p>
@@ -12227,7 +12227,7 @@
                 <a:ea typeface="Cambria" pitchFamily="34" charset="-122"/>
                 <a:cs typeface="Cambria" pitchFamily="34" charset="-120"/>
               </a:rPr>
-              <a:t>/expand or /deploy</a:t>
+              <a:t>/northline-expand or /northline-deploy</a:t>
             </a:r>
             <a:endParaRPr lang="en-US" sz="1300" dirty="0"/>
           </a:p>

</xml_diff>

<commit_message>
Setup: the desktop app's Code tab or a terminal; not New project mode
Tested both. The Code tab in the Claude desktop app is real Claude Code and
runs /northline-setup to READY. The app's New project mode runs commands
in a sandbox whose `claude` accepts only a plain prompt, so classify,
diagnose, propose and the acceptance run all fail there. Slide 1, README,
session plan and outline say which is which.

Co-Authored-By: Claude Fable 5.1 <noreply@anthropic.com>
Claude-Session: https://claude.ai/code/session_01Jo9JuGz9sGjCWMSFMqHMPx
</commit_message>
<xml_diff>
--- a/slides/deck.pptx
+++ b/slides/deck.pptx
@@ -3375,13 +3375,13 @@
           <a:lstStyle/>
           <a:p>
             <a:r>
-              <a:rPr sz="2000" b="1">
+              <a:rPr sz="1900" b="1">
                 <a:solidFill>
                   <a:srgbClr val="21295C"/>
                 </a:solidFill>
                 <a:latin typeface="Cambria"/>
               </a:rPr>
-              <a:t>Open Claude Code</a:t>
+              <a:t>Claude Code</a:t>
             </a:r>
           </a:p>
         </p:txBody>
@@ -3420,7 +3420,16 @@
                 </a:solidFill>
                 <a:latin typeface="Calibri"/>
               </a:rPr>
-              <a:t>The desktop app. Sign in if it asks.</a:t>
+              <a:t>Install it and sign in. Check: </a:t>
+            </a:r>
+            <a:r>
+              <a:rPr sz="1300" b="1">
+                <a:solidFill>
+                  <a:srgbClr val="1C7293"/>
+                </a:solidFill>
+                <a:latin typeface="Consolas"/>
+              </a:rPr>
+              <a:t>claude --version</a:t>
             </a:r>
           </a:p>
           <a:p>
@@ -3430,49 +3439,13 @@
               </a:spcAft>
             </a:pPr>
             <a:r>
-              <a:rPr sz="1400">
+              <a:rPr sz="1100">
                 <a:solidFill>
                   <a:srgbClr val="5B6472"/>
                 </a:solidFill>
                 <a:latin typeface="Calibri"/>
               </a:rPr>
-              <a:t>Click </a:t>
-            </a:r>
-            <a:r>
-              <a:rPr sz="1400" b="1">
-                <a:solidFill>
-                  <a:srgbClr val="5B6472"/>
-                </a:solidFill>
-                <a:latin typeface="Calibri"/>
-              </a:rPr>
-              <a:t>New project</a:t>
-            </a:r>
-            <a:r>
-              <a:rPr sz="1400">
-                <a:solidFill>
-                  <a:srgbClr val="5B6472"/>
-                </a:solidFill>
-                <a:latin typeface="Calibri"/>
-              </a:rPr>
-              <a:t>, make a new empty folder, and name it </a:t>
-            </a:r>
-            <a:r>
-              <a:rPr sz="1300" b="1">
-                <a:solidFill>
-                  <a:srgbClr val="1C7293"/>
-                </a:solidFill>
-                <a:latin typeface="Consolas"/>
-              </a:rPr>
-              <a:t>northline</a:t>
-            </a:r>
-            <a:r>
-              <a:rPr sz="1400">
-                <a:solidFill>
-                  <a:srgbClr val="5B6472"/>
-                </a:solidFill>
-                <a:latin typeface="Calibri"/>
-              </a:rPr>
-              <a:t>.</a:t>
+              <a:t>The Code tab in the Claude desktop app, or claude in a terminal. Not New project.</a:t>
             </a:r>
           </a:p>
         </p:txBody>
@@ -3582,13 +3555,13 @@
           <a:lstStyle/>
           <a:p>
             <a:r>
-              <a:rPr sz="2000" b="1">
+              <a:rPr sz="1900" b="1">
                 <a:solidFill>
                   <a:srgbClr val="21295C"/>
                 </a:solidFill>
                 <a:latin typeface="Cambria"/>
               </a:rPr>
-              <a:t>Paste the line below</a:t>
+              <a:t>The folder</a:t>
             </a:r>
           </a:p>
         </p:txBody>
@@ -3627,7 +3600,25 @@
                 </a:solidFill>
                 <a:latin typeface="Calibri"/>
               </a:rPr>
-              <a:t>Claude downloads the course and unpacks it into your folder.</a:t>
+              <a:t>Open the link below, click </a:t>
+            </a:r>
+            <a:r>
+              <a:rPr sz="1400" b="1">
+                <a:solidFill>
+                  <a:srgbClr val="5B6472"/>
+                </a:solidFill>
+                <a:latin typeface="Calibri"/>
+              </a:rPr>
+              <a:t>Code → Download ZIP</a:t>
+            </a:r>
+            <a:r>
+              <a:rPr sz="1400">
+                <a:solidFill>
+                  <a:srgbClr val="5B6472"/>
+                </a:solidFill>
+                <a:latin typeface="Calibri"/>
+              </a:rPr>
+              <a:t>.</a:t>
             </a:r>
           </a:p>
           <a:p>
@@ -3643,7 +3634,7 @@
                 </a:solidFill>
                 <a:latin typeface="Calibri"/>
               </a:rPr>
-              <a:t>When it says it is done, close the project and open it again.</a:t>
+              <a:t>Unzip it into your home folder.</a:t>
             </a:r>
           </a:p>
         </p:txBody>
@@ -3753,7 +3744,7 @@
           <a:lstStyle/>
           <a:p>
             <a:r>
-              <a:rPr sz="2000" b="1">
+              <a:rPr sz="1900" b="1">
                 <a:solidFill>
                   <a:srgbClr val="21295C"/>
                 </a:solidFill>
@@ -3798,7 +3789,7 @@
                 </a:solidFill>
                 <a:latin typeface="Calibri"/>
               </a:rPr>
-              <a:t>Type </a:t>
+              <a:t>Open the folder in Code, or in a terminal: </a:t>
             </a:r>
             <a:r>
               <a:rPr sz="1300" b="1">
@@ -3807,16 +3798,7 @@
                 </a:solidFill>
                 <a:latin typeface="Consolas"/>
               </a:rPr>
-              <a:t>/northline-setup</a:t>
-            </a:r>
-            <a:r>
-              <a:rPr sz="1400">
-                <a:solidFill>
-                  <a:srgbClr val="5B6472"/>
-                </a:solidFill>
-                <a:latin typeface="Calibri"/>
-              </a:rPr>
-              <a:t>. Do what it says.</a:t>
+              <a:t>cd ~/northline-course</a:t>
             </a:r>
           </a:p>
           <a:p>
@@ -3832,7 +3814,50 @@
                 </a:solidFill>
                 <a:latin typeface="Calibri"/>
               </a:rPr>
-              <a:t>Stop when you see </a:t>
+              <a:t>then </a:t>
+            </a:r>
+            <a:r>
+              <a:rPr sz="1300" b="1">
+                <a:solidFill>
+                  <a:srgbClr val="1C7293"/>
+                </a:solidFill>
+                <a:latin typeface="Consolas"/>
+              </a:rPr>
+              <a:t>claude</a:t>
+            </a:r>
+            <a:r>
+              <a:rPr sz="1400">
+                <a:solidFill>
+                  <a:srgbClr val="5B6472"/>
+                </a:solidFill>
+                <a:latin typeface="Calibri"/>
+              </a:rPr>
+              <a:t>, then </a:t>
+            </a:r>
+            <a:r>
+              <a:rPr sz="1300" b="1">
+                <a:solidFill>
+                  <a:srgbClr val="1C7293"/>
+                </a:solidFill>
+                <a:latin typeface="Consolas"/>
+              </a:rPr>
+              <a:t>/northline-setup</a:t>
+            </a:r>
+          </a:p>
+          <a:p>
+            <a:pPr>
+              <a:spcAft>
+                <a:spcPts val="800"/>
+              </a:spcAft>
+            </a:pPr>
+            <a:r>
+              <a:rPr sz="1400">
+                <a:solidFill>
+                  <a:srgbClr val="5B6472"/>
+                </a:solidFill>
+                <a:latin typeface="Calibri"/>
+              </a:rPr>
+              <a:t>Do what it says. Stop at </a:t>
             </a:r>
             <a:r>
               <a:rPr sz="1300" b="1">
@@ -3864,7 +3889,7 @@
         <p:spPr>
           <a:xfrm>
             <a:off x="548640" y="4480560"/>
-            <a:ext cx="11094415" cy="1234440"/>
+            <a:ext cx="11094415" cy="1005840"/>
           </a:xfrm>
           <a:prstGeom prst="roundRect">
             <a:avLst>
@@ -3930,7 +3955,7 @@
                 </a:solidFill>
                 <a:latin typeface="Calibri"/>
               </a:rPr>
-              <a:t>Paste this into Claude Code (step 2)</a:t>
+              <a:t>The folder</a:t>
             </a:r>
           </a:p>
         </p:txBody>
@@ -3943,8 +3968,8 @@
         </p:nvSpPr>
         <p:spPr>
           <a:xfrm>
-            <a:off x="868680" y="4901184"/>
-            <a:ext cx="10454320" cy="822960"/>
+            <a:off x="868680" y="4882896"/>
+            <a:ext cx="10454320" cy="457200"/>
           </a:xfrm>
           <a:prstGeom prst="rect">
             <a:avLst/>
@@ -3958,13 +3983,13 @@
           <a:lstStyle/>
           <a:p>
             <a:r>
-              <a:rPr sz="1600" b="1">
+              <a:rPr sz="2200" b="1">
                 <a:solidFill>
                   <a:srgbClr val="FFFFFF"/>
                 </a:solidFill>
                 <a:latin typeface="Consolas"/>
               </a:rPr>
-              <a:t>Download github.com/anthonymorrisjohnson/northline-course as a ZIP, unzip it so the files sit directly in this folder, then delete the zip.</a:t>
+              <a:t>github.com/anthonymorrisjohnson/northline-course</a:t>
             </a:r>
           </a:p>
         </p:txBody>

</xml_diff>

<commit_message>
Setup instructions lead with the Code tab, not a terminal
Slide 1, README, session plan and the northline-setup skill now describe
the Claude desktop app's Code tab as the way in (a terminal still works
but is no longer presented as an equal option). Also fixes two command
names the rename missed on slides 6 and 15, and a stale slide reference
in slide 14's notes.

Co-Authored-By: Claude Fable 5.1 <noreply@anthropic.com>
Claude-Session: https://claude.ai/code/session_01Jo9JuGz9sGjCWMSFMqHMPx
</commit_message>
<xml_diff>
--- a/slides/deck.pptx
+++ b/slides/deck.pptx
@@ -2043,7 +2043,7 @@
           <a:p>
             <a:r>
               <a:rPr lang="en-US" dirty="0"/>
-              <a:t>hold this one line. It is the reason the four decisions on slide 5 have no universal right answer — only a market that is or isn't willing to accept them.</a:t>
+              <a:t>hold this one line. It is the reason the four decisions on slide 6 have no universal right answer — only a market that is or isn't willing to accept them.</a:t>
             </a:r>
             <a:endParaRPr lang="en-US" dirty="0"/>
           </a:p>
@@ -3381,7 +3381,7 @@
                 </a:solidFill>
                 <a:latin typeface="Cambria"/>
               </a:rPr>
-              <a:t>Claude Code</a:t>
+              <a:t>The Claude app</a:t>
             </a:r>
           </a:p>
         </p:txBody>
@@ -3420,16 +3420,7 @@
                 </a:solidFill>
                 <a:latin typeface="Calibri"/>
               </a:rPr>
-              <a:t>Install it and sign in. Check: </a:t>
-            </a:r>
-            <a:r>
-              <a:rPr sz="1300" b="1">
-                <a:solidFill>
-                  <a:srgbClr val="1C7293"/>
-                </a:solidFill>
-                <a:latin typeface="Consolas"/>
-              </a:rPr>
-              <a:t>claude --version</a:t>
+              <a:t>Install the Claude desktop app and sign in.</a:t>
             </a:r>
           </a:p>
           <a:p>
@@ -3439,13 +3430,31 @@
               </a:spcAft>
             </a:pPr>
             <a:r>
-              <a:rPr sz="1100">
+              <a:rPr sz="1400">
                 <a:solidFill>
                   <a:srgbClr val="5B6472"/>
                 </a:solidFill>
                 <a:latin typeface="Calibri"/>
               </a:rPr>
-              <a:t>The Code tab in the Claude desktop app, or claude in a terminal. Not New project.</a:t>
+              <a:t>Open the </a:t>
+            </a:r>
+            <a:r>
+              <a:rPr sz="1300" b="1">
+                <a:solidFill>
+                  <a:srgbClr val="5B6472"/>
+                </a:solidFill>
+                <a:latin typeface="Consolas"/>
+              </a:rPr>
+              <a:t>Code</a:t>
+            </a:r>
+            <a:r>
+              <a:rPr sz="1400">
+                <a:solidFill>
+                  <a:srgbClr val="5B6472"/>
+                </a:solidFill>
+                <a:latin typeface="Calibri"/>
+              </a:rPr>
+              <a:t> tab. Not New project.</a:t>
             </a:r>
           </a:p>
         </p:txBody>
@@ -3789,16 +3798,25 @@
                 </a:solidFill>
                 <a:latin typeface="Calibri"/>
               </a:rPr>
-              <a:t>Open the folder in Code, or in a terminal: </a:t>
+              <a:t>In the Code tab, open the </a:t>
             </a:r>
             <a:r>
               <a:rPr sz="1300" b="1">
                 <a:solidFill>
-                  <a:srgbClr val="1C7293"/>
+                  <a:srgbClr val="5B6472"/>
                 </a:solidFill>
                 <a:latin typeface="Consolas"/>
               </a:rPr>
-              <a:t>cd ~/northline-course</a:t>
+              <a:t>northline-course</a:t>
+            </a:r>
+            <a:r>
+              <a:rPr sz="1400">
+                <a:solidFill>
+                  <a:srgbClr val="5B6472"/>
+                </a:solidFill>
+                <a:latin typeface="Calibri"/>
+              </a:rPr>
+              <a:t> folder.</a:t>
             </a:r>
           </a:p>
           <a:p>
@@ -3814,16 +3832,16 @@
                 </a:solidFill>
                 <a:latin typeface="Calibri"/>
               </a:rPr>
-              <a:t>then </a:t>
+              <a:t>Type </a:t>
             </a:r>
             <a:r>
               <a:rPr sz="1300" b="1">
                 <a:solidFill>
-                  <a:srgbClr val="1C7293"/>
+                  <a:srgbClr val="5B6472"/>
                 </a:solidFill>
                 <a:latin typeface="Consolas"/>
               </a:rPr>
-              <a:t>claude</a:t>
+              <a:t>/northline-setup</a:t>
             </a:r>
             <a:r>
               <a:rPr sz="1400">
@@ -3832,16 +3850,7 @@
                 </a:solidFill>
                 <a:latin typeface="Calibri"/>
               </a:rPr>
-              <a:t>, then </a:t>
-            </a:r>
-            <a:r>
-              <a:rPr sz="1300" b="1">
-                <a:solidFill>
-                  <a:srgbClr val="1C7293"/>
-                </a:solidFill>
-                <a:latin typeface="Consolas"/>
-              </a:rPr>
-              <a:t>/northline-setup</a:t>
+              <a:t> in the chat.</a:t>
             </a:r>
           </a:p>
           <a:p>
@@ -3862,7 +3871,7 @@
             <a:r>
               <a:rPr sz="1300" b="1">
                 <a:solidFill>
-                  <a:srgbClr val="1C7293"/>
+                  <a:srgbClr val="5B6472"/>
                 </a:solidFill>
                 <a:latin typeface="Consolas"/>
               </a:rPr>
@@ -8637,7 +8646,7 @@
                 <a:ea typeface="Cambria" pitchFamily="34" charset="-122"/>
                 <a:cs typeface="Cambria" pitchFamily="34" charset="-120"/>
               </a:rPr>
-              <a:t>/setup</a:t>
+              <a:t>/northline-setup</a:t>
             </a:r>
             <a:endParaRPr lang="en-US" sz="1500" dirty="0"/>
           </a:p>
@@ -12440,7 +12449,7 @@
                 <a:ea typeface="Calibri" pitchFamily="34" charset="-122"/>
                 <a:cs typeface="Calibri" pitchFamily="34" charset="-120"/>
               </a:rPr>
-              <a:t>/DEPLOY TRIAGE</a:t>
+              <a:t>/NORTHLINE-DEPLOY TRIAGE</a:t>
             </a:r>
             <a:endParaRPr lang="en-US" sz="1200" dirty="0"/>
           </a:p>

</xml_diff>